<commit_message>
Expand Applied AI with visual workflow and creative project cases
</commit_message>
<xml_diff>
--- a/downloads/ai/kyle-hobson-ai-deck.pptx
+++ b/downloads/ai/kyle-hobson-ai-deck.pptx
@@ -2,23 +2,26 @@
 <file path=ppt/presentation.xml><?xml version="1.0" encoding="utf-8"?>
 <p:presentation xmlns:p="http://schemas.openxmlformats.org/presentationml/2006/main">
   <p:sldMasterIdLst>
-    <p:sldMasterId xmlns:r="http://schemas.openxmlformats.org/officeDocument/2006/relationships" id="2147483648" r:id="Rda529569b9e34b12"/>
+    <p:sldMasterId xmlns:r="http://schemas.openxmlformats.org/officeDocument/2006/relationships" id="2147483648" r:id="Rd751833ee9f74d62"/>
   </p:sldMasterIdLst>
   <p:notesMasterIdLst>
-    <p:notesMasterId xmlns:r="http://schemas.openxmlformats.org/officeDocument/2006/relationships" r:id="R50fd29ee5ab84f10"/>
+    <p:notesMasterId xmlns:r="http://schemas.openxmlformats.org/officeDocument/2006/relationships" r:id="R895d3a2b19d743fb"/>
   </p:notesMasterIdLst>
   <p:sldIdLst>
-    <p:sldId xmlns:r="http://schemas.openxmlformats.org/officeDocument/2006/relationships" id="256" r:id="Reaa0ba7922bf4e27"/>
-    <p:sldId xmlns:r="http://schemas.openxmlformats.org/officeDocument/2006/relationships" id="257" r:id="R6e2fe5131c8a4cb0"/>
-    <p:sldId xmlns:r="http://schemas.openxmlformats.org/officeDocument/2006/relationships" id="258" r:id="R078889a060e14430"/>
-    <p:sldId xmlns:r="http://schemas.openxmlformats.org/officeDocument/2006/relationships" id="259" r:id="R01cb443a87154e58"/>
-    <p:sldId xmlns:r="http://schemas.openxmlformats.org/officeDocument/2006/relationships" id="260" r:id="R101a440a8d3c4134"/>
-    <p:sldId xmlns:r="http://schemas.openxmlformats.org/officeDocument/2006/relationships" id="261" r:id="R01cbdee59e2540d5"/>
-    <p:sldId xmlns:r="http://schemas.openxmlformats.org/officeDocument/2006/relationships" id="262" r:id="Rd0b3d5187de74ecf"/>
-    <p:sldId xmlns:r="http://schemas.openxmlformats.org/officeDocument/2006/relationships" id="263" r:id="R0ce6f8a2a54d4467"/>
-    <p:sldId xmlns:r="http://schemas.openxmlformats.org/officeDocument/2006/relationships" id="264" r:id="R150c6e6f36a74dbc"/>
-    <p:sldId xmlns:r="http://schemas.openxmlformats.org/officeDocument/2006/relationships" id="265" r:id="R2543c271e9694f94"/>
-    <p:sldId xmlns:r="http://schemas.openxmlformats.org/officeDocument/2006/relationships" id="266" r:id="R9ba87ae128d24b02"/>
+    <p:sldId xmlns:r="http://schemas.openxmlformats.org/officeDocument/2006/relationships" id="256" r:id="R9f5ace3fb182454e"/>
+    <p:sldId xmlns:r="http://schemas.openxmlformats.org/officeDocument/2006/relationships" id="257" r:id="Re6e264488ef84974"/>
+    <p:sldId xmlns:r="http://schemas.openxmlformats.org/officeDocument/2006/relationships" id="258" r:id="Rcb1d1a3661fe47a5"/>
+    <p:sldId xmlns:r="http://schemas.openxmlformats.org/officeDocument/2006/relationships" id="259" r:id="Rb016987a26ff4954"/>
+    <p:sldId xmlns:r="http://schemas.openxmlformats.org/officeDocument/2006/relationships" id="260" r:id="R06a8fcb0138946f1"/>
+    <p:sldId xmlns:r="http://schemas.openxmlformats.org/officeDocument/2006/relationships" id="261" r:id="R1f49bb5d2c564a10"/>
+    <p:sldId xmlns:r="http://schemas.openxmlformats.org/officeDocument/2006/relationships" id="262" r:id="R8b6a1c5e2deb47a4"/>
+    <p:sldId xmlns:r="http://schemas.openxmlformats.org/officeDocument/2006/relationships" id="263" r:id="Ra1f9851c134d4a26"/>
+    <p:sldId xmlns:r="http://schemas.openxmlformats.org/officeDocument/2006/relationships" id="264" r:id="R97b6a51075524bbc"/>
+    <p:sldId xmlns:r="http://schemas.openxmlformats.org/officeDocument/2006/relationships" id="265" r:id="R99464550dc7346a6"/>
+    <p:sldId xmlns:r="http://schemas.openxmlformats.org/officeDocument/2006/relationships" id="266" r:id="Rd9034d9f88494c3f"/>
+    <p:sldId xmlns:r="http://schemas.openxmlformats.org/officeDocument/2006/relationships" id="267" r:id="R9b64abd5ac7a403c"/>
+    <p:sldId xmlns:r="http://schemas.openxmlformats.org/officeDocument/2006/relationships" id="268" r:id="R3ea5c35b95154a41"/>
+    <p:sldId xmlns:r="http://schemas.openxmlformats.org/officeDocument/2006/relationships" id="269" r:id="Rd3b34bab93fe4a0c"/>
   </p:sldIdLst>
   <p:sldSz cx="12192000" cy="6858000"/>
   <p:notesSz cx="6858000" cy="9144000"/>
@@ -522,7 +525,7 @@
           <a:lstStyle xmlns:a="http://schemas.openxmlformats.org/drawingml/2006/main"/>
           <a:p xmlns:a="http://schemas.openxmlformats.org/drawingml/2006/main">
             <a:r>
-              <a:t>This editorial connection draws on Kyle’s self-described documentary filmmaking background, reviewed learning-design roles and published AI instruction. It frames his applied-AI approach without claiming production machine-learning engineering or measured client ROI. The portrait is a user-supplied personal image.</a:t>
+              <a:t>Sources: original collaborative ASU for Life prompt-architecture document, which explicitly identifies Kyle’s proposal, and the original 2024 Figma flowchart. Formal role: AI Analyst, ASU Learning Innovations, February–October 2024. The simplified reconstruction retains context summarization, mentor review, task generation/refinement and output confirmation. It does not reproduce legacy speculative components from the collaborative artifact or claim model training, fine-tuning, deployment or measured time savings. This supporting case demonstrates workflow-design judgment. A next validation would test the mentor checkpoints with realistic learner contexts before piloting the flow.</a:t>
             </a:r>
           </a:p>
         </p:txBody>
@@ -592,6 +595,216 @@
           <a:lstStyle xmlns:a="http://schemas.openxmlformats.org/drawingml/2006/main"/>
           <a:p xmlns:a="http://schemas.openxmlformats.org/drawingml/2006/main">
             <a:r>
+              <a:t>Source image: public/assets/ai-lumina-river.png, a local Lumina3D screenshot showing the playable river candidate and timed bridge objective. Source workflow: Lumina3D docs/ai-prompt-workflow/README.md. A human captures selected-object, transform, collision and visual context; AI diagnoses and proposes a minimal source patch; the developer verifies with build, scene checks and play. Case page: https://jonathankhobson.github.io/portfolio/ai/case/lumina/ . The screenshot is gameplay evidence, not proof of an autonomous game-playing agent. The current local candidate is separate from the older public repository. No public release, success-rate or model capability result is claimed.</a:t>
+            </a:r>
+          </a:p>
+        </p:txBody>
+      </p:sp>
+      <p:sp>
+        <p:nvSpPr>
+          <p:cNvPr id="4" name="Slide Number Placeholder 3"/>
+          <p:cNvSpPr>
+            <a:spLocks xmlns:a="http://schemas.openxmlformats.org/drawingml/2006/main" noGrp="1"/>
+          </p:cNvSpPr>
+          <p:nvPr>
+            <p:ph type="sldNum" idx="5"/>
+          </p:nvPr>
+        </p:nvSpPr>
+        <p:spPr/>
+        <p:txBody>
+          <a:bodyPr xmlns:a="http://schemas.openxmlformats.org/drawingml/2006/main"/>
+          <a:lstStyle xmlns:a="http://schemas.openxmlformats.org/drawingml/2006/main"/>
+          <a:p xmlns:a="http://schemas.openxmlformats.org/drawingml/2006/main"/>
+        </p:txBody>
+      </p:sp>
+    </p:spTree>
+  </p:cSld>
+  <p:clrMapOvr>
+    <a:masterClrMapping xmlns:a="http://schemas.openxmlformats.org/drawingml/2006/main"/>
+  </p:clrMapOvr>
+</p:notes>
+</file>
+
+<file path=ppt/notesSlides/notesSlide12.xml><?xml version="1.0" encoding="utf-8"?>
+<p:notes xmlns:p="http://schemas.openxmlformats.org/presentationml/2006/main">
+  <p:cSld>
+    <p:spTree>
+      <p:nvGrpSpPr>
+        <p:cNvPr id="1" name=""/>
+        <p:cNvGrpSpPr/>
+        <p:nvPr/>
+      </p:nvGrpSpPr>
+      <p:grpSpPr>
+        <a:xfrm xmlns:a="http://schemas.openxmlformats.org/drawingml/2006/main"/>
+      </p:grpSpPr>
+      <p:sp>
+        <p:nvSpPr>
+          <p:cNvPr id="2" name="Slide Image Placeholder 1"/>
+          <p:cNvSpPr>
+            <a:spLocks xmlns:a="http://schemas.openxmlformats.org/drawingml/2006/main" noGrp="1"/>
+          </p:cNvSpPr>
+          <p:nvPr>
+            <p:ph type="sldImg" idx="0"/>
+          </p:nvPr>
+        </p:nvSpPr>
+        <p:spPr/>
+      </p:sp>
+      <p:sp>
+        <p:nvSpPr>
+          <p:cNvPr id="3" name="Notes Placeholder 2"/>
+          <p:cNvSpPr>
+            <a:spLocks xmlns:a="http://schemas.openxmlformats.org/drawingml/2006/main" noGrp="1"/>
+          </p:cNvSpPr>
+          <p:nvPr>
+            <p:ph type="body" idx="1"/>
+          </p:nvPr>
+        </p:nvSpPr>
+        <p:spPr/>
+        <p:txBody>
+          <a:bodyPr xmlns:a="http://schemas.openxmlformats.org/drawingml/2006/main"/>
+          <a:lstStyle xmlns:a="http://schemas.openxmlformats.org/drawingml/2006/main"/>
+          <a:p xmlns:a="http://schemas.openxmlformats.org/drawingml/2006/main">
+            <a:r>
+              <a:t>Source image: case-library/ai-assisted-web-evolution/site/assets/portfolio-2026-09.png, an original screenshot of Kyle’s earlier public portfolio presentation. Public Applied AI destination: https://jonathankhobson.github.io/portfolio/ai/ . Case page: https://jonathankhobson.github.io/portfolio/ai/case/making-the-portfolio/ . The workflow is evidence selection, AI-assisted drafting and integration into the public site with human claim review. This image predates the current visual case refinements; it is not a screenshot of an autonomous publishing system or a measured conversion result.</a:t>
+            </a:r>
+          </a:p>
+        </p:txBody>
+      </p:sp>
+      <p:sp>
+        <p:nvSpPr>
+          <p:cNvPr id="4" name="Slide Number Placeholder 3"/>
+          <p:cNvSpPr>
+            <a:spLocks xmlns:a="http://schemas.openxmlformats.org/drawingml/2006/main" noGrp="1"/>
+          </p:cNvSpPr>
+          <p:nvPr>
+            <p:ph type="sldNum" idx="5"/>
+          </p:nvPr>
+        </p:nvSpPr>
+        <p:spPr/>
+        <p:txBody>
+          <a:bodyPr xmlns:a="http://schemas.openxmlformats.org/drawingml/2006/main"/>
+          <a:lstStyle xmlns:a="http://schemas.openxmlformats.org/drawingml/2006/main"/>
+          <a:p xmlns:a="http://schemas.openxmlformats.org/drawingml/2006/main"/>
+        </p:txBody>
+      </p:sp>
+    </p:spTree>
+  </p:cSld>
+  <p:clrMapOvr>
+    <a:masterClrMapping xmlns:a="http://schemas.openxmlformats.org/drawingml/2006/main"/>
+  </p:clrMapOvr>
+</p:notes>
+</file>
+
+<file path=ppt/notesSlides/notesSlide13.xml><?xml version="1.0" encoding="utf-8"?>
+<p:notes xmlns:p="http://schemas.openxmlformats.org/presentationml/2006/main">
+  <p:cSld>
+    <p:spTree>
+      <p:nvGrpSpPr>
+        <p:cNvPr id="1" name=""/>
+        <p:cNvGrpSpPr/>
+        <p:nvPr/>
+      </p:nvGrpSpPr>
+      <p:grpSpPr>
+        <a:xfrm xmlns:a="http://schemas.openxmlformats.org/drawingml/2006/main"/>
+      </p:grpSpPr>
+      <p:sp>
+        <p:nvSpPr>
+          <p:cNvPr id="2" name="Slide Image Placeholder 1"/>
+          <p:cNvSpPr>
+            <a:spLocks xmlns:a="http://schemas.openxmlformats.org/drawingml/2006/main" noGrp="1"/>
+          </p:cNvSpPr>
+          <p:nvPr>
+            <p:ph type="sldImg" idx="0"/>
+          </p:nvPr>
+        </p:nvSpPr>
+        <p:spPr/>
+      </p:sp>
+      <p:sp>
+        <p:nvSpPr>
+          <p:cNvPr id="3" name="Notes Placeholder 2"/>
+          <p:cNvSpPr>
+            <a:spLocks xmlns:a="http://schemas.openxmlformats.org/drawingml/2006/main" noGrp="1"/>
+          </p:cNvSpPr>
+          <p:nvPr>
+            <p:ph type="body" idx="1"/>
+          </p:nvPr>
+        </p:nvSpPr>
+        <p:spPr/>
+        <p:txBody>
+          <a:bodyPr xmlns:a="http://schemas.openxmlformats.org/drawingml/2006/main"/>
+          <a:lstStyle xmlns:a="http://schemas.openxmlformats.org/drawingml/2006/main"/>
+          <a:p xmlns:a="http://schemas.openxmlformats.org/drawingml/2006/main">
+            <a:r>
+              <a:t>This editorial connection draws on Kyle’s self-described documentary filmmaking background, reviewed learning-design roles and published AI instruction. It frames his applied-AI approach without claiming production machine-learning engineering or measured client ROI. The portrait is a user-supplied personal image.</a:t>
+            </a:r>
+          </a:p>
+        </p:txBody>
+      </p:sp>
+      <p:sp>
+        <p:nvSpPr>
+          <p:cNvPr id="4" name="Slide Number Placeholder 3"/>
+          <p:cNvSpPr>
+            <a:spLocks xmlns:a="http://schemas.openxmlformats.org/drawingml/2006/main" noGrp="1"/>
+          </p:cNvSpPr>
+          <p:nvPr>
+            <p:ph type="sldNum" idx="5"/>
+          </p:nvPr>
+        </p:nvSpPr>
+        <p:spPr/>
+        <p:txBody>
+          <a:bodyPr xmlns:a="http://schemas.openxmlformats.org/drawingml/2006/main"/>
+          <a:lstStyle xmlns:a="http://schemas.openxmlformats.org/drawingml/2006/main"/>
+          <a:p xmlns:a="http://schemas.openxmlformats.org/drawingml/2006/main"/>
+        </p:txBody>
+      </p:sp>
+    </p:spTree>
+  </p:cSld>
+  <p:clrMapOvr>
+    <a:masterClrMapping xmlns:a="http://schemas.openxmlformats.org/drawingml/2006/main"/>
+  </p:clrMapOvr>
+</p:notes>
+</file>
+
+<file path=ppt/notesSlides/notesSlide14.xml><?xml version="1.0" encoding="utf-8"?>
+<p:notes xmlns:p="http://schemas.openxmlformats.org/presentationml/2006/main">
+  <p:cSld>
+    <p:spTree>
+      <p:nvGrpSpPr>
+        <p:cNvPr id="1" name=""/>
+        <p:cNvGrpSpPr/>
+        <p:nvPr/>
+      </p:nvGrpSpPr>
+      <p:grpSpPr>
+        <a:xfrm xmlns:a="http://schemas.openxmlformats.org/drawingml/2006/main"/>
+      </p:grpSpPr>
+      <p:sp>
+        <p:nvSpPr>
+          <p:cNvPr id="2" name="Slide Image Placeholder 1"/>
+          <p:cNvSpPr>
+            <a:spLocks xmlns:a="http://schemas.openxmlformats.org/drawingml/2006/main" noGrp="1"/>
+          </p:cNvSpPr>
+          <p:nvPr>
+            <p:ph type="sldImg" idx="0"/>
+          </p:nvPr>
+        </p:nvSpPr>
+        <p:spPr/>
+      </p:sp>
+      <p:sp>
+        <p:nvSpPr>
+          <p:cNvPr id="3" name="Notes Placeholder 2"/>
+          <p:cNvSpPr>
+            <a:spLocks xmlns:a="http://schemas.openxmlformats.org/drawingml/2006/main" noGrp="1"/>
+          </p:cNvSpPr>
+          <p:nvPr>
+            <p:ph type="body" idx="1"/>
+          </p:nvPr>
+        </p:nvSpPr>
+        <p:spPr/>
+        <p:txBody>
+          <a:bodyPr xmlns:a="http://schemas.openxmlformats.org/drawingml/2006/main"/>
+          <a:lstStyle xmlns:a="http://schemas.openxmlformats.org/drawingml/2006/main"/>
+          <a:p xmlns:a="http://schemas.openxmlformats.org/drawingml/2006/main">
+            <a:r>
               <a:t>For applied AI workflow consulting, prompt engineering, business analysis and enablement. The intended portfolio destination is configured as a hyperlink.</a:t>
             </a:r>
           </a:p>
@@ -1152,7 +1365,7 @@
           <a:lstStyle xmlns:a="http://schemas.openxmlformats.org/drawingml/2006/main"/>
           <a:p xmlns:a="http://schemas.openxmlformats.org/drawingml/2006/main">
             <a:r>
-              <a:t>Sources: original collaborative ASU for Life prompt-architecture document, which explicitly identifies Kyle’s proposal, and the original 2024 Figma flowchart. Formal role: AI Analyst, ASU Learning Innovations, February–October 2024. The simplified reconstruction retains context summarization, mentor review, task generation/refinement and output confirmation. It does not reproduce legacy speculative components from the collaborative artifact or claim model training, fine-tuning, deployment or measured time savings. This supporting case demonstrates workflow-design judgment. A next validation would test the mentor checkpoints with realistic learner contexts before piloting the flow.</a:t>
+              <a:t>Source image: public/assets/ai-studio-learner.png, copied from the approved learner-design capture in the AI Workshop Studio integration source. It shows the older published six-lesson learner view, not the unfinished Intro to ChatGPT Desktop course. The application is public at https://ai-workshop-studio.jkylehobson.chatgpt.site/ . The shared four-tab video workspace was published in application v37 on September 26, 2026; hosted playback and transcript seeking were checked. Source: integration/docs/pm/workstreams/lesson-workspace-september26.md. Case page: https://jonathankhobson.github.io/portfolio/ai/case/workshop-studio/ . The current Intro to ChatGPT Desktop course remains a private draft at revision 176; app publication did not publish that course. No learning-gain claim is made.</a:t>
             </a:r>
           </a:p>
         </p:txBody>
@@ -1220,7 +1433,7 @@
   </p:cSld>
   <p:clrMap bg1="lt1" tx1="dk1" bg2="lt2" tx2="dk2" accent1="accent1" accent2="accent2" accent3="accent3" accent4="accent4" accent5="accent5" accent6="accent6" hlink="hlink" folHlink="folHlink"/>
   <p:sldLayoutIdLst>
-    <p:sldLayoutId xmlns:r="http://schemas.openxmlformats.org/officeDocument/2006/relationships" id="2147483649" r:id="R60beb0d4cac64816"/>
+    <p:sldLayoutId xmlns:r="http://schemas.openxmlformats.org/officeDocument/2006/relationships" id="2147483649" r:id="R033c7b51478f48bd"/>
   </p:sldLayoutIdLst>
   <p:txStyles>
     <p:titleStyle>
@@ -1771,7 +1984,7 @@
           <p:cNvPr id="7" name="section-label">
             <a:extLst xmlns:a="http://schemas.openxmlformats.org/drawingml/2006/main">
               <a:ext uri="{FF2B5EF4-FFF2-40B4-BE49-F238E27FC236}">
-                <a16:creationId xmlns:a16="http://schemas.microsoft.com/office/drawing/2014/main" id="{8941AD11-4D00-419F-A03E-532A5A1F0775}"/>
+                <a16:creationId xmlns:a16="http://schemas.microsoft.com/office/drawing/2014/main" id="{0168E38D-8DF3-4C7D-9EF5-D420C5005A52}"/>
               </a:ext>
             </a:extLst>
           </p:cNvPr>
@@ -1832,7 +2045,7 @@
           <p:cNvPr id="2" name="headline">
             <a:extLst xmlns:a="http://schemas.openxmlformats.org/drawingml/2006/main">
               <a:ext uri="{FF2B5EF4-FFF2-40B4-BE49-F238E27FC236}">
-                <a16:creationId xmlns:a16="http://schemas.microsoft.com/office/drawing/2014/main" id="{384D8161-2C0D-4B26-8157-AA53A9D20F75}"/>
+                <a16:creationId xmlns:a16="http://schemas.microsoft.com/office/drawing/2014/main" id="{7B0E7B8C-9D4F-4946-847D-90E3C6109A65}"/>
               </a:ext>
             </a:extLst>
           </p:cNvPr>
@@ -1924,7 +2137,7 @@
           <p:nvPr/>
         </p:nvPicPr>
         <p:blipFill>
-          <a:blip xmlns:r="http://schemas.openxmlformats.org/officeDocument/2006/relationships" xmlns:a="http://schemas.openxmlformats.org/drawingml/2006/main" r:embed="Rd10f5bb62b3c4811"/>
+          <a:blip xmlns:r="http://schemas.openxmlformats.org/officeDocument/2006/relationships" xmlns:a="http://schemas.openxmlformats.org/drawingml/2006/main" r:embed="Re92fea9c4103427b"/>
           <a:stretch xmlns:a="http://schemas.openxmlformats.org/drawingml/2006/main"/>
         </p:blipFill>
         <p:spPr>
@@ -1942,7 +2155,7 @@
           <p:cNvPr id="4" name="cover-intro">
             <a:extLst xmlns:a="http://schemas.openxmlformats.org/drawingml/2006/main">
               <a:ext uri="{FF2B5EF4-FFF2-40B4-BE49-F238E27FC236}">
-                <a16:creationId xmlns:a16="http://schemas.microsoft.com/office/drawing/2014/main" id="{25C930DB-5DAF-439E-BB08-DCD96A6CCFCD}"/>
+                <a16:creationId xmlns:a16="http://schemas.microsoft.com/office/drawing/2014/main" id="{C9CB9851-322B-4B4E-9F01-7E8B1D75E58F}"/>
               </a:ext>
             </a:extLst>
           </p:cNvPr>
@@ -2057,7 +2270,7 @@
           <p:cNvPr id="5" name="cover-role">
             <a:extLst xmlns:a="http://schemas.openxmlformats.org/drawingml/2006/main">
               <a:ext uri="{FF2B5EF4-FFF2-40B4-BE49-F238E27FC236}">
-                <a16:creationId xmlns:a16="http://schemas.microsoft.com/office/drawing/2014/main" id="{6CA9CE26-6A26-4821-A6E4-FE682F94E0F7}"/>
+                <a16:creationId xmlns:a16="http://schemas.microsoft.com/office/drawing/2014/main" id="{09387CE2-4E41-4E93-A858-2990F14651D1}"/>
               </a:ext>
             </a:extLst>
           </p:cNvPr>
@@ -2145,7 +2358,7 @@
           <p:cNvPr id="6" name="slide-number">
             <a:extLst xmlns:a="http://schemas.openxmlformats.org/drawingml/2006/main">
               <a:ext uri="{FF2B5EF4-FFF2-40B4-BE49-F238E27FC236}">
-                <a16:creationId xmlns:a16="http://schemas.microsoft.com/office/drawing/2014/main" id="{26E96E52-B55E-4668-9BD7-C66496BA02D0}"/>
+                <a16:creationId xmlns:a16="http://schemas.microsoft.com/office/drawing/2014/main" id="{E1050CCA-2947-41E9-9FA1-84553A1A1E65}"/>
               </a:ext>
             </a:extLst>
           </p:cNvPr>
@@ -2204,7 +2417,7 @@
     </p:spTree>
     <p:extLst>
       <p:ext uri="{BB962C8B-B14F-4D97-AF65-F5344CB8AC3E}">
-        <p14:creationId xmlns:p14="http://schemas.microsoft.com/office/powerpoint/2010/main" val="1983171969"/>
+        <p14:creationId xmlns:p14="http://schemas.microsoft.com/office/powerpoint/2010/main" val="274552175"/>
       </p:ext>
     </p:extLst>
   </p:cSld>
@@ -2235,19 +2448,19 @@
           <p:cNvPr id="7" name="section-label">
             <a:extLst xmlns:a="http://schemas.openxmlformats.org/drawingml/2006/main">
               <a:ext uri="{FF2B5EF4-FFF2-40B4-BE49-F238E27FC236}">
-                <a16:creationId xmlns:a16="http://schemas.microsoft.com/office/drawing/2014/main" id="{DF2D0410-0E18-4470-B360-0979C0857950}"/>
-              </a:ext>
-            </a:extLst>
-          </p:cNvPr>
-          <p:cNvSpPr>
-            <a:spLocks xmlns:a="http://schemas.openxmlformats.org/drawingml/2006/main" noGrp="1"/>
-          </p:cNvSpPr>
-          <p:nvPr/>
-        </p:nvSpPr>
-        <p:spPr>
-          <a:xfrm xmlns:a="http://schemas.openxmlformats.org/drawingml/2006/main">
-            <a:off x="609600" y="514350"/>
-            <a:ext cx="6477000" cy="266700"/>
+                <a16:creationId xmlns:a16="http://schemas.microsoft.com/office/drawing/2014/main" id="{CF1B556B-5902-4D3D-879B-A77948FC1DE6}"/>
+              </a:ext>
+            </a:extLst>
+          </p:cNvPr>
+          <p:cNvSpPr>
+            <a:spLocks xmlns:a="http://schemas.openxmlformats.org/drawingml/2006/main" noGrp="1"/>
+          </p:cNvSpPr>
+          <p:nvPr/>
+        </p:nvSpPr>
+        <p:spPr>
+          <a:xfrm xmlns:a="http://schemas.openxmlformats.org/drawingml/2006/main">
+            <a:off x="609600" y="495300"/>
+            <a:ext cx="10668000" cy="266700"/>
           </a:xfrm>
           <a:prstGeom xmlns:a="http://schemas.openxmlformats.org/drawingml/2006/main" prst="rect">
             <a:avLst/>
@@ -2286,7 +2499,7 @@
                 <a:ea typeface="Helvetica Neue"/>
                 <a:cs typeface="Helvetica Neue"/>
               </a:rPr>
-              <a:t>THE THREAD THROUGH MY WORK</a:t>
+              <a:t>ASU LEARNING INNOVATIONS   /   AI ANALYST, FEB–OCT 2024</a:t>
             </a:r>
           </a:p>
         </p:txBody>
@@ -2296,19 +2509,19 @@
           <p:cNvPr id="2" name="headline">
             <a:extLst xmlns:a="http://schemas.openxmlformats.org/drawingml/2006/main">
               <a:ext uri="{FF2B5EF4-FFF2-40B4-BE49-F238E27FC236}">
-                <a16:creationId xmlns:a16="http://schemas.microsoft.com/office/drawing/2014/main" id="{B2F9A2E2-B222-466C-921A-1469A9EC0D00}"/>
-              </a:ext>
-            </a:extLst>
-          </p:cNvPr>
-          <p:cNvSpPr>
-            <a:spLocks xmlns:a="http://schemas.openxmlformats.org/drawingml/2006/main" noGrp="1"/>
-          </p:cNvSpPr>
-          <p:nvPr/>
-        </p:nvSpPr>
-        <p:spPr>
-          <a:xfrm xmlns:a="http://schemas.openxmlformats.org/drawingml/2006/main">
-            <a:off x="609600" y="1352550"/>
-            <a:ext cx="5905500" cy="1485900"/>
+                <a16:creationId xmlns:a16="http://schemas.microsoft.com/office/drawing/2014/main" id="{4BF4AB73-6A8F-4C3B-85FD-ABD2119245E9}"/>
+              </a:ext>
+            </a:extLst>
+          </p:cNvPr>
+          <p:cNvSpPr>
+            <a:spLocks xmlns:a="http://schemas.openxmlformats.org/drawingml/2006/main" noGrp="1"/>
+          </p:cNvSpPr>
+          <p:nvPr/>
+        </p:nvSpPr>
+        <p:spPr>
+          <a:xfrm xmlns:a="http://schemas.openxmlformats.org/drawingml/2006/main">
+            <a:off x="609600" y="1095375"/>
+            <a:ext cx="6810375" cy="1466850"/>
           </a:xfrm>
           <a:prstGeom xmlns:a="http://schemas.openxmlformats.org/drawingml/2006/main" prst="rect">
             <a:avLst/>
@@ -2347,7 +2560,7 @@
                 <a:ea typeface="Helvetica Neue"/>
                 <a:cs typeface="Helvetica Neue"/>
               </a:rPr>
-              <a:t>The person using</a:t>
+              <a:t>Mentor review shaped</a:t>
             </a:r>
           </a:p>
           <a:p xmlns:a="http://schemas.openxmlformats.org/drawingml/2006/main">
@@ -2374,29 +2587,29 @@
                 <a:ea typeface="Helvetica Neue"/>
                 <a:cs typeface="Helvetica Neue"/>
               </a:rPr>
-              <a:t>the system matters</a:t>
-            </a:r>
-          </a:p>
-        </p:txBody>
-      </p:sp>
-      <p:sp>
-        <p:nvSpPr>
-          <p:cNvPr id="3" name="story-origin">
-            <a:extLst xmlns:a="http://schemas.openxmlformats.org/drawingml/2006/main">
-              <a:ext uri="{FF2B5EF4-FFF2-40B4-BE49-F238E27FC236}">
-                <a16:creationId xmlns:a16="http://schemas.microsoft.com/office/drawing/2014/main" id="{F347451E-1D8E-4D26-8F1A-681AA5EFA125}"/>
-              </a:ext>
-            </a:extLst>
-          </p:cNvPr>
-          <p:cNvSpPr>
-            <a:spLocks xmlns:a="http://schemas.openxmlformats.org/drawingml/2006/main" noGrp="1"/>
-          </p:cNvSpPr>
-          <p:nvPr/>
-        </p:nvSpPr>
-        <p:spPr>
-          <a:xfrm xmlns:a="http://schemas.openxmlformats.org/drawingml/2006/main">
-            <a:off x="609600" y="3333750"/>
-            <a:ext cx="5572125" cy="1228725"/>
+              <a:t>the learner workflow</a:t>
+            </a:r>
+          </a:p>
+        </p:txBody>
+      </p:sp>
+      <p:sp>
+        <p:nvSpPr>
+          <p:cNvPr id="3" name="asu-purpose">
+            <a:extLst xmlns:a="http://schemas.openxmlformats.org/drawingml/2006/main">
+              <a:ext uri="{FF2B5EF4-FFF2-40B4-BE49-F238E27FC236}">
+                <a16:creationId xmlns:a16="http://schemas.microsoft.com/office/drawing/2014/main" id="{8F4593FF-732E-4485-A06B-C11636456306}"/>
+              </a:ext>
+            </a:extLst>
+          </p:cNvPr>
+          <p:cNvSpPr>
+            <a:spLocks xmlns:a="http://schemas.openxmlformats.org/drawingml/2006/main" noGrp="1"/>
+          </p:cNvSpPr>
+          <p:nvPr/>
+        </p:nvSpPr>
+        <p:spPr>
+          <a:xfrm xmlns:a="http://schemas.openxmlformats.org/drawingml/2006/main">
+            <a:off x="609600" y="3228975"/>
+            <a:ext cx="6286500" cy="1114425"/>
           </a:xfrm>
           <a:prstGeom xmlns:a="http://schemas.openxmlformats.org/drawingml/2006/main" prst="rect">
             <a:avLst/>
@@ -2417,7 +2630,7 @@
                 <a:spcPct val="110000"/>
               </a:lnSpc>
               <a:buNone/>
-              <a:defRPr sz="1950" b="0">
+              <a:defRPr sz="2025" b="0">
                 <a:solidFill>
                   <a:srgbClr val="192B25"/>
                 </a:solidFill>
@@ -2427,7 +2640,7 @@
               </a:defRPr>
             </a:pPr>
             <a:r>
-              <a:rPr sz="1950" b="0">
+              <a:rPr sz="2025" b="0">
                 <a:solidFill>
                   <a:srgbClr val="192B25"/>
                 </a:solidFill>
@@ -2435,29 +2648,51 @@
                 <a:ea typeface="Helvetica Neue"/>
                 <a:cs typeface="Helvetica Neue"/>
               </a:rPr>
-              <a:t>Documentary filmmaking taught me to listen closely. Learning design taught me to make the next step teachable.</a:t>
-            </a:r>
-          </a:p>
-        </p:txBody>
-      </p:sp>
-      <p:sp>
-        <p:nvSpPr>
-          <p:cNvPr id="4" name="story-ai">
-            <a:extLst xmlns:a="http://schemas.openxmlformats.org/drawingml/2006/main">
-              <a:ext uri="{FF2B5EF4-FFF2-40B4-BE49-F238E27FC236}">
-                <a16:creationId xmlns:a16="http://schemas.microsoft.com/office/drawing/2014/main" id="{067B1565-37B5-4B95-B0AF-231E5100A9C2}"/>
-              </a:ext>
-            </a:extLst>
-          </p:cNvPr>
-          <p:cNvSpPr>
-            <a:spLocks xmlns:a="http://schemas.openxmlformats.org/drawingml/2006/main" noGrp="1"/>
-          </p:cNvSpPr>
-          <p:nvPr/>
-        </p:nvSpPr>
-        <p:spPr>
-          <a:xfrm xmlns:a="http://schemas.openxmlformats.org/drawingml/2006/main">
-            <a:off x="609600" y="4953000"/>
-            <a:ext cx="5572125" cy="1209675"/>
+              <a:t>I proposed staged generation of personalized learner tasks, with a mentor checking the context and the output.</a:t>
+            </a:r>
+          </a:p>
+        </p:txBody>
+      </p:sp>
+      <p:pic>
+        <p:nvPicPr>
+          <p:cNvPr id="10" name=""/>
+          <p:cNvPicPr>
+            <a:picLocks xmlns:a="http://schemas.openxmlformats.org/drawingml/2006/main" noChangeAspect="1"/>
+          </p:cNvPicPr>
+          <p:nvPr/>
+        </p:nvPicPr>
+        <p:blipFill>
+          <a:blip xmlns:r="http://schemas.openxmlformats.org/officeDocument/2006/relationships" xmlns:a="http://schemas.openxmlformats.org/drawingml/2006/main" r:embed="R444cfc0a62e24116"/>
+          <a:stretch xmlns:a="http://schemas.openxmlformats.org/drawingml/2006/main"/>
+        </p:blipFill>
+        <p:spPr>
+          <a:xfrm xmlns:a="http://schemas.openxmlformats.org/drawingml/2006/main">
+            <a:off x="8241908" y="1200150"/>
+            <a:ext cx="2604285" cy="5038725"/>
+          </a:xfrm>
+          <a:prstGeom xmlns:a="http://schemas.openxmlformats.org/drawingml/2006/main" prst="rect">
+            <a:avLst/>
+          </a:prstGeom>
+        </p:spPr>
+      </p:pic>
+      <p:sp>
+        <p:nvSpPr>
+          <p:cNvPr id="5" name="asu-stage">
+            <a:extLst xmlns:a="http://schemas.openxmlformats.org/drawingml/2006/main">
+              <a:ext uri="{FF2B5EF4-FFF2-40B4-BE49-F238E27FC236}">
+                <a16:creationId xmlns:a16="http://schemas.microsoft.com/office/drawing/2014/main" id="{CEADAC50-9255-4012-8333-DD98E4F21043}"/>
+              </a:ext>
+            </a:extLst>
+          </p:cNvPr>
+          <p:cNvSpPr>
+            <a:spLocks xmlns:a="http://schemas.openxmlformats.org/drawingml/2006/main" noGrp="1"/>
+          </p:cNvSpPr>
+          <p:nvPr/>
+        </p:nvSpPr>
+        <p:spPr>
+          <a:xfrm xmlns:a="http://schemas.openxmlformats.org/drawingml/2006/main">
+            <a:off x="609600" y="5257800"/>
+            <a:ext cx="6381750" cy="866775"/>
           </a:xfrm>
           <a:prstGeom xmlns:a="http://schemas.openxmlformats.org/drawingml/2006/main" prst="rect">
             <a:avLst/>
@@ -2478,7 +2713,7 @@
                 <a:spcPct val="110000"/>
               </a:lnSpc>
               <a:buNone/>
-              <a:defRPr sz="1800" b="0">
+              <a:defRPr sz="1575" b="0">
                 <a:solidFill>
                   <a:srgbClr val="58645D"/>
                 </a:solidFill>
@@ -2488,7 +2723,7 @@
               </a:defRPr>
             </a:pPr>
             <a:r>
-              <a:rPr sz="1800" b="0">
+              <a:rPr sz="1575" b="0">
                 <a:solidFill>
                   <a:srgbClr val="58645D"/>
                 </a:solidFill>
@@ -2496,39 +2731,17 @@
                 <a:ea typeface="Helvetica Neue"/>
                 <a:cs typeface="Helvetica Neue"/>
               </a:rPr>
-              <a:t>That perspective carries into my AI work: understand the task, make the output inspectable, and leave room for human judgment.</a:t>
-            </a:r>
-          </a:p>
-        </p:txBody>
-      </p:sp>
-      <p:pic>
-        <p:nvPicPr>
-          <p:cNvPr id="11" name=""/>
-          <p:cNvPicPr>
-            <a:picLocks xmlns:a="http://schemas.openxmlformats.org/drawingml/2006/main" noChangeAspect="1"/>
-          </p:cNvPicPr>
-          <p:nvPr/>
-        </p:nvPicPr>
-        <p:blipFill>
-          <a:blip xmlns:r="http://schemas.openxmlformats.org/officeDocument/2006/relationships" xmlns:a="http://schemas.openxmlformats.org/drawingml/2006/main" r:embed="Rb4d49872975243d8"/>
-          <a:stretch xmlns:a="http://schemas.openxmlformats.org/drawingml/2006/main"/>
-        </p:blipFill>
-        <p:spPr>
-          <a:xfrm xmlns:a="http://schemas.openxmlformats.org/drawingml/2006/main">
-            <a:off x="7010400" y="1447800"/>
-            <a:ext cx="4876800" cy="4876800"/>
-          </a:xfrm>
-          <a:prstGeom xmlns:a="http://schemas.openxmlformats.org/drawingml/2006/main" prst="rect">
-            <a:avLst/>
-          </a:prstGeom>
-        </p:spPr>
-      </p:pic>
+              <a:t>Two mentor checkpoints from the simplified 2024 proposal. Deployment and time savings were not established.</a:t>
+            </a:r>
+          </a:p>
+        </p:txBody>
+      </p:sp>
       <p:sp>
         <p:nvSpPr>
           <p:cNvPr id="6" name="slide-number">
             <a:extLst xmlns:a="http://schemas.openxmlformats.org/drawingml/2006/main">
               <a:ext uri="{FF2B5EF4-FFF2-40B4-BE49-F238E27FC236}">
-                <a16:creationId xmlns:a16="http://schemas.microsoft.com/office/drawing/2014/main" id="{458B06C5-9ECC-4648-A7EA-B92DCBD08E61}"/>
+                <a16:creationId xmlns:a16="http://schemas.microsoft.com/office/drawing/2014/main" id="{588F70A2-C2C3-4131-B6D7-D6DA64273C39}"/>
               </a:ext>
             </a:extLst>
           </p:cNvPr>
@@ -2587,7 +2800,7 @@
     </p:spTree>
     <p:extLst>
       <p:ext uri="{BB962C8B-B14F-4D97-AF65-F5344CB8AC3E}">
-        <p14:creationId xmlns:p14="http://schemas.microsoft.com/office/powerpoint/2010/main" val="665758601"/>
+        <p14:creationId xmlns:p14="http://schemas.microsoft.com/office/powerpoint/2010/main" val="473011641"/>
       </p:ext>
     </p:extLst>
   </p:cSld>
@@ -2595,6 +2808,1400 @@
 </file>
 
 <file path=ppt/slides/slide11.xml><?xml version="1.0" encoding="utf-8"?>
+<p:sld xmlns:p="http://schemas.openxmlformats.org/presentationml/2006/main">
+  <p:cSld>
+    <p:bg>
+      <p:bgPr>
+        <a:solidFill xmlns:a="http://schemas.openxmlformats.org/drawingml/2006/main">
+          <a:srgbClr val="F4F2E9"/>
+        </a:solidFill>
+      </p:bgPr>
+    </p:bg>
+    <p:spTree>
+      <p:nvGrpSpPr>
+        <p:cNvPr id="1" name=""/>
+        <p:cNvGrpSpPr/>
+        <p:nvPr/>
+      </p:nvGrpSpPr>
+      <p:grpSpPr>
+        <a:xfrm xmlns:a="http://schemas.openxmlformats.org/drawingml/2006/main"/>
+      </p:grpSpPr>
+      <p:sp>
+        <p:nvSpPr>
+          <p:cNvPr id="9" name="section-label">
+            <a:extLst xmlns:a="http://schemas.openxmlformats.org/drawingml/2006/main">
+              <a:ext uri="{FF2B5EF4-FFF2-40B4-BE49-F238E27FC236}">
+                <a16:creationId xmlns:a16="http://schemas.microsoft.com/office/drawing/2014/main" id="{79419B5A-84FE-48D7-A954-27EFFC437B80}"/>
+              </a:ext>
+            </a:extLst>
+          </p:cNvPr>
+          <p:cNvSpPr>
+            <a:spLocks xmlns:a="http://schemas.openxmlformats.org/drawingml/2006/main" noGrp="1"/>
+          </p:cNvSpPr>
+          <p:nvPr/>
+        </p:nvSpPr>
+        <p:spPr>
+          <a:xfrm xmlns:a="http://schemas.openxmlformats.org/drawingml/2006/main">
+            <a:off x="609600" y="495300"/>
+            <a:ext cx="10668000" cy="266700"/>
+          </a:xfrm>
+          <a:prstGeom xmlns:a="http://schemas.openxmlformats.org/drawingml/2006/main" prst="rect">
+            <a:avLst/>
+          </a:prstGeom>
+          <a:noFill xmlns:a="http://schemas.openxmlformats.org/drawingml/2006/main"/>
+          <a:ln xmlns:a="http://schemas.openxmlformats.org/drawingml/2006/main" w="0">
+            <a:noFill/>
+          </a:ln>
+        </p:spPr>
+        <p:txBody>
+          <a:bodyPr xmlns:a="http://schemas.openxmlformats.org/drawingml/2006/main" wrap="square" lIns="0" tIns="0" rIns="0" bIns="0" anchor="t">
+            <a:noAutofit/>
+          </a:bodyPr>
+          <a:lstStyle xmlns:a="http://schemas.openxmlformats.org/drawingml/2006/main"/>
+          <a:p xmlns:a="http://schemas.openxmlformats.org/drawingml/2006/main">
+            <a:pPr>
+              <a:lnSpc>
+                <a:spcPct val="110000"/>
+              </a:lnSpc>
+              <a:buNone/>
+              <a:defRPr sz="1200" b="1">
+                <a:solidFill>
+                  <a:srgbClr val="244D3C"/>
+                </a:solidFill>
+                <a:latin typeface="Helvetica Neue"/>
+                <a:ea typeface="Helvetica Neue"/>
+                <a:cs typeface="Helvetica Neue"/>
+              </a:defRPr>
+            </a:pPr>
+            <a:r>
+              <a:rPr sz="1200" b="1">
+                <a:solidFill>
+                  <a:srgbClr val="244D3C"/>
+                </a:solidFill>
+                <a:latin typeface="Helvetica Neue"/>
+                <a:ea typeface="Helvetica Neue"/>
+                <a:cs typeface="Helvetica Neue"/>
+              </a:rPr>
+              <a:t>LUMINA3D   /   LOCAL PLAYABLE CANDIDATE, 2026</a:t>
+            </a:r>
+          </a:p>
+        </p:txBody>
+      </p:sp>
+      <p:sp>
+        <p:nvSpPr>
+          <p:cNvPr id="2" name="headline">
+            <a:extLst xmlns:a="http://schemas.openxmlformats.org/drawingml/2006/main">
+              <a:ext uri="{FF2B5EF4-FFF2-40B4-BE49-F238E27FC236}">
+                <a16:creationId xmlns:a16="http://schemas.microsoft.com/office/drawing/2014/main" id="{2DD94AF9-53FA-413E-890E-7E7125C12287}"/>
+              </a:ext>
+            </a:extLst>
+          </p:cNvPr>
+          <p:cNvSpPr>
+            <a:spLocks xmlns:a="http://schemas.openxmlformats.org/drawingml/2006/main" noGrp="1"/>
+          </p:cNvSpPr>
+          <p:nvPr/>
+        </p:nvSpPr>
+        <p:spPr>
+          <a:xfrm xmlns:a="http://schemas.openxmlformats.org/drawingml/2006/main">
+            <a:off x="609600" y="1057275"/>
+            <a:ext cx="10896600" cy="1143000"/>
+          </a:xfrm>
+          <a:prstGeom xmlns:a="http://schemas.openxmlformats.org/drawingml/2006/main" prst="rect">
+            <a:avLst/>
+          </a:prstGeom>
+          <a:noFill xmlns:a="http://schemas.openxmlformats.org/drawingml/2006/main"/>
+          <a:ln xmlns:a="http://schemas.openxmlformats.org/drawingml/2006/main" w="0">
+            <a:noFill/>
+          </a:ln>
+        </p:spPr>
+        <p:txBody>
+          <a:bodyPr xmlns:a="http://schemas.openxmlformats.org/drawingml/2006/main" wrap="square" lIns="0" tIns="0" rIns="0" bIns="0" anchor="t">
+            <a:noAutofit/>
+          </a:bodyPr>
+          <a:lstStyle xmlns:a="http://schemas.openxmlformats.org/drawingml/2006/main"/>
+          <a:p xmlns:a="http://schemas.openxmlformats.org/drawingml/2006/main">
+            <a:pPr>
+              <a:lnSpc>
+                <a:spcPct val="110000"/>
+              </a:lnSpc>
+              <a:buNone/>
+              <a:defRPr sz="3600" b="1">
+                <a:solidFill>
+                  <a:srgbClr val="192B25"/>
+                </a:solidFill>
+                <a:latin typeface="Helvetica Neue"/>
+                <a:ea typeface="Helvetica Neue"/>
+                <a:cs typeface="Helvetica Neue"/>
+              </a:defRPr>
+            </a:pPr>
+            <a:r>
+              <a:rPr sz="3600" b="1">
+                <a:solidFill>
+                  <a:srgbClr val="192B25"/>
+                </a:solidFill>
+                <a:latin typeface="Helvetica Neue"/>
+                <a:ea typeface="Helvetica Neue"/>
+                <a:cs typeface="Helvetica Neue"/>
+              </a:rPr>
+              <a:t>Spatial context guides</a:t>
+            </a:r>
+          </a:p>
+          <a:p xmlns:a="http://schemas.openxmlformats.org/drawingml/2006/main">
+            <a:pPr>
+              <a:lnSpc>
+                <a:spcPct val="110000"/>
+              </a:lnSpc>
+              <a:buNone/>
+              <a:defRPr sz="3600" b="1">
+                <a:solidFill>
+                  <a:srgbClr val="192B25"/>
+                </a:solidFill>
+                <a:latin typeface="Helvetica Neue"/>
+                <a:ea typeface="Helvetica Neue"/>
+                <a:cs typeface="Helvetica Neue"/>
+              </a:defRPr>
+            </a:pPr>
+            <a:r>
+              <a:rPr sz="3600" b="1">
+                <a:solidFill>
+                  <a:srgbClr val="192B25"/>
+                </a:solidFill>
+                <a:latin typeface="Helvetica Neue"/>
+                <a:ea typeface="Helvetica Neue"/>
+                <a:cs typeface="Helvetica Neue"/>
+              </a:rPr>
+              <a:t>AI-assisted edits</a:t>
+            </a:r>
+          </a:p>
+        </p:txBody>
+      </p:sp>
+      <p:pic>
+        <p:nvPicPr>
+          <p:cNvPr id="11" name=""/>
+          <p:cNvPicPr>
+            <a:picLocks xmlns:a="http://schemas.openxmlformats.org/drawingml/2006/main" noChangeAspect="1"/>
+          </p:cNvPicPr>
+          <p:nvPr/>
+        </p:nvPicPr>
+        <p:blipFill>
+          <a:blip xmlns:r="http://schemas.openxmlformats.org/officeDocument/2006/relationships" xmlns:a="http://schemas.openxmlformats.org/drawingml/2006/main" r:embed="R98461685271e4624"/>
+          <a:stretch xmlns:a="http://schemas.openxmlformats.org/drawingml/2006/main"/>
+        </p:blipFill>
+        <p:spPr>
+          <a:xfrm xmlns:a="http://schemas.openxmlformats.org/drawingml/2006/main">
+            <a:off x="1479033" y="2286000"/>
+            <a:ext cx="6281184" cy="3971925"/>
+          </a:xfrm>
+          <a:prstGeom xmlns:a="http://schemas.openxmlformats.org/drawingml/2006/main" prst="rect">
+            <a:avLst/>
+          </a:prstGeom>
+        </p:spPr>
+      </p:pic>
+      <p:sp>
+        <p:nvSpPr>
+          <p:cNvPr id="4" name="lumina-purpose">
+            <a:extLst xmlns:a="http://schemas.openxmlformats.org/drawingml/2006/main">
+              <a:ext uri="{FF2B5EF4-FFF2-40B4-BE49-F238E27FC236}">
+                <a16:creationId xmlns:a16="http://schemas.microsoft.com/office/drawing/2014/main" id="{62CDFC7A-A401-42C4-AA1F-E357F6608CA0}"/>
+              </a:ext>
+            </a:extLst>
+          </p:cNvPr>
+          <p:cNvSpPr>
+            <a:spLocks xmlns:a="http://schemas.openxmlformats.org/drawingml/2006/main" noGrp="1"/>
+          </p:cNvSpPr>
+          <p:nvPr/>
+        </p:nvSpPr>
+        <p:spPr>
+          <a:xfrm xmlns:a="http://schemas.openxmlformats.org/drawingml/2006/main">
+            <a:off x="8991600" y="2428875"/>
+            <a:ext cx="2562225" cy="1714500"/>
+          </a:xfrm>
+          <a:prstGeom xmlns:a="http://schemas.openxmlformats.org/drawingml/2006/main" prst="rect">
+            <a:avLst/>
+          </a:prstGeom>
+          <a:noFill xmlns:a="http://schemas.openxmlformats.org/drawingml/2006/main"/>
+          <a:ln xmlns:a="http://schemas.openxmlformats.org/drawingml/2006/main" w="0">
+            <a:noFill/>
+          </a:ln>
+        </p:spPr>
+        <p:txBody>
+          <a:bodyPr xmlns:a="http://schemas.openxmlformats.org/drawingml/2006/main" wrap="square" lIns="0" tIns="0" rIns="0" bIns="0" anchor="t">
+            <a:noAutofit/>
+          </a:bodyPr>
+          <a:lstStyle xmlns:a="http://schemas.openxmlformats.org/drawingml/2006/main"/>
+          <a:p xmlns:a="http://schemas.openxmlformats.org/drawingml/2006/main">
+            <a:pPr>
+              <a:lnSpc>
+                <a:spcPct val="110000"/>
+              </a:lnSpc>
+              <a:buNone/>
+              <a:defRPr sz="1800" b="0">
+                <a:solidFill>
+                  <a:srgbClr val="192B25"/>
+                </a:solidFill>
+                <a:latin typeface="Helvetica Neue"/>
+                <a:ea typeface="Helvetica Neue"/>
+                <a:cs typeface="Helvetica Neue"/>
+              </a:defRPr>
+            </a:pPr>
+            <a:r>
+              <a:rPr sz="1800" b="0">
+                <a:solidFill>
+                  <a:srgbClr val="192B25"/>
+                </a:solidFill>
+                <a:latin typeface="Helvetica Neue"/>
+                <a:ea typeface="Helvetica Neue"/>
+                <a:cs typeface="Helvetica Neue"/>
+              </a:rPr>
+              <a:t>I capture the selected object, position and collision context before asking AI to diagnose a scene bug.</a:t>
+            </a:r>
+          </a:p>
+        </p:txBody>
+      </p:sp>
+      <p:sp>
+        <p:nvSpPr>
+          <p:cNvPr id="5" name="lumina-detail">
+            <a:extLst xmlns:a="http://schemas.openxmlformats.org/drawingml/2006/main">
+              <a:ext uri="{FF2B5EF4-FFF2-40B4-BE49-F238E27FC236}">
+                <a16:creationId xmlns:a16="http://schemas.microsoft.com/office/drawing/2014/main" id="{8C130CBA-9D78-4907-BFA1-29B396349218}"/>
+              </a:ext>
+            </a:extLst>
+          </p:cNvPr>
+          <p:cNvSpPr>
+            <a:spLocks xmlns:a="http://schemas.openxmlformats.org/drawingml/2006/main" noGrp="1"/>
+          </p:cNvSpPr>
+          <p:nvPr/>
+        </p:nvSpPr>
+        <p:spPr>
+          <a:xfrm xmlns:a="http://schemas.openxmlformats.org/drawingml/2006/main">
+            <a:off x="8991600" y="4505325"/>
+            <a:ext cx="2562225" cy="1190625"/>
+          </a:xfrm>
+          <a:prstGeom xmlns:a="http://schemas.openxmlformats.org/drawingml/2006/main" prst="rect">
+            <a:avLst/>
+          </a:prstGeom>
+          <a:noFill xmlns:a="http://schemas.openxmlformats.org/drawingml/2006/main"/>
+          <a:ln xmlns:a="http://schemas.openxmlformats.org/drawingml/2006/main" w="0">
+            <a:noFill/>
+          </a:ln>
+        </p:spPr>
+        <p:txBody>
+          <a:bodyPr xmlns:a="http://schemas.openxmlformats.org/drawingml/2006/main" wrap="square" lIns="0" tIns="0" rIns="0" bIns="0" anchor="t">
+            <a:noAutofit/>
+          </a:bodyPr>
+          <a:lstStyle xmlns:a="http://schemas.openxmlformats.org/drawingml/2006/main"/>
+          <a:p xmlns:a="http://schemas.openxmlformats.org/drawingml/2006/main">
+            <a:pPr>
+              <a:lnSpc>
+                <a:spcPct val="110000"/>
+              </a:lnSpc>
+              <a:buNone/>
+              <a:defRPr sz="1575" b="0">
+                <a:solidFill>
+                  <a:srgbClr val="58645D"/>
+                </a:solidFill>
+                <a:latin typeface="Helvetica Neue"/>
+                <a:ea typeface="Helvetica Neue"/>
+                <a:cs typeface="Helvetica Neue"/>
+              </a:defRPr>
+            </a:pPr>
+            <a:r>
+              <a:rPr sz="1575" b="0">
+                <a:solidFill>
+                  <a:srgbClr val="58645D"/>
+                </a:solidFill>
+                <a:latin typeface="Helvetica Neue"/>
+                <a:ea typeface="Helvetica Neue"/>
+                <a:cs typeface="Helvetica Neue"/>
+              </a:rPr>
+              <a:t>The AI proposes a small source change. I check it with a build, scene tests and play.</a:t>
+            </a:r>
+          </a:p>
+        </p:txBody>
+      </p:sp>
+      <p:sp>
+        <p:nvSpPr>
+          <p:cNvPr id="6" name="lumina-case-background">
+            <a:extLst xmlns:a="http://schemas.openxmlformats.org/drawingml/2006/main">
+              <a:ext uri="{FF2B5EF4-FFF2-40B4-BE49-F238E27FC236}">
+                <a16:creationId xmlns:a16="http://schemas.microsoft.com/office/drawing/2014/main" id="{F0078BE6-2C1B-43B7-9673-5A23C98C0DCB}"/>
+              </a:ext>
+            </a:extLst>
+          </p:cNvPr>
+          <p:cNvSpPr>
+            <a:spLocks xmlns:a="http://schemas.openxmlformats.org/drawingml/2006/main" noGrp="1"/>
+          </p:cNvSpPr>
+          <p:nvPr/>
+        </p:nvSpPr>
+        <p:spPr>
+          <a:xfrm xmlns:a="http://schemas.openxmlformats.org/drawingml/2006/main">
+            <a:off x="8810625" y="6153150"/>
+            <a:ext cx="2343150" cy="400050"/>
+          </a:xfrm>
+          <a:prstGeom xmlns:a="http://schemas.openxmlformats.org/drawingml/2006/main" prst="rect">
+            <a:avLst/>
+          </a:prstGeom>
+          <a:solidFill xmlns:a="http://schemas.openxmlformats.org/drawingml/2006/main">
+            <a:srgbClr val="244D3C"/>
+          </a:solidFill>
+          <a:ln xmlns:a="http://schemas.openxmlformats.org/drawingml/2006/main" w="0">
+            <a:noFill/>
+          </a:ln>
+        </p:spPr>
+      </p:sp>
+      <p:sp>
+        <p:nvSpPr>
+          <p:cNvPr id="7" name="lumina-case-link">
+            <a:extLst xmlns:a="http://schemas.openxmlformats.org/drawingml/2006/main">
+              <a:ext uri="{FF2B5EF4-FFF2-40B4-BE49-F238E27FC236}">
+                <a16:creationId xmlns:a16="http://schemas.microsoft.com/office/drawing/2014/main" id="{1F22B30B-F18D-431A-9CDB-21EEAE7813A4}"/>
+              </a:ext>
+            </a:extLst>
+          </p:cNvPr>
+          <p:cNvSpPr>
+            <a:spLocks xmlns:a="http://schemas.openxmlformats.org/drawingml/2006/main" noGrp="1"/>
+          </p:cNvSpPr>
+          <p:nvPr/>
+        </p:nvSpPr>
+        <p:spPr>
+          <a:xfrm xmlns:a="http://schemas.openxmlformats.org/drawingml/2006/main">
+            <a:off x="8963025" y="6229350"/>
+            <a:ext cx="2047875" cy="266700"/>
+          </a:xfrm>
+          <a:prstGeom xmlns:a="http://schemas.openxmlformats.org/drawingml/2006/main" prst="rect">
+            <a:avLst/>
+          </a:prstGeom>
+          <a:noFill xmlns:a="http://schemas.openxmlformats.org/drawingml/2006/main"/>
+          <a:ln xmlns:a="http://schemas.openxmlformats.org/drawingml/2006/main" w="0">
+            <a:noFill/>
+          </a:ln>
+        </p:spPr>
+        <p:txBody>
+          <a:bodyPr xmlns:a="http://schemas.openxmlformats.org/drawingml/2006/main" wrap="square" lIns="0" tIns="0" rIns="0" bIns="0" anchor="t">
+            <a:noAutofit/>
+          </a:bodyPr>
+          <a:lstStyle xmlns:a="http://schemas.openxmlformats.org/drawingml/2006/main"/>
+          <a:p xmlns:a="http://schemas.openxmlformats.org/drawingml/2006/main">
+            <a:pPr>
+              <a:lnSpc>
+                <a:spcPct val="110000"/>
+              </a:lnSpc>
+              <a:buNone/>
+              <a:defRPr sz="1350" b="0" u="sng">
+                <a:solidFill>
+                  <a:srgbClr val="DBEB89"/>
+                </a:solidFill>
+                <a:latin typeface="Helvetica Neue"/>
+                <a:ea typeface="Helvetica Neue"/>
+                <a:cs typeface="Helvetica Neue"/>
+              </a:defRPr>
+            </a:pPr>
+            <a:r>
+              <a:rPr sz="1350" b="0" u="sng">
+                <a:solidFill>
+                  <a:srgbClr val="DBEB89"/>
+                </a:solidFill>
+                <a:latin typeface="Helvetica Neue"/>
+                <a:ea typeface="Helvetica Neue"/>
+                <a:cs typeface="Helvetica Neue"/>
+                <a:hlinkClick xmlns:r="http://schemas.openxmlformats.org/officeDocument/2006/relationships" r:id="Ra20fcaa4c4c742ad"/>
+              </a:rPr>
+              <a:t>View the case →</a:t>
+            </a:r>
+          </a:p>
+        </p:txBody>
+      </p:sp>
+      <p:sp>
+        <p:nvSpPr>
+          <p:cNvPr id="8" name="slide-number">
+            <a:extLst xmlns:a="http://schemas.openxmlformats.org/drawingml/2006/main">
+              <a:ext uri="{FF2B5EF4-FFF2-40B4-BE49-F238E27FC236}">
+                <a16:creationId xmlns:a16="http://schemas.microsoft.com/office/drawing/2014/main" id="{F7CD9389-2901-489B-8867-46C4272809F2}"/>
+              </a:ext>
+            </a:extLst>
+          </p:cNvPr>
+          <p:cNvSpPr>
+            <a:spLocks xmlns:a="http://schemas.openxmlformats.org/drawingml/2006/main" noGrp="1"/>
+          </p:cNvSpPr>
+          <p:nvPr/>
+        </p:nvSpPr>
+        <p:spPr>
+          <a:xfrm xmlns:a="http://schemas.openxmlformats.org/drawingml/2006/main">
+            <a:off x="11353800" y="6562725"/>
+            <a:ext cx="323850" cy="190500"/>
+          </a:xfrm>
+          <a:prstGeom xmlns:a="http://schemas.openxmlformats.org/drawingml/2006/main" prst="rect">
+            <a:avLst/>
+          </a:prstGeom>
+          <a:noFill xmlns:a="http://schemas.openxmlformats.org/drawingml/2006/main"/>
+          <a:ln xmlns:a="http://schemas.openxmlformats.org/drawingml/2006/main" w="0">
+            <a:noFill/>
+          </a:ln>
+        </p:spPr>
+        <p:txBody>
+          <a:bodyPr xmlns:a="http://schemas.openxmlformats.org/drawingml/2006/main" wrap="square" lIns="0" tIns="0" rIns="0" bIns="0" anchor="t">
+            <a:noAutofit/>
+          </a:bodyPr>
+          <a:lstStyle xmlns:a="http://schemas.openxmlformats.org/drawingml/2006/main"/>
+          <a:p xmlns:a="http://schemas.openxmlformats.org/drawingml/2006/main">
+            <a:pPr>
+              <a:lnSpc>
+                <a:spcPct val="110000"/>
+              </a:lnSpc>
+              <a:buNone/>
+              <a:defRPr sz="1050" b="0">
+                <a:solidFill>
+                  <a:srgbClr val="58645D"/>
+                </a:solidFill>
+                <a:latin typeface="Helvetica Neue"/>
+                <a:ea typeface="Helvetica Neue"/>
+                <a:cs typeface="Helvetica Neue"/>
+              </a:defRPr>
+            </a:pPr>
+            <a:r>
+              <a:rPr sz="1050" b="0">
+                <a:solidFill>
+                  <a:srgbClr val="58645D"/>
+                </a:solidFill>
+                <a:latin typeface="Helvetica Neue"/>
+                <a:ea typeface="Helvetica Neue"/>
+                <a:cs typeface="Helvetica Neue"/>
+              </a:rPr>
+              <a:t>11</a:t>
+            </a:r>
+          </a:p>
+        </p:txBody>
+      </p:sp>
+    </p:spTree>
+    <p:extLst>
+      <p:ext uri="{BB962C8B-B14F-4D97-AF65-F5344CB8AC3E}">
+        <p14:creationId xmlns:p14="http://schemas.microsoft.com/office/powerpoint/2010/main" val="1249901970"/>
+      </p:ext>
+    </p:extLst>
+  </p:cSld>
+</p:sld>
+</file>
+
+<file path=ppt/slides/slide12.xml><?xml version="1.0" encoding="utf-8"?>
+<p:sld xmlns:p="http://schemas.openxmlformats.org/presentationml/2006/main">
+  <p:cSld>
+    <p:bg>
+      <p:bgPr>
+        <a:solidFill xmlns:a="http://schemas.openxmlformats.org/drawingml/2006/main">
+          <a:srgbClr val="F4F2E9"/>
+        </a:solidFill>
+      </p:bgPr>
+    </p:bg>
+    <p:spTree>
+      <p:nvGrpSpPr>
+        <p:cNvPr id="1" name=""/>
+        <p:cNvGrpSpPr/>
+        <p:nvPr/>
+      </p:nvGrpSpPr>
+      <p:grpSpPr>
+        <a:xfrm xmlns:a="http://schemas.openxmlformats.org/drawingml/2006/main"/>
+      </p:grpSpPr>
+      <p:sp>
+        <p:nvSpPr>
+          <p:cNvPr id="10" name="section-label">
+            <a:extLst xmlns:a="http://schemas.openxmlformats.org/drawingml/2006/main">
+              <a:ext uri="{FF2B5EF4-FFF2-40B4-BE49-F238E27FC236}">
+                <a16:creationId xmlns:a16="http://schemas.microsoft.com/office/drawing/2014/main" id="{A999F192-BA08-4EEA-8048-A3F00875C5C7}"/>
+              </a:ext>
+            </a:extLst>
+          </p:cNvPr>
+          <p:cNvSpPr>
+            <a:spLocks xmlns:a="http://schemas.openxmlformats.org/drawingml/2006/main" noGrp="1"/>
+          </p:cNvSpPr>
+          <p:nvPr/>
+        </p:nvSpPr>
+        <p:spPr>
+          <a:xfrm xmlns:a="http://schemas.openxmlformats.org/drawingml/2006/main">
+            <a:off x="609600" y="495300"/>
+            <a:ext cx="10668000" cy="266700"/>
+          </a:xfrm>
+          <a:prstGeom xmlns:a="http://schemas.openxmlformats.org/drawingml/2006/main" prst="rect">
+            <a:avLst/>
+          </a:prstGeom>
+          <a:noFill xmlns:a="http://schemas.openxmlformats.org/drawingml/2006/main"/>
+          <a:ln xmlns:a="http://schemas.openxmlformats.org/drawingml/2006/main" w="0">
+            <a:noFill/>
+          </a:ln>
+        </p:spPr>
+        <p:txBody>
+          <a:bodyPr xmlns:a="http://schemas.openxmlformats.org/drawingml/2006/main" wrap="square" lIns="0" tIns="0" rIns="0" bIns="0" anchor="t">
+            <a:noAutofit/>
+          </a:bodyPr>
+          <a:lstStyle xmlns:a="http://schemas.openxmlformats.org/drawingml/2006/main"/>
+          <a:p xmlns:a="http://schemas.openxmlformats.org/drawingml/2006/main">
+            <a:pPr>
+              <a:lnSpc>
+                <a:spcPct val="110000"/>
+              </a:lnSpc>
+              <a:buNone/>
+              <a:defRPr sz="1200" b="1">
+                <a:solidFill>
+                  <a:srgbClr val="244D3C"/>
+                </a:solidFill>
+                <a:latin typeface="Helvetica Neue"/>
+                <a:ea typeface="Helvetica Neue"/>
+                <a:cs typeface="Helvetica Neue"/>
+              </a:defRPr>
+            </a:pPr>
+            <a:r>
+              <a:rPr sz="1200" b="1">
+                <a:solidFill>
+                  <a:srgbClr val="244D3C"/>
+                </a:solidFill>
+                <a:latin typeface="Helvetica Neue"/>
+                <a:ea typeface="Helvetica Neue"/>
+                <a:cs typeface="Helvetica Neue"/>
+              </a:rPr>
+              <a:t>PORTFOLIO MAKING   /   ORIGINAL PUBLIC SITE, 2026</a:t>
+            </a:r>
+          </a:p>
+        </p:txBody>
+      </p:sp>
+      <p:sp>
+        <p:nvSpPr>
+          <p:cNvPr id="2" name="headline">
+            <a:extLst xmlns:a="http://schemas.openxmlformats.org/drawingml/2006/main">
+              <a:ext uri="{FF2B5EF4-FFF2-40B4-BE49-F238E27FC236}">
+                <a16:creationId xmlns:a16="http://schemas.microsoft.com/office/drawing/2014/main" id="{07DEB018-8998-465F-AD57-A6B2AF0E3723}"/>
+              </a:ext>
+            </a:extLst>
+          </p:cNvPr>
+          <p:cNvSpPr>
+            <a:spLocks xmlns:a="http://schemas.openxmlformats.org/drawingml/2006/main" noGrp="1"/>
+          </p:cNvSpPr>
+          <p:nvPr/>
+        </p:nvSpPr>
+        <p:spPr>
+          <a:xfrm xmlns:a="http://schemas.openxmlformats.org/drawingml/2006/main">
+            <a:off x="609600" y="1057275"/>
+            <a:ext cx="10896600" cy="1143000"/>
+          </a:xfrm>
+          <a:prstGeom xmlns:a="http://schemas.openxmlformats.org/drawingml/2006/main" prst="rect">
+            <a:avLst/>
+          </a:prstGeom>
+          <a:noFill xmlns:a="http://schemas.openxmlformats.org/drawingml/2006/main"/>
+          <a:ln xmlns:a="http://schemas.openxmlformats.org/drawingml/2006/main" w="0">
+            <a:noFill/>
+          </a:ln>
+        </p:spPr>
+        <p:txBody>
+          <a:bodyPr xmlns:a="http://schemas.openxmlformats.org/drawingml/2006/main" wrap="square" lIns="0" tIns="0" rIns="0" bIns="0" anchor="t">
+            <a:noAutofit/>
+          </a:bodyPr>
+          <a:lstStyle xmlns:a="http://schemas.openxmlformats.org/drawingml/2006/main"/>
+          <a:p xmlns:a="http://schemas.openxmlformats.org/drawingml/2006/main">
+            <a:pPr>
+              <a:lnSpc>
+                <a:spcPct val="110000"/>
+              </a:lnSpc>
+              <a:buNone/>
+              <a:defRPr sz="3600" b="1">
+                <a:solidFill>
+                  <a:srgbClr val="192B25"/>
+                </a:solidFill>
+                <a:latin typeface="Helvetica Neue"/>
+                <a:ea typeface="Helvetica Neue"/>
+                <a:cs typeface="Helvetica Neue"/>
+              </a:defRPr>
+            </a:pPr>
+            <a:r>
+              <a:rPr sz="3600" b="1">
+                <a:solidFill>
+                  <a:srgbClr val="192B25"/>
+                </a:solidFill>
+                <a:latin typeface="Helvetica Neue"/>
+                <a:ea typeface="Helvetica Neue"/>
+                <a:cs typeface="Helvetica Neue"/>
+              </a:rPr>
+              <a:t>The portfolio is part</a:t>
+            </a:r>
+          </a:p>
+          <a:p xmlns:a="http://schemas.openxmlformats.org/drawingml/2006/main">
+            <a:pPr>
+              <a:lnSpc>
+                <a:spcPct val="110000"/>
+              </a:lnSpc>
+              <a:buNone/>
+              <a:defRPr sz="3600" b="1">
+                <a:solidFill>
+                  <a:srgbClr val="192B25"/>
+                </a:solidFill>
+                <a:latin typeface="Helvetica Neue"/>
+                <a:ea typeface="Helvetica Neue"/>
+                <a:cs typeface="Helvetica Neue"/>
+              </a:defRPr>
+            </a:pPr>
+            <a:r>
+              <a:rPr sz="3600" b="1">
+                <a:solidFill>
+                  <a:srgbClr val="192B25"/>
+                </a:solidFill>
+                <a:latin typeface="Helvetica Neue"/>
+                <a:ea typeface="Helvetica Neue"/>
+                <a:cs typeface="Helvetica Neue"/>
+              </a:rPr>
+              <a:t>of the AI workflow</a:t>
+            </a:r>
+          </a:p>
+        </p:txBody>
+      </p:sp>
+      <p:pic>
+        <p:nvPicPr>
+          <p:cNvPr id="12" name=""/>
+          <p:cNvPicPr>
+            <a:picLocks xmlns:a="http://schemas.openxmlformats.org/drawingml/2006/main" noChangeAspect="1"/>
+          </p:cNvPicPr>
+          <p:nvPr/>
+        </p:nvPicPr>
+        <p:blipFill>
+          <a:blip xmlns:r="http://schemas.openxmlformats.org/officeDocument/2006/relationships" xmlns:a="http://schemas.openxmlformats.org/drawingml/2006/main" r:embed="R1292b3510add4ddf"/>
+          <a:stretch xmlns:a="http://schemas.openxmlformats.org/drawingml/2006/main"/>
+        </p:blipFill>
+        <p:spPr>
+          <a:xfrm xmlns:a="http://schemas.openxmlformats.org/drawingml/2006/main">
+            <a:off x="1716977" y="2286000"/>
+            <a:ext cx="5719572" cy="3971925"/>
+          </a:xfrm>
+          <a:prstGeom xmlns:a="http://schemas.openxmlformats.org/drawingml/2006/main" prst="rect">
+            <a:avLst/>
+          </a:prstGeom>
+        </p:spPr>
+      </p:pic>
+      <p:sp>
+        <p:nvSpPr>
+          <p:cNvPr id="4" name="portfolio-purpose">
+            <a:extLst xmlns:a="http://schemas.openxmlformats.org/drawingml/2006/main">
+              <a:ext uri="{FF2B5EF4-FFF2-40B4-BE49-F238E27FC236}">
+                <a16:creationId xmlns:a16="http://schemas.microsoft.com/office/drawing/2014/main" id="{5C02D13F-5D6D-4CA6-AC10-B179C05A848E}"/>
+              </a:ext>
+            </a:extLst>
+          </p:cNvPr>
+          <p:cNvSpPr>
+            <a:spLocks xmlns:a="http://schemas.openxmlformats.org/drawingml/2006/main" noGrp="1"/>
+          </p:cNvSpPr>
+          <p:nvPr/>
+        </p:nvSpPr>
+        <p:spPr>
+          <a:xfrm xmlns:a="http://schemas.openxmlformats.org/drawingml/2006/main">
+            <a:off x="8896350" y="2419350"/>
+            <a:ext cx="2657475" cy="1714500"/>
+          </a:xfrm>
+          <a:prstGeom xmlns:a="http://schemas.openxmlformats.org/drawingml/2006/main" prst="rect">
+            <a:avLst/>
+          </a:prstGeom>
+          <a:noFill xmlns:a="http://schemas.openxmlformats.org/drawingml/2006/main"/>
+          <a:ln xmlns:a="http://schemas.openxmlformats.org/drawingml/2006/main" w="0">
+            <a:noFill/>
+          </a:ln>
+        </p:spPr>
+        <p:txBody>
+          <a:bodyPr xmlns:a="http://schemas.openxmlformats.org/drawingml/2006/main" wrap="square" lIns="0" tIns="0" rIns="0" bIns="0" anchor="t">
+            <a:noAutofit/>
+          </a:bodyPr>
+          <a:lstStyle xmlns:a="http://schemas.openxmlformats.org/drawingml/2006/main"/>
+          <a:p xmlns:a="http://schemas.openxmlformats.org/drawingml/2006/main">
+            <a:pPr>
+              <a:lnSpc>
+                <a:spcPct val="110000"/>
+              </a:lnSpc>
+              <a:buNone/>
+              <a:defRPr sz="1800" b="0">
+                <a:solidFill>
+                  <a:srgbClr val="192B25"/>
+                </a:solidFill>
+                <a:latin typeface="Helvetica Neue"/>
+                <a:ea typeface="Helvetica Neue"/>
+                <a:cs typeface="Helvetica Neue"/>
+              </a:defRPr>
+            </a:pPr>
+            <a:r>
+              <a:rPr sz="1800" b="0">
+                <a:solidFill>
+                  <a:srgbClr val="192B25"/>
+                </a:solidFill>
+                <a:latin typeface="Helvetica Neue"/>
+                <a:ea typeface="Helvetica Neue"/>
+                <a:cs typeface="Helvetica Neue"/>
+              </a:rPr>
+              <a:t>I use AI to organize source material and test drafts, then check each public claim against its evidence.</a:t>
+            </a:r>
+          </a:p>
+        </p:txBody>
+      </p:sp>
+      <p:sp>
+        <p:nvSpPr>
+          <p:cNvPr id="5" name="portfolio-detail">
+            <a:extLst xmlns:a="http://schemas.openxmlformats.org/drawingml/2006/main">
+              <a:ext uri="{FF2B5EF4-FFF2-40B4-BE49-F238E27FC236}">
+                <a16:creationId xmlns:a16="http://schemas.microsoft.com/office/drawing/2014/main" id="{FF2711F7-1978-494C-99C9-164790F2C42A}"/>
+              </a:ext>
+            </a:extLst>
+          </p:cNvPr>
+          <p:cNvSpPr>
+            <a:spLocks xmlns:a="http://schemas.openxmlformats.org/drawingml/2006/main" noGrp="1"/>
+          </p:cNvSpPr>
+          <p:nvPr/>
+        </p:nvSpPr>
+        <p:spPr>
+          <a:xfrm xmlns:a="http://schemas.openxmlformats.org/drawingml/2006/main">
+            <a:off x="8896350" y="4629150"/>
+            <a:ext cx="2657475" cy="1057275"/>
+          </a:xfrm>
+          <a:prstGeom xmlns:a="http://schemas.openxmlformats.org/drawingml/2006/main" prst="rect">
+            <a:avLst/>
+          </a:prstGeom>
+          <a:noFill xmlns:a="http://schemas.openxmlformats.org/drawingml/2006/main"/>
+          <a:ln xmlns:a="http://schemas.openxmlformats.org/drawingml/2006/main" w="0">
+            <a:noFill/>
+          </a:ln>
+        </p:spPr>
+        <p:txBody>
+          <a:bodyPr xmlns:a="http://schemas.openxmlformats.org/drawingml/2006/main" wrap="square" lIns="0" tIns="0" rIns="0" bIns="0" anchor="t">
+            <a:noAutofit/>
+          </a:bodyPr>
+          <a:lstStyle xmlns:a="http://schemas.openxmlformats.org/drawingml/2006/main"/>
+          <a:p xmlns:a="http://schemas.openxmlformats.org/drawingml/2006/main">
+            <a:pPr>
+              <a:lnSpc>
+                <a:spcPct val="110000"/>
+              </a:lnSpc>
+              <a:buNone/>
+              <a:defRPr sz="1575" b="0">
+                <a:solidFill>
+                  <a:srgbClr val="58645D"/>
+                </a:solidFill>
+                <a:latin typeface="Helvetica Neue"/>
+                <a:ea typeface="Helvetica Neue"/>
+                <a:cs typeface="Helvetica Neue"/>
+              </a:defRPr>
+            </a:pPr>
+            <a:r>
+              <a:rPr sz="1575" b="0">
+                <a:solidFill>
+                  <a:srgbClr val="58645D"/>
+                </a:solidFill>
+                <a:latin typeface="Helvetica Neue"/>
+                <a:ea typeface="Helvetica Neue"/>
+                <a:cs typeface="Helvetica Neue"/>
+              </a:rPr>
+              <a:t>The result connects a working example to its case, context and next action.</a:t>
+            </a:r>
+          </a:p>
+        </p:txBody>
+      </p:sp>
+      <p:sp>
+        <p:nvSpPr>
+          <p:cNvPr id="6" name="portfolio-image-status">
+            <a:extLst xmlns:a="http://schemas.openxmlformats.org/drawingml/2006/main">
+              <a:ext uri="{FF2B5EF4-FFF2-40B4-BE49-F238E27FC236}">
+                <a16:creationId xmlns:a16="http://schemas.microsoft.com/office/drawing/2014/main" id="{7DADA056-E331-4360-B939-83E592678D3F}"/>
+              </a:ext>
+            </a:extLst>
+          </p:cNvPr>
+          <p:cNvSpPr>
+            <a:spLocks xmlns:a="http://schemas.openxmlformats.org/drawingml/2006/main" noGrp="1"/>
+          </p:cNvSpPr>
+          <p:nvPr/>
+        </p:nvSpPr>
+        <p:spPr>
+          <a:xfrm xmlns:a="http://schemas.openxmlformats.org/drawingml/2006/main">
+            <a:off x="609600" y="6286500"/>
+            <a:ext cx="7953375" cy="238125"/>
+          </a:xfrm>
+          <a:prstGeom xmlns:a="http://schemas.openxmlformats.org/drawingml/2006/main" prst="rect">
+            <a:avLst/>
+          </a:prstGeom>
+          <a:noFill xmlns:a="http://schemas.openxmlformats.org/drawingml/2006/main"/>
+          <a:ln xmlns:a="http://schemas.openxmlformats.org/drawingml/2006/main" w="0">
+            <a:noFill/>
+          </a:ln>
+        </p:spPr>
+        <p:txBody>
+          <a:bodyPr xmlns:a="http://schemas.openxmlformats.org/drawingml/2006/main" wrap="square" lIns="0" tIns="0" rIns="0" bIns="0" anchor="t">
+            <a:noAutofit/>
+          </a:bodyPr>
+          <a:lstStyle xmlns:a="http://schemas.openxmlformats.org/drawingml/2006/main"/>
+          <a:p xmlns:a="http://schemas.openxmlformats.org/drawingml/2006/main">
+            <a:pPr>
+              <a:lnSpc>
+                <a:spcPct val="110000"/>
+              </a:lnSpc>
+              <a:buNone/>
+              <a:defRPr sz="1275" b="0">
+                <a:solidFill>
+                  <a:srgbClr val="58645D"/>
+                </a:solidFill>
+                <a:latin typeface="Helvetica Neue"/>
+                <a:ea typeface="Helvetica Neue"/>
+                <a:cs typeface="Helvetica Neue"/>
+              </a:defRPr>
+            </a:pPr>
+            <a:r>
+              <a:rPr sz="1275" b="0">
+                <a:solidFill>
+                  <a:srgbClr val="58645D"/>
+                </a:solidFill>
+                <a:latin typeface="Helvetica Neue"/>
+                <a:ea typeface="Helvetica Neue"/>
+                <a:cs typeface="Helvetica Neue"/>
+              </a:rPr>
+              <a:t>Earlier portfolio presentation, before visual case refinements</a:t>
+            </a:r>
+          </a:p>
+        </p:txBody>
+      </p:sp>
+      <p:sp>
+        <p:nvSpPr>
+          <p:cNvPr id="7" name="portfolio-case-background">
+            <a:extLst xmlns:a="http://schemas.openxmlformats.org/drawingml/2006/main">
+              <a:ext uri="{FF2B5EF4-FFF2-40B4-BE49-F238E27FC236}">
+                <a16:creationId xmlns:a16="http://schemas.microsoft.com/office/drawing/2014/main" id="{C5E11898-3FA2-4DF8-8273-3FC3E58AAA3F}"/>
+              </a:ext>
+            </a:extLst>
+          </p:cNvPr>
+          <p:cNvSpPr>
+            <a:spLocks xmlns:a="http://schemas.openxmlformats.org/drawingml/2006/main" noGrp="1"/>
+          </p:cNvSpPr>
+          <p:nvPr/>
+        </p:nvSpPr>
+        <p:spPr>
+          <a:xfrm xmlns:a="http://schemas.openxmlformats.org/drawingml/2006/main">
+            <a:off x="8810625" y="6153150"/>
+            <a:ext cx="2343150" cy="400050"/>
+          </a:xfrm>
+          <a:prstGeom xmlns:a="http://schemas.openxmlformats.org/drawingml/2006/main" prst="rect">
+            <a:avLst/>
+          </a:prstGeom>
+          <a:solidFill xmlns:a="http://schemas.openxmlformats.org/drawingml/2006/main">
+            <a:srgbClr val="244D3C"/>
+          </a:solidFill>
+          <a:ln xmlns:a="http://schemas.openxmlformats.org/drawingml/2006/main" w="0">
+            <a:noFill/>
+          </a:ln>
+        </p:spPr>
+      </p:sp>
+      <p:sp>
+        <p:nvSpPr>
+          <p:cNvPr id="8" name="portfolio-case-link">
+            <a:extLst xmlns:a="http://schemas.openxmlformats.org/drawingml/2006/main">
+              <a:ext uri="{FF2B5EF4-FFF2-40B4-BE49-F238E27FC236}">
+                <a16:creationId xmlns:a16="http://schemas.microsoft.com/office/drawing/2014/main" id="{298396DE-6596-4383-96F2-3427E7432033}"/>
+              </a:ext>
+            </a:extLst>
+          </p:cNvPr>
+          <p:cNvSpPr>
+            <a:spLocks xmlns:a="http://schemas.openxmlformats.org/drawingml/2006/main" noGrp="1"/>
+          </p:cNvSpPr>
+          <p:nvPr/>
+        </p:nvSpPr>
+        <p:spPr>
+          <a:xfrm xmlns:a="http://schemas.openxmlformats.org/drawingml/2006/main">
+            <a:off x="8963025" y="6229350"/>
+            <a:ext cx="2047875" cy="266700"/>
+          </a:xfrm>
+          <a:prstGeom xmlns:a="http://schemas.openxmlformats.org/drawingml/2006/main" prst="rect">
+            <a:avLst/>
+          </a:prstGeom>
+          <a:noFill xmlns:a="http://schemas.openxmlformats.org/drawingml/2006/main"/>
+          <a:ln xmlns:a="http://schemas.openxmlformats.org/drawingml/2006/main" w="0">
+            <a:noFill/>
+          </a:ln>
+        </p:spPr>
+        <p:txBody>
+          <a:bodyPr xmlns:a="http://schemas.openxmlformats.org/drawingml/2006/main" wrap="square" lIns="0" tIns="0" rIns="0" bIns="0" anchor="t">
+            <a:noAutofit/>
+          </a:bodyPr>
+          <a:lstStyle xmlns:a="http://schemas.openxmlformats.org/drawingml/2006/main"/>
+          <a:p xmlns:a="http://schemas.openxmlformats.org/drawingml/2006/main">
+            <a:pPr>
+              <a:lnSpc>
+                <a:spcPct val="110000"/>
+              </a:lnSpc>
+              <a:buNone/>
+              <a:defRPr sz="1350" b="0" u="sng">
+                <a:solidFill>
+                  <a:srgbClr val="DBEB89"/>
+                </a:solidFill>
+                <a:latin typeface="Helvetica Neue"/>
+                <a:ea typeface="Helvetica Neue"/>
+                <a:cs typeface="Helvetica Neue"/>
+              </a:defRPr>
+            </a:pPr>
+            <a:r>
+              <a:rPr sz="1350" b="0" u="sng">
+                <a:solidFill>
+                  <a:srgbClr val="DBEB89"/>
+                </a:solidFill>
+                <a:latin typeface="Helvetica Neue"/>
+                <a:ea typeface="Helvetica Neue"/>
+                <a:cs typeface="Helvetica Neue"/>
+                <a:hlinkClick xmlns:r="http://schemas.openxmlformats.org/officeDocument/2006/relationships" r:id="R51716a2dde574a9c"/>
+              </a:rPr>
+              <a:t>View the case →</a:t>
+            </a:r>
+          </a:p>
+        </p:txBody>
+      </p:sp>
+      <p:sp>
+        <p:nvSpPr>
+          <p:cNvPr id="9" name="slide-number">
+            <a:extLst xmlns:a="http://schemas.openxmlformats.org/drawingml/2006/main">
+              <a:ext uri="{FF2B5EF4-FFF2-40B4-BE49-F238E27FC236}">
+                <a16:creationId xmlns:a16="http://schemas.microsoft.com/office/drawing/2014/main" id="{538E74F8-F058-4368-9798-0108EF0362E5}"/>
+              </a:ext>
+            </a:extLst>
+          </p:cNvPr>
+          <p:cNvSpPr>
+            <a:spLocks xmlns:a="http://schemas.openxmlformats.org/drawingml/2006/main" noGrp="1"/>
+          </p:cNvSpPr>
+          <p:nvPr/>
+        </p:nvSpPr>
+        <p:spPr>
+          <a:xfrm xmlns:a="http://schemas.openxmlformats.org/drawingml/2006/main">
+            <a:off x="11353800" y="6562725"/>
+            <a:ext cx="323850" cy="190500"/>
+          </a:xfrm>
+          <a:prstGeom xmlns:a="http://schemas.openxmlformats.org/drawingml/2006/main" prst="rect">
+            <a:avLst/>
+          </a:prstGeom>
+          <a:noFill xmlns:a="http://schemas.openxmlformats.org/drawingml/2006/main"/>
+          <a:ln xmlns:a="http://schemas.openxmlformats.org/drawingml/2006/main" w="0">
+            <a:noFill/>
+          </a:ln>
+        </p:spPr>
+        <p:txBody>
+          <a:bodyPr xmlns:a="http://schemas.openxmlformats.org/drawingml/2006/main" wrap="square" lIns="0" tIns="0" rIns="0" bIns="0" anchor="t">
+            <a:noAutofit/>
+          </a:bodyPr>
+          <a:lstStyle xmlns:a="http://schemas.openxmlformats.org/drawingml/2006/main"/>
+          <a:p xmlns:a="http://schemas.openxmlformats.org/drawingml/2006/main">
+            <a:pPr>
+              <a:lnSpc>
+                <a:spcPct val="110000"/>
+              </a:lnSpc>
+              <a:buNone/>
+              <a:defRPr sz="1050" b="0">
+                <a:solidFill>
+                  <a:srgbClr val="58645D"/>
+                </a:solidFill>
+                <a:latin typeface="Helvetica Neue"/>
+                <a:ea typeface="Helvetica Neue"/>
+                <a:cs typeface="Helvetica Neue"/>
+              </a:defRPr>
+            </a:pPr>
+            <a:r>
+              <a:rPr sz="1050" b="0">
+                <a:solidFill>
+                  <a:srgbClr val="58645D"/>
+                </a:solidFill>
+                <a:latin typeface="Helvetica Neue"/>
+                <a:ea typeface="Helvetica Neue"/>
+                <a:cs typeface="Helvetica Neue"/>
+              </a:rPr>
+              <a:t>12</a:t>
+            </a:r>
+          </a:p>
+        </p:txBody>
+      </p:sp>
+    </p:spTree>
+    <p:extLst>
+      <p:ext uri="{BB962C8B-B14F-4D97-AF65-F5344CB8AC3E}">
+        <p14:creationId xmlns:p14="http://schemas.microsoft.com/office/powerpoint/2010/main" val="1987097151"/>
+      </p:ext>
+    </p:extLst>
+  </p:cSld>
+</p:sld>
+</file>
+
+<file path=ppt/slides/slide13.xml><?xml version="1.0" encoding="utf-8"?>
+<p:sld xmlns:p="http://schemas.openxmlformats.org/presentationml/2006/main">
+  <p:cSld>
+    <p:bg>
+      <p:bgPr>
+        <a:solidFill xmlns:a="http://schemas.openxmlformats.org/drawingml/2006/main">
+          <a:srgbClr val="F4F2E9"/>
+        </a:solidFill>
+      </p:bgPr>
+    </p:bg>
+    <p:spTree>
+      <p:nvGrpSpPr>
+        <p:cNvPr id="1" name=""/>
+        <p:cNvGrpSpPr/>
+        <p:nvPr/>
+      </p:nvGrpSpPr>
+      <p:grpSpPr>
+        <a:xfrm xmlns:a="http://schemas.openxmlformats.org/drawingml/2006/main"/>
+      </p:grpSpPr>
+      <p:sp>
+        <p:nvSpPr>
+          <p:cNvPr id="7" name="section-label">
+            <a:extLst xmlns:a="http://schemas.openxmlformats.org/drawingml/2006/main">
+              <a:ext uri="{FF2B5EF4-FFF2-40B4-BE49-F238E27FC236}">
+                <a16:creationId xmlns:a16="http://schemas.microsoft.com/office/drawing/2014/main" id="{1BA8870A-F13F-4FCC-845D-9D3854A18BFB}"/>
+              </a:ext>
+            </a:extLst>
+          </p:cNvPr>
+          <p:cNvSpPr>
+            <a:spLocks xmlns:a="http://schemas.openxmlformats.org/drawingml/2006/main" noGrp="1"/>
+          </p:cNvSpPr>
+          <p:nvPr/>
+        </p:nvSpPr>
+        <p:spPr>
+          <a:xfrm xmlns:a="http://schemas.openxmlformats.org/drawingml/2006/main">
+            <a:off x="609600" y="514350"/>
+            <a:ext cx="6477000" cy="266700"/>
+          </a:xfrm>
+          <a:prstGeom xmlns:a="http://schemas.openxmlformats.org/drawingml/2006/main" prst="rect">
+            <a:avLst/>
+          </a:prstGeom>
+          <a:noFill xmlns:a="http://schemas.openxmlformats.org/drawingml/2006/main"/>
+          <a:ln xmlns:a="http://schemas.openxmlformats.org/drawingml/2006/main" w="0">
+            <a:noFill/>
+          </a:ln>
+        </p:spPr>
+        <p:txBody>
+          <a:bodyPr xmlns:a="http://schemas.openxmlformats.org/drawingml/2006/main" wrap="square" lIns="0" tIns="0" rIns="0" bIns="0" anchor="t">
+            <a:noAutofit/>
+          </a:bodyPr>
+          <a:lstStyle xmlns:a="http://schemas.openxmlformats.org/drawingml/2006/main"/>
+          <a:p xmlns:a="http://schemas.openxmlformats.org/drawingml/2006/main">
+            <a:pPr>
+              <a:lnSpc>
+                <a:spcPct val="110000"/>
+              </a:lnSpc>
+              <a:buNone/>
+              <a:defRPr sz="1200" b="1">
+                <a:solidFill>
+                  <a:srgbClr val="244D3C"/>
+                </a:solidFill>
+                <a:latin typeface="Helvetica Neue"/>
+                <a:ea typeface="Helvetica Neue"/>
+                <a:cs typeface="Helvetica Neue"/>
+              </a:defRPr>
+            </a:pPr>
+            <a:r>
+              <a:rPr sz="1200" b="1">
+                <a:solidFill>
+                  <a:srgbClr val="244D3C"/>
+                </a:solidFill>
+                <a:latin typeface="Helvetica Neue"/>
+                <a:ea typeface="Helvetica Neue"/>
+                <a:cs typeface="Helvetica Neue"/>
+              </a:rPr>
+              <a:t>THE THREAD THROUGH MY WORK</a:t>
+            </a:r>
+          </a:p>
+        </p:txBody>
+      </p:sp>
+      <p:sp>
+        <p:nvSpPr>
+          <p:cNvPr id="2" name="headline">
+            <a:extLst xmlns:a="http://schemas.openxmlformats.org/drawingml/2006/main">
+              <a:ext uri="{FF2B5EF4-FFF2-40B4-BE49-F238E27FC236}">
+                <a16:creationId xmlns:a16="http://schemas.microsoft.com/office/drawing/2014/main" id="{8F5075C9-9172-4EE3-B46C-4E4D3A4A1A7B}"/>
+              </a:ext>
+            </a:extLst>
+          </p:cNvPr>
+          <p:cNvSpPr>
+            <a:spLocks xmlns:a="http://schemas.openxmlformats.org/drawingml/2006/main" noGrp="1"/>
+          </p:cNvSpPr>
+          <p:nvPr/>
+        </p:nvSpPr>
+        <p:spPr>
+          <a:xfrm xmlns:a="http://schemas.openxmlformats.org/drawingml/2006/main">
+            <a:off x="609600" y="1352550"/>
+            <a:ext cx="5905500" cy="1485900"/>
+          </a:xfrm>
+          <a:prstGeom xmlns:a="http://schemas.openxmlformats.org/drawingml/2006/main" prst="rect">
+            <a:avLst/>
+          </a:prstGeom>
+          <a:noFill xmlns:a="http://schemas.openxmlformats.org/drawingml/2006/main"/>
+          <a:ln xmlns:a="http://schemas.openxmlformats.org/drawingml/2006/main" w="0">
+            <a:noFill/>
+          </a:ln>
+        </p:spPr>
+        <p:txBody>
+          <a:bodyPr xmlns:a="http://schemas.openxmlformats.org/drawingml/2006/main" wrap="square" lIns="0" tIns="0" rIns="0" bIns="0" anchor="t">
+            <a:noAutofit/>
+          </a:bodyPr>
+          <a:lstStyle xmlns:a="http://schemas.openxmlformats.org/drawingml/2006/main"/>
+          <a:p xmlns:a="http://schemas.openxmlformats.org/drawingml/2006/main">
+            <a:pPr>
+              <a:lnSpc>
+                <a:spcPct val="110000"/>
+              </a:lnSpc>
+              <a:buNone/>
+              <a:defRPr sz="3750" b="1">
+                <a:solidFill>
+                  <a:srgbClr val="192B25"/>
+                </a:solidFill>
+                <a:latin typeface="Helvetica Neue"/>
+                <a:ea typeface="Helvetica Neue"/>
+                <a:cs typeface="Helvetica Neue"/>
+              </a:defRPr>
+            </a:pPr>
+            <a:r>
+              <a:rPr sz="3750" b="1">
+                <a:solidFill>
+                  <a:srgbClr val="192B25"/>
+                </a:solidFill>
+                <a:latin typeface="Helvetica Neue"/>
+                <a:ea typeface="Helvetica Neue"/>
+                <a:cs typeface="Helvetica Neue"/>
+              </a:rPr>
+              <a:t>The person using</a:t>
+            </a:r>
+          </a:p>
+          <a:p xmlns:a="http://schemas.openxmlformats.org/drawingml/2006/main">
+            <a:pPr>
+              <a:lnSpc>
+                <a:spcPct val="110000"/>
+              </a:lnSpc>
+              <a:buNone/>
+              <a:defRPr sz="3750" b="1">
+                <a:solidFill>
+                  <a:srgbClr val="192B25"/>
+                </a:solidFill>
+                <a:latin typeface="Helvetica Neue"/>
+                <a:ea typeface="Helvetica Neue"/>
+                <a:cs typeface="Helvetica Neue"/>
+              </a:defRPr>
+            </a:pPr>
+            <a:r>
+              <a:rPr sz="3750" b="1">
+                <a:solidFill>
+                  <a:srgbClr val="192B25"/>
+                </a:solidFill>
+                <a:latin typeface="Helvetica Neue"/>
+                <a:ea typeface="Helvetica Neue"/>
+                <a:cs typeface="Helvetica Neue"/>
+              </a:rPr>
+              <a:t>the system matters</a:t>
+            </a:r>
+          </a:p>
+        </p:txBody>
+      </p:sp>
+      <p:sp>
+        <p:nvSpPr>
+          <p:cNvPr id="3" name="story-origin">
+            <a:extLst xmlns:a="http://schemas.openxmlformats.org/drawingml/2006/main">
+              <a:ext uri="{FF2B5EF4-FFF2-40B4-BE49-F238E27FC236}">
+                <a16:creationId xmlns:a16="http://schemas.microsoft.com/office/drawing/2014/main" id="{80CCEC20-355A-4E8B-B128-94352A735333}"/>
+              </a:ext>
+            </a:extLst>
+          </p:cNvPr>
+          <p:cNvSpPr>
+            <a:spLocks xmlns:a="http://schemas.openxmlformats.org/drawingml/2006/main" noGrp="1"/>
+          </p:cNvSpPr>
+          <p:nvPr/>
+        </p:nvSpPr>
+        <p:spPr>
+          <a:xfrm xmlns:a="http://schemas.openxmlformats.org/drawingml/2006/main">
+            <a:off x="609600" y="3333750"/>
+            <a:ext cx="5572125" cy="1228725"/>
+          </a:xfrm>
+          <a:prstGeom xmlns:a="http://schemas.openxmlformats.org/drawingml/2006/main" prst="rect">
+            <a:avLst/>
+          </a:prstGeom>
+          <a:noFill xmlns:a="http://schemas.openxmlformats.org/drawingml/2006/main"/>
+          <a:ln xmlns:a="http://schemas.openxmlformats.org/drawingml/2006/main" w="0">
+            <a:noFill/>
+          </a:ln>
+        </p:spPr>
+        <p:txBody>
+          <a:bodyPr xmlns:a="http://schemas.openxmlformats.org/drawingml/2006/main" wrap="square" lIns="0" tIns="0" rIns="0" bIns="0" anchor="t">
+            <a:noAutofit/>
+          </a:bodyPr>
+          <a:lstStyle xmlns:a="http://schemas.openxmlformats.org/drawingml/2006/main"/>
+          <a:p xmlns:a="http://schemas.openxmlformats.org/drawingml/2006/main">
+            <a:pPr>
+              <a:lnSpc>
+                <a:spcPct val="110000"/>
+              </a:lnSpc>
+              <a:buNone/>
+              <a:defRPr sz="1950" b="0">
+                <a:solidFill>
+                  <a:srgbClr val="192B25"/>
+                </a:solidFill>
+                <a:latin typeface="Helvetica Neue"/>
+                <a:ea typeface="Helvetica Neue"/>
+                <a:cs typeface="Helvetica Neue"/>
+              </a:defRPr>
+            </a:pPr>
+            <a:r>
+              <a:rPr sz="1950" b="0">
+                <a:solidFill>
+                  <a:srgbClr val="192B25"/>
+                </a:solidFill>
+                <a:latin typeface="Helvetica Neue"/>
+                <a:ea typeface="Helvetica Neue"/>
+                <a:cs typeface="Helvetica Neue"/>
+              </a:rPr>
+              <a:t>Documentary filmmaking taught me to listen closely. Learning design taught me to make the next step teachable.</a:t>
+            </a:r>
+          </a:p>
+        </p:txBody>
+      </p:sp>
+      <p:sp>
+        <p:nvSpPr>
+          <p:cNvPr id="4" name="story-ai">
+            <a:extLst xmlns:a="http://schemas.openxmlformats.org/drawingml/2006/main">
+              <a:ext uri="{FF2B5EF4-FFF2-40B4-BE49-F238E27FC236}">
+                <a16:creationId xmlns:a16="http://schemas.microsoft.com/office/drawing/2014/main" id="{13339B96-0F64-48C8-B6D0-1029401FD7F1}"/>
+              </a:ext>
+            </a:extLst>
+          </p:cNvPr>
+          <p:cNvSpPr>
+            <a:spLocks xmlns:a="http://schemas.openxmlformats.org/drawingml/2006/main" noGrp="1"/>
+          </p:cNvSpPr>
+          <p:nvPr/>
+        </p:nvSpPr>
+        <p:spPr>
+          <a:xfrm xmlns:a="http://schemas.openxmlformats.org/drawingml/2006/main">
+            <a:off x="609600" y="4953000"/>
+            <a:ext cx="5572125" cy="1209675"/>
+          </a:xfrm>
+          <a:prstGeom xmlns:a="http://schemas.openxmlformats.org/drawingml/2006/main" prst="rect">
+            <a:avLst/>
+          </a:prstGeom>
+          <a:noFill xmlns:a="http://schemas.openxmlformats.org/drawingml/2006/main"/>
+          <a:ln xmlns:a="http://schemas.openxmlformats.org/drawingml/2006/main" w="0">
+            <a:noFill/>
+          </a:ln>
+        </p:spPr>
+        <p:txBody>
+          <a:bodyPr xmlns:a="http://schemas.openxmlformats.org/drawingml/2006/main" wrap="square" lIns="0" tIns="0" rIns="0" bIns="0" anchor="t">
+            <a:noAutofit/>
+          </a:bodyPr>
+          <a:lstStyle xmlns:a="http://schemas.openxmlformats.org/drawingml/2006/main"/>
+          <a:p xmlns:a="http://schemas.openxmlformats.org/drawingml/2006/main">
+            <a:pPr>
+              <a:lnSpc>
+                <a:spcPct val="110000"/>
+              </a:lnSpc>
+              <a:buNone/>
+              <a:defRPr sz="1800" b="0">
+                <a:solidFill>
+                  <a:srgbClr val="58645D"/>
+                </a:solidFill>
+                <a:latin typeface="Helvetica Neue"/>
+                <a:ea typeface="Helvetica Neue"/>
+                <a:cs typeface="Helvetica Neue"/>
+              </a:defRPr>
+            </a:pPr>
+            <a:r>
+              <a:rPr sz="1800" b="0">
+                <a:solidFill>
+                  <a:srgbClr val="58645D"/>
+                </a:solidFill>
+                <a:latin typeface="Helvetica Neue"/>
+                <a:ea typeface="Helvetica Neue"/>
+                <a:cs typeface="Helvetica Neue"/>
+              </a:rPr>
+              <a:t>That perspective carries into my AI work: understand the task, make the output inspectable, and leave room for human judgment.</a:t>
+            </a:r>
+          </a:p>
+        </p:txBody>
+      </p:sp>
+      <p:pic>
+        <p:nvPicPr>
+          <p:cNvPr id="11" name=""/>
+          <p:cNvPicPr>
+            <a:picLocks xmlns:a="http://schemas.openxmlformats.org/drawingml/2006/main" noChangeAspect="1"/>
+          </p:cNvPicPr>
+          <p:nvPr/>
+        </p:nvPicPr>
+        <p:blipFill>
+          <a:blip xmlns:r="http://schemas.openxmlformats.org/officeDocument/2006/relationships" xmlns:a="http://schemas.openxmlformats.org/drawingml/2006/main" r:embed="R1d2bf517d34b42d1"/>
+          <a:stretch xmlns:a="http://schemas.openxmlformats.org/drawingml/2006/main"/>
+        </p:blipFill>
+        <p:spPr>
+          <a:xfrm xmlns:a="http://schemas.openxmlformats.org/drawingml/2006/main">
+            <a:off x="7010400" y="1447800"/>
+            <a:ext cx="4876800" cy="4876800"/>
+          </a:xfrm>
+          <a:prstGeom xmlns:a="http://schemas.openxmlformats.org/drawingml/2006/main" prst="rect">
+            <a:avLst/>
+          </a:prstGeom>
+        </p:spPr>
+      </p:pic>
+      <p:sp>
+        <p:nvSpPr>
+          <p:cNvPr id="6" name="slide-number">
+            <a:extLst xmlns:a="http://schemas.openxmlformats.org/drawingml/2006/main">
+              <a:ext uri="{FF2B5EF4-FFF2-40B4-BE49-F238E27FC236}">
+                <a16:creationId xmlns:a16="http://schemas.microsoft.com/office/drawing/2014/main" id="{6670C944-B77D-4769-ADF0-C2EBA6288E10}"/>
+              </a:ext>
+            </a:extLst>
+          </p:cNvPr>
+          <p:cNvSpPr>
+            <a:spLocks xmlns:a="http://schemas.openxmlformats.org/drawingml/2006/main" noGrp="1"/>
+          </p:cNvSpPr>
+          <p:nvPr/>
+        </p:nvSpPr>
+        <p:spPr>
+          <a:xfrm xmlns:a="http://schemas.openxmlformats.org/drawingml/2006/main">
+            <a:off x="11353800" y="6562725"/>
+            <a:ext cx="323850" cy="190500"/>
+          </a:xfrm>
+          <a:prstGeom xmlns:a="http://schemas.openxmlformats.org/drawingml/2006/main" prst="rect">
+            <a:avLst/>
+          </a:prstGeom>
+          <a:noFill xmlns:a="http://schemas.openxmlformats.org/drawingml/2006/main"/>
+          <a:ln xmlns:a="http://schemas.openxmlformats.org/drawingml/2006/main" w="0">
+            <a:noFill/>
+          </a:ln>
+        </p:spPr>
+        <p:txBody>
+          <a:bodyPr xmlns:a="http://schemas.openxmlformats.org/drawingml/2006/main" wrap="square" lIns="0" tIns="0" rIns="0" bIns="0" anchor="t">
+            <a:noAutofit/>
+          </a:bodyPr>
+          <a:lstStyle xmlns:a="http://schemas.openxmlformats.org/drawingml/2006/main"/>
+          <a:p xmlns:a="http://schemas.openxmlformats.org/drawingml/2006/main">
+            <a:pPr>
+              <a:lnSpc>
+                <a:spcPct val="110000"/>
+              </a:lnSpc>
+              <a:buNone/>
+              <a:defRPr sz="1050" b="0">
+                <a:solidFill>
+                  <a:srgbClr val="58645D"/>
+                </a:solidFill>
+                <a:latin typeface="Helvetica Neue"/>
+                <a:ea typeface="Helvetica Neue"/>
+                <a:cs typeface="Helvetica Neue"/>
+              </a:defRPr>
+            </a:pPr>
+            <a:r>
+              <a:rPr sz="1050" b="0">
+                <a:solidFill>
+                  <a:srgbClr val="58645D"/>
+                </a:solidFill>
+                <a:latin typeface="Helvetica Neue"/>
+                <a:ea typeface="Helvetica Neue"/>
+                <a:cs typeface="Helvetica Neue"/>
+              </a:rPr>
+              <a:t>13</a:t>
+            </a:r>
+          </a:p>
+        </p:txBody>
+      </p:sp>
+    </p:spTree>
+    <p:extLst>
+      <p:ext uri="{BB962C8B-B14F-4D97-AF65-F5344CB8AC3E}">
+        <p14:creationId xmlns:p14="http://schemas.microsoft.com/office/powerpoint/2010/main" val="1759730857"/>
+      </p:ext>
+    </p:extLst>
+  </p:cSld>
+</p:sld>
+</file>
+
+<file path=ppt/slides/slide14.xml><?xml version="1.0" encoding="utf-8"?>
 <p:sld xmlns:p="http://schemas.openxmlformats.org/presentationml/2006/main">
   <p:cSld>
     <p:bg>
@@ -2618,7 +4225,7 @@
           <p:cNvPr id="7" name="section-label">
             <a:extLst xmlns:a="http://schemas.openxmlformats.org/drawingml/2006/main">
               <a:ext uri="{FF2B5EF4-FFF2-40B4-BE49-F238E27FC236}">
-                <a16:creationId xmlns:a16="http://schemas.microsoft.com/office/drawing/2014/main" id="{064AA452-B3A1-45C1-B33A-80804B0B2385}"/>
+                <a16:creationId xmlns:a16="http://schemas.microsoft.com/office/drawing/2014/main" id="{BDA9708C-4932-404C-9507-DF6B5FB74FBB}"/>
               </a:ext>
             </a:extLst>
           </p:cNvPr>
@@ -2679,7 +4286,7 @@
           <p:cNvPr id="2" name="headline">
             <a:extLst xmlns:a="http://schemas.openxmlformats.org/drawingml/2006/main">
               <a:ext uri="{FF2B5EF4-FFF2-40B4-BE49-F238E27FC236}">
-                <a16:creationId xmlns:a16="http://schemas.microsoft.com/office/drawing/2014/main" id="{FEFDF4CC-AA26-4A12-887C-D36F36D7E6F9}"/>
+                <a16:creationId xmlns:a16="http://schemas.microsoft.com/office/drawing/2014/main" id="{ACC25B1B-7F99-4B79-AF3C-5C9A5A191858}"/>
               </a:ext>
             </a:extLst>
           </p:cNvPr>
@@ -2767,7 +4374,7 @@
           <p:cNvPr id="3" name="contact-intent">
             <a:extLst xmlns:a="http://schemas.openxmlformats.org/drawingml/2006/main">
               <a:ext uri="{FF2B5EF4-FFF2-40B4-BE49-F238E27FC236}">
-                <a16:creationId xmlns:a16="http://schemas.microsoft.com/office/drawing/2014/main" id="{4C469B6F-6E36-4606-A85B-7F2040E3A803}"/>
+                <a16:creationId xmlns:a16="http://schemas.microsoft.com/office/drawing/2014/main" id="{FAF73A0C-8363-474E-909D-FFF1D0C5CB11}"/>
               </a:ext>
             </a:extLst>
           </p:cNvPr>
@@ -2828,7 +4435,7 @@
           <p:cNvPr id="4" name="email">
             <a:extLst xmlns:a="http://schemas.openxmlformats.org/drawingml/2006/main">
               <a:ext uri="{FF2B5EF4-FFF2-40B4-BE49-F238E27FC236}">
-                <a16:creationId xmlns:a16="http://schemas.microsoft.com/office/drawing/2014/main" id="{60D67BDC-DD06-4E54-A0B0-EB8F31EEEE08}"/>
+                <a16:creationId xmlns:a16="http://schemas.microsoft.com/office/drawing/2014/main" id="{83D9BAC1-5172-4D39-B242-12623F600F5B}"/>
               </a:ext>
             </a:extLst>
           </p:cNvPr>
@@ -2878,7 +4485,7 @@
                 <a:latin typeface="Helvetica Neue"/>
                 <a:ea typeface="Helvetica Neue"/>
                 <a:cs typeface="Helvetica Neue"/>
-                <a:hlinkClick xmlns:r="http://schemas.openxmlformats.org/officeDocument/2006/relationships" r:id="Rce14a096a3a84c88"/>
+                <a:hlinkClick xmlns:r="http://schemas.openxmlformats.org/officeDocument/2006/relationships" r:id="Raf1ccf5bd02c4ec3"/>
               </a:rPr>
               <a:t>JonathanKyleHobson@gmail.com</a:t>
             </a:r>
@@ -2890,7 +4497,7 @@
           <p:cNvPr id="5" name="portfolio">
             <a:extLst xmlns:a="http://schemas.openxmlformats.org/drawingml/2006/main">
               <a:ext uri="{FF2B5EF4-FFF2-40B4-BE49-F238E27FC236}">
-                <a16:creationId xmlns:a16="http://schemas.microsoft.com/office/drawing/2014/main" id="{06719078-8FA9-48B1-A636-4A9227900AC2}"/>
+                <a16:creationId xmlns:a16="http://schemas.microsoft.com/office/drawing/2014/main" id="{4AEE9D05-6F4E-415A-9ED1-5BA804434144}"/>
               </a:ext>
             </a:extLst>
           </p:cNvPr>
@@ -2940,7 +4547,7 @@
                 <a:latin typeface="Helvetica Neue"/>
                 <a:ea typeface="Helvetica Neue"/>
                 <a:cs typeface="Helvetica Neue"/>
-                <a:hlinkClick xmlns:r="http://schemas.openxmlformats.org/officeDocument/2006/relationships" r:id="R85cb4237f8d043f9"/>
+                <a:hlinkClick xmlns:r="http://schemas.openxmlformats.org/officeDocument/2006/relationships" r:id="Ra0564cf1ec3046fa"/>
               </a:rPr>
               <a:t>jonathankhobson.github.io/portfolio/ai</a:t>
             </a:r>
@@ -2952,7 +4559,7 @@
           <p:cNvPr id="6" name="slide-number">
             <a:extLst xmlns:a="http://schemas.openxmlformats.org/drawingml/2006/main">
               <a:ext uri="{FF2B5EF4-FFF2-40B4-BE49-F238E27FC236}">
-                <a16:creationId xmlns:a16="http://schemas.microsoft.com/office/drawing/2014/main" id="{03FEE3ED-84E0-42A5-ACC0-6B2ADAB464C9}"/>
+                <a16:creationId xmlns:a16="http://schemas.microsoft.com/office/drawing/2014/main" id="{E5C78305-7E95-417D-B09B-C1620ED7C91A}"/>
               </a:ext>
             </a:extLst>
           </p:cNvPr>
@@ -3003,7 +4610,7 @@
                 <a:ea typeface="Helvetica Neue"/>
                 <a:cs typeface="Helvetica Neue"/>
               </a:rPr>
-              <a:t>11</a:t>
+              <a:t>14</a:t>
             </a:r>
           </a:p>
         </p:txBody>
@@ -3011,7 +4618,7 @@
     </p:spTree>
     <p:extLst>
       <p:ext uri="{BB962C8B-B14F-4D97-AF65-F5344CB8AC3E}">
-        <p14:creationId xmlns:p14="http://schemas.microsoft.com/office/powerpoint/2010/main" val="1497661228"/>
+        <p14:creationId xmlns:p14="http://schemas.microsoft.com/office/powerpoint/2010/main" val="1532696714"/>
       </p:ext>
     </p:extLst>
   </p:cSld>
@@ -3042,7 +4649,7 @@
           <p:cNvPr id="7" name="section-label">
             <a:extLst xmlns:a="http://schemas.openxmlformats.org/drawingml/2006/main">
               <a:ext uri="{FF2B5EF4-FFF2-40B4-BE49-F238E27FC236}">
-                <a16:creationId xmlns:a16="http://schemas.microsoft.com/office/drawing/2014/main" id="{26E54458-2BE8-4898-8CFF-A22AEF608A6D}"/>
+                <a16:creationId xmlns:a16="http://schemas.microsoft.com/office/drawing/2014/main" id="{A1D516BF-B4C8-42F8-A9ED-EB07074B3ADE}"/>
               </a:ext>
             </a:extLst>
           </p:cNvPr>
@@ -3103,7 +4710,7 @@
           <p:cNvPr id="2" name="headline">
             <a:extLst xmlns:a="http://schemas.openxmlformats.org/drawingml/2006/main">
               <a:ext uri="{FF2B5EF4-FFF2-40B4-BE49-F238E27FC236}">
-                <a16:creationId xmlns:a16="http://schemas.microsoft.com/office/drawing/2014/main" id="{9E5151BE-665E-4BAD-9795-2564A4BC7465}"/>
+                <a16:creationId xmlns:a16="http://schemas.microsoft.com/office/drawing/2014/main" id="{12F36C93-83C7-4757-892A-2EA5E3FAD38E}"/>
               </a:ext>
             </a:extLst>
           </p:cNvPr>
@@ -3164,7 +4771,7 @@
           <p:cNvPr id="3" name="prompt-purpose">
             <a:extLst xmlns:a="http://schemas.openxmlformats.org/drawingml/2006/main">
               <a:ext uri="{FF2B5EF4-FFF2-40B4-BE49-F238E27FC236}">
-                <a16:creationId xmlns:a16="http://schemas.microsoft.com/office/drawing/2014/main" id="{EAEB4DFC-9912-48F3-BF5C-AE61997804FE}"/>
+                <a16:creationId xmlns:a16="http://schemas.microsoft.com/office/drawing/2014/main" id="{22B9850A-8B69-417A-AC83-2781A24F6BFD}"/>
               </a:ext>
             </a:extLst>
           </p:cNvPr>
@@ -3229,7 +4836,7 @@
           <p:nvPr/>
         </p:nvPicPr>
         <p:blipFill>
-          <a:blip xmlns:r="http://schemas.openxmlformats.org/officeDocument/2006/relationships" xmlns:a="http://schemas.openxmlformats.org/drawingml/2006/main" r:embed="R8e0b6c7d72a9476d"/>
+          <a:blip xmlns:r="http://schemas.openxmlformats.org/officeDocument/2006/relationships" xmlns:a="http://schemas.openxmlformats.org/drawingml/2006/main" r:embed="R93e3d5608b454141"/>
           <a:stretch xmlns:a="http://schemas.openxmlformats.org/drawingml/2006/main"/>
         </p:blipFill>
         <p:spPr>
@@ -3247,7 +4854,7 @@
           <p:cNvPr id="5" name="prompt-status">
             <a:extLst xmlns:a="http://schemas.openxmlformats.org/drawingml/2006/main">
               <a:ext uri="{FF2B5EF4-FFF2-40B4-BE49-F238E27FC236}">
-                <a16:creationId xmlns:a16="http://schemas.microsoft.com/office/drawing/2014/main" id="{B39D5680-D880-4BEC-9F96-B131B8B4EB95}"/>
+                <a16:creationId xmlns:a16="http://schemas.microsoft.com/office/drawing/2014/main" id="{06D0F797-5B68-4B78-A635-BBD4B2F52053}"/>
               </a:ext>
             </a:extLst>
           </p:cNvPr>
@@ -3308,7 +4915,7 @@
           <p:cNvPr id="6" name="slide-number">
             <a:extLst xmlns:a="http://schemas.openxmlformats.org/drawingml/2006/main">
               <a:ext uri="{FF2B5EF4-FFF2-40B4-BE49-F238E27FC236}">
-                <a16:creationId xmlns:a16="http://schemas.microsoft.com/office/drawing/2014/main" id="{F1B088F8-0046-48C7-ACC7-6157BD713878}"/>
+                <a16:creationId xmlns:a16="http://schemas.microsoft.com/office/drawing/2014/main" id="{811376AF-5AAA-448B-9C24-B9176C80AA8A}"/>
               </a:ext>
             </a:extLst>
           </p:cNvPr>
@@ -3367,7 +4974,7 @@
     </p:spTree>
     <p:extLst>
       <p:ext uri="{BB962C8B-B14F-4D97-AF65-F5344CB8AC3E}">
-        <p14:creationId xmlns:p14="http://schemas.microsoft.com/office/powerpoint/2010/main" val="2097708785"/>
+        <p14:creationId xmlns:p14="http://schemas.microsoft.com/office/powerpoint/2010/main" val="1429300355"/>
       </p:ext>
     </p:extLst>
   </p:cSld>
@@ -3398,7 +5005,7 @@
           <p:cNvPr id="10" name="section-label">
             <a:extLst xmlns:a="http://schemas.openxmlformats.org/drawingml/2006/main">
               <a:ext uri="{FF2B5EF4-FFF2-40B4-BE49-F238E27FC236}">
-                <a16:creationId xmlns:a16="http://schemas.microsoft.com/office/drawing/2014/main" id="{EBE9BA27-0EB0-413E-86DF-FFB674E45928}"/>
+                <a16:creationId xmlns:a16="http://schemas.microsoft.com/office/drawing/2014/main" id="{A137F959-6269-4C6E-9719-E81FD78D35A8}"/>
               </a:ext>
             </a:extLst>
           </p:cNvPr>
@@ -3459,7 +5066,7 @@
           <p:cNvPr id="2" name="headline">
             <a:extLst xmlns:a="http://schemas.openxmlformats.org/drawingml/2006/main">
               <a:ext uri="{FF2B5EF4-FFF2-40B4-BE49-F238E27FC236}">
-                <a16:creationId xmlns:a16="http://schemas.microsoft.com/office/drawing/2014/main" id="{677AD72D-5E51-4B27-B79D-19E173FC070D}"/>
+                <a16:creationId xmlns:a16="http://schemas.microsoft.com/office/drawing/2014/main" id="{3C260FCB-3635-485F-8612-7A69A5E28879}"/>
               </a:ext>
             </a:extLst>
           </p:cNvPr>
@@ -3520,7 +5127,7 @@
           <p:cNvPr id="3" name="before-label">
             <a:extLst xmlns:a="http://schemas.openxmlformats.org/drawingml/2006/main">
               <a:ext uri="{FF2B5EF4-FFF2-40B4-BE49-F238E27FC236}">
-                <a16:creationId xmlns:a16="http://schemas.microsoft.com/office/drawing/2014/main" id="{2D141EB0-C214-4785-8024-CF7BD7E29513}"/>
+                <a16:creationId xmlns:a16="http://schemas.microsoft.com/office/drawing/2014/main" id="{2BB8EB5E-1E56-49CD-B596-892CE238C0E2}"/>
               </a:ext>
             </a:extLst>
           </p:cNvPr>
@@ -3581,7 +5188,7 @@
           <p:cNvPr id="4" name="after-label">
             <a:extLst xmlns:a="http://schemas.openxmlformats.org/drawingml/2006/main">
               <a:ext uri="{FF2B5EF4-FFF2-40B4-BE49-F238E27FC236}">
-                <a16:creationId xmlns:a16="http://schemas.microsoft.com/office/drawing/2014/main" id="{4B8A99CD-C311-4AFC-A510-855F958AF88B}"/>
+                <a16:creationId xmlns:a16="http://schemas.microsoft.com/office/drawing/2014/main" id="{8FB1E23A-ACE5-4F0A-B06D-0A3A1805F47C}"/>
               </a:ext>
             </a:extLst>
           </p:cNvPr>
@@ -3642,7 +5249,7 @@
           <p:cNvPr id="5" name="before-prompt">
             <a:extLst xmlns:a="http://schemas.openxmlformats.org/drawingml/2006/main">
               <a:ext uri="{FF2B5EF4-FFF2-40B4-BE49-F238E27FC236}">
-                <a16:creationId xmlns:a16="http://schemas.microsoft.com/office/drawing/2014/main" id="{EE4D86B3-CD16-4EA3-BB8A-E2C518A4E9D3}"/>
+                <a16:creationId xmlns:a16="http://schemas.microsoft.com/office/drawing/2014/main" id="{26F89521-0B9F-436F-9F89-5E234A5BF5E8}"/>
               </a:ext>
             </a:extLst>
           </p:cNvPr>
@@ -3703,7 +5310,7 @@
           <p:cNvPr id="6" name="after-prompt">
             <a:extLst xmlns:a="http://schemas.openxmlformats.org/drawingml/2006/main">
               <a:ext uri="{FF2B5EF4-FFF2-40B4-BE49-F238E27FC236}">
-                <a16:creationId xmlns:a16="http://schemas.microsoft.com/office/drawing/2014/main" id="{F970F969-5663-4C36-AFA0-D2EB65D75BC1}"/>
+                <a16:creationId xmlns:a16="http://schemas.microsoft.com/office/drawing/2014/main" id="{6A7B903B-2C87-4408-99EF-7631C1494A2B}"/>
               </a:ext>
             </a:extLst>
           </p:cNvPr>
@@ -3764,7 +5371,7 @@
           <p:cNvPr id="7" name="expected-winner">
             <a:extLst xmlns:a="http://schemas.openxmlformats.org/drawingml/2006/main">
               <a:ext uri="{FF2B5EF4-FFF2-40B4-BE49-F238E27FC236}">
-                <a16:creationId xmlns:a16="http://schemas.microsoft.com/office/drawing/2014/main" id="{AA7B7648-9534-4C20-AC57-193C8C34D9A9}"/>
+                <a16:creationId xmlns:a16="http://schemas.microsoft.com/office/drawing/2014/main" id="{BAAD91CC-FECF-4225-A439-48D3CEA79355}"/>
               </a:ext>
             </a:extLst>
           </p:cNvPr>
@@ -3825,7 +5432,7 @@
           <p:cNvPr id="8" name="fixture-reason">
             <a:extLst xmlns:a="http://schemas.openxmlformats.org/drawingml/2006/main">
               <a:ext uri="{FF2B5EF4-FFF2-40B4-BE49-F238E27FC236}">
-                <a16:creationId xmlns:a16="http://schemas.microsoft.com/office/drawing/2014/main" id="{DF5E24F5-A7C5-414E-8EB3-92E26F0C0CB9}"/>
+                <a16:creationId xmlns:a16="http://schemas.microsoft.com/office/drawing/2014/main" id="{3D8E55BB-4A87-4953-8E8F-3BDCC11111FC}"/>
               </a:ext>
             </a:extLst>
           </p:cNvPr>
@@ -3886,7 +5493,7 @@
           <p:cNvPr id="9" name="slide-number">
             <a:extLst xmlns:a="http://schemas.openxmlformats.org/drawingml/2006/main">
               <a:ext uri="{FF2B5EF4-FFF2-40B4-BE49-F238E27FC236}">
-                <a16:creationId xmlns:a16="http://schemas.microsoft.com/office/drawing/2014/main" id="{CC9BBCD8-2018-4512-9645-B7C65537108F}"/>
+                <a16:creationId xmlns:a16="http://schemas.microsoft.com/office/drawing/2014/main" id="{222C6693-6C0A-4EE1-B43D-8F5FA01EB9B7}"/>
               </a:ext>
             </a:extLst>
           </p:cNvPr>
@@ -3945,7 +5552,7 @@
     </p:spTree>
     <p:extLst>
       <p:ext uri="{BB962C8B-B14F-4D97-AF65-F5344CB8AC3E}">
-        <p14:creationId xmlns:p14="http://schemas.microsoft.com/office/powerpoint/2010/main" val="1841116108"/>
+        <p14:creationId xmlns:p14="http://schemas.microsoft.com/office/powerpoint/2010/main" val="2127500150"/>
       </p:ext>
     </p:extLst>
   </p:cSld>
@@ -3976,7 +5583,7 @@
           <p:cNvPr id="8" name="section-label">
             <a:extLst xmlns:a="http://schemas.openxmlformats.org/drawingml/2006/main">
               <a:ext uri="{FF2B5EF4-FFF2-40B4-BE49-F238E27FC236}">
-                <a16:creationId xmlns:a16="http://schemas.microsoft.com/office/drawing/2014/main" id="{D4B79198-4C29-4B3C-B83E-CF58F560EB94}"/>
+                <a16:creationId xmlns:a16="http://schemas.microsoft.com/office/drawing/2014/main" id="{1DC0F625-63C6-42DD-8016-8A25B99EEB58}"/>
               </a:ext>
             </a:extLst>
           </p:cNvPr>
@@ -4037,7 +5644,7 @@
           <p:cNvPr id="2" name="headline">
             <a:extLst xmlns:a="http://schemas.openxmlformats.org/drawingml/2006/main">
               <a:ext uri="{FF2B5EF4-FFF2-40B4-BE49-F238E27FC236}">
-                <a16:creationId xmlns:a16="http://schemas.microsoft.com/office/drawing/2014/main" id="{C05365F6-8EE0-4935-8D34-316B9DE3B75E}"/>
+                <a16:creationId xmlns:a16="http://schemas.microsoft.com/office/drawing/2014/main" id="{6055136C-1EF9-448C-9F44-23DBEE877FB1}"/>
               </a:ext>
             </a:extLst>
           </p:cNvPr>
@@ -4098,7 +5705,7 @@
           <p:cNvPr id="3" name="host-tool">
             <a:extLst xmlns:a="http://schemas.openxmlformats.org/drawingml/2006/main">
               <a:ext uri="{FF2B5EF4-FFF2-40B4-BE49-F238E27FC236}">
-                <a16:creationId xmlns:a16="http://schemas.microsoft.com/office/drawing/2014/main" id="{E45B263D-DC33-4483-9F4F-3F1BE28C9A99}"/>
+                <a16:creationId xmlns:a16="http://schemas.microsoft.com/office/drawing/2014/main" id="{726AF689-2BE6-4FA5-91DF-7CE6741C1EC2}"/>
               </a:ext>
             </a:extLst>
           </p:cNvPr>
@@ -4159,7 +5766,7 @@
           <p:cNvPr id="4" name="prompt-next">
             <a:extLst xmlns:a="http://schemas.openxmlformats.org/drawingml/2006/main">
               <a:ext uri="{FF2B5EF4-FFF2-40B4-BE49-F238E27FC236}">
-                <a16:creationId xmlns:a16="http://schemas.microsoft.com/office/drawing/2014/main" id="{BCAC5DEC-D4B7-4EFD-8A57-0BD94B556560}"/>
+                <a16:creationId xmlns:a16="http://schemas.microsoft.com/office/drawing/2014/main" id="{EA5BD1F3-6B15-4F2A-965A-40CDF3A01729}"/>
               </a:ext>
             </a:extLst>
           </p:cNvPr>
@@ -4224,7 +5831,7 @@
           <p:nvPr/>
         </p:nvPicPr>
         <p:blipFill>
-          <a:blip xmlns:r="http://schemas.openxmlformats.org/officeDocument/2006/relationships" xmlns:a="http://schemas.openxmlformats.org/drawingml/2006/main" r:embed="Rc720a3eac4a64446"/>
+          <a:blip xmlns:r="http://schemas.openxmlformats.org/officeDocument/2006/relationships" xmlns:a="http://schemas.openxmlformats.org/drawingml/2006/main" r:embed="Rf201f167dfdd42ba"/>
           <a:stretch xmlns:a="http://schemas.openxmlformats.org/drawingml/2006/main"/>
         </p:blipFill>
         <p:spPr>
@@ -4242,7 +5849,7 @@
           <p:cNvPr id="6" name="session-caption">
             <a:extLst xmlns:a="http://schemas.openxmlformats.org/drawingml/2006/main">
               <a:ext uri="{FF2B5EF4-FFF2-40B4-BE49-F238E27FC236}">
-                <a16:creationId xmlns:a16="http://schemas.microsoft.com/office/drawing/2014/main" id="{30B28BAC-0DF3-4E24-A943-95323529DFF7}"/>
+                <a16:creationId xmlns:a16="http://schemas.microsoft.com/office/drawing/2014/main" id="{F1024482-B071-478E-ACF2-F7138A38DC34}"/>
               </a:ext>
             </a:extLst>
           </p:cNvPr>
@@ -4303,7 +5910,7 @@
           <p:cNvPr id="7" name="slide-number">
             <a:extLst xmlns:a="http://schemas.openxmlformats.org/drawingml/2006/main">
               <a:ext uri="{FF2B5EF4-FFF2-40B4-BE49-F238E27FC236}">
-                <a16:creationId xmlns:a16="http://schemas.microsoft.com/office/drawing/2014/main" id="{CCF1452C-AF60-4212-992F-3AB84402C479}"/>
+                <a16:creationId xmlns:a16="http://schemas.microsoft.com/office/drawing/2014/main" id="{6E0EC25F-57B3-475B-A1D8-D8BE4AF417E5}"/>
               </a:ext>
             </a:extLst>
           </p:cNvPr>
@@ -4362,7 +5969,7 @@
     </p:spTree>
     <p:extLst>
       <p:ext uri="{BB962C8B-B14F-4D97-AF65-F5344CB8AC3E}">
-        <p14:creationId xmlns:p14="http://schemas.microsoft.com/office/powerpoint/2010/main" val="351091464"/>
+        <p14:creationId xmlns:p14="http://schemas.microsoft.com/office/powerpoint/2010/main" val="648885786"/>
       </p:ext>
     </p:extLst>
   </p:cSld>
@@ -4393,7 +6000,7 @@
           <p:cNvPr id="7" name="section-label">
             <a:extLst xmlns:a="http://schemas.openxmlformats.org/drawingml/2006/main">
               <a:ext uri="{FF2B5EF4-FFF2-40B4-BE49-F238E27FC236}">
-                <a16:creationId xmlns:a16="http://schemas.microsoft.com/office/drawing/2014/main" id="{B3FAF5B9-DA4E-41D2-959E-A375903FAC50}"/>
+                <a16:creationId xmlns:a16="http://schemas.microsoft.com/office/drawing/2014/main" id="{13442D05-3E1C-4BCD-AB3B-7213B83698B7}"/>
               </a:ext>
             </a:extLst>
           </p:cNvPr>
@@ -4454,7 +6061,7 @@
           <p:cNvPr id="2" name="headline">
             <a:extLst xmlns:a="http://schemas.openxmlformats.org/drawingml/2006/main">
               <a:ext uri="{FF2B5EF4-FFF2-40B4-BE49-F238E27FC236}">
-                <a16:creationId xmlns:a16="http://schemas.microsoft.com/office/drawing/2014/main" id="{267E6141-811B-47AA-81F0-DF47FA85A561}"/>
+                <a16:creationId xmlns:a16="http://schemas.microsoft.com/office/drawing/2014/main" id="{A18E9656-2235-4F30-BD3F-D636994F5B00}"/>
               </a:ext>
             </a:extLst>
           </p:cNvPr>
@@ -4515,7 +6122,7 @@
           <p:cNvPr id="3" name="retrieval-purpose">
             <a:extLst xmlns:a="http://schemas.openxmlformats.org/drawingml/2006/main">
               <a:ext uri="{FF2B5EF4-FFF2-40B4-BE49-F238E27FC236}">
-                <a16:creationId xmlns:a16="http://schemas.microsoft.com/office/drawing/2014/main" id="{F29DB37C-AF07-4284-8AAF-E7C2C7AC472A}"/>
+                <a16:creationId xmlns:a16="http://schemas.microsoft.com/office/drawing/2014/main" id="{62BEA31B-B522-4480-A763-8B57ED71B036}"/>
               </a:ext>
             </a:extLst>
           </p:cNvPr>
@@ -4580,7 +6187,7 @@
           <p:nvPr/>
         </p:nvPicPr>
         <p:blipFill>
-          <a:blip xmlns:r="http://schemas.openxmlformats.org/officeDocument/2006/relationships" xmlns:a="http://schemas.openxmlformats.org/drawingml/2006/main" r:embed="R7e5d84f418794afe"/>
+          <a:blip xmlns:r="http://schemas.openxmlformats.org/officeDocument/2006/relationships" xmlns:a="http://schemas.openxmlformats.org/drawingml/2006/main" r:embed="R133291c3bc1b47d3"/>
           <a:stretch xmlns:a="http://schemas.openxmlformats.org/drawingml/2006/main"/>
         </p:blipFill>
         <p:spPr>
@@ -4598,7 +6205,7 @@
           <p:cNvPr id="5" name="internal-status">
             <a:extLst xmlns:a="http://schemas.openxmlformats.org/drawingml/2006/main">
               <a:ext uri="{FF2B5EF4-FFF2-40B4-BE49-F238E27FC236}">
-                <a16:creationId xmlns:a16="http://schemas.microsoft.com/office/drawing/2014/main" id="{F7D39366-8D44-4608-9175-8BBC4C33DC1D}"/>
+                <a16:creationId xmlns:a16="http://schemas.microsoft.com/office/drawing/2014/main" id="{D36B5A2B-DA21-48C1-8B6C-4ED82671C199}"/>
               </a:ext>
             </a:extLst>
           </p:cNvPr>
@@ -4659,7 +6266,7 @@
           <p:cNvPr id="6" name="slide-number">
             <a:extLst xmlns:a="http://schemas.openxmlformats.org/drawingml/2006/main">
               <a:ext uri="{FF2B5EF4-FFF2-40B4-BE49-F238E27FC236}">
-                <a16:creationId xmlns:a16="http://schemas.microsoft.com/office/drawing/2014/main" id="{B4AD9D44-EEEB-43EC-AC19-B2DD9B913F0B}"/>
+                <a16:creationId xmlns:a16="http://schemas.microsoft.com/office/drawing/2014/main" id="{64831BCE-E025-42F7-B702-4DBE1022B686}"/>
               </a:ext>
             </a:extLst>
           </p:cNvPr>
@@ -4718,7 +6325,7 @@
     </p:spTree>
     <p:extLst>
       <p:ext uri="{BB962C8B-B14F-4D97-AF65-F5344CB8AC3E}">
-        <p14:creationId xmlns:p14="http://schemas.microsoft.com/office/powerpoint/2010/main" val="1251512934"/>
+        <p14:creationId xmlns:p14="http://schemas.microsoft.com/office/powerpoint/2010/main" val="563646195"/>
       </p:ext>
     </p:extLst>
   </p:cSld>
@@ -4749,7 +6356,7 @@
           <p:cNvPr id="8" name="section-label">
             <a:extLst xmlns:a="http://schemas.openxmlformats.org/drawingml/2006/main">
               <a:ext uri="{FF2B5EF4-FFF2-40B4-BE49-F238E27FC236}">
-                <a16:creationId xmlns:a16="http://schemas.microsoft.com/office/drawing/2014/main" id="{834438D8-1082-4CD1-B0EA-00CA9DFD8DC5}"/>
+                <a16:creationId xmlns:a16="http://schemas.microsoft.com/office/drawing/2014/main" id="{0B68A74A-58FE-4235-BA5E-2159C27E6682}"/>
               </a:ext>
             </a:extLst>
           </p:cNvPr>
@@ -4810,7 +6417,7 @@
           <p:cNvPr id="2" name="headline">
             <a:extLst xmlns:a="http://schemas.openxmlformats.org/drawingml/2006/main">
               <a:ext uri="{FF2B5EF4-FFF2-40B4-BE49-F238E27FC236}">
-                <a16:creationId xmlns:a16="http://schemas.microsoft.com/office/drawing/2014/main" id="{804D648C-D29C-485B-BC40-B87EB1D9D4BD}"/>
+                <a16:creationId xmlns:a16="http://schemas.microsoft.com/office/drawing/2014/main" id="{05676DBA-D008-41C6-87A6-BA11C8B4E557}"/>
               </a:ext>
             </a:extLst>
           </p:cNvPr>
@@ -4871,7 +6478,7 @@
           <p:cNvPr id="3" name="retrieval-detail">
             <a:extLst xmlns:a="http://schemas.openxmlformats.org/drawingml/2006/main">
               <a:ext uri="{FF2B5EF4-FFF2-40B4-BE49-F238E27FC236}">
-                <a16:creationId xmlns:a16="http://schemas.microsoft.com/office/drawing/2014/main" id="{589EFDE3-FAD9-44B3-86DC-651B1B8DCFFC}"/>
+                <a16:creationId xmlns:a16="http://schemas.microsoft.com/office/drawing/2014/main" id="{159684C5-7A4A-4E69-89CA-EFF4AD1AED17}"/>
               </a:ext>
             </a:extLst>
           </p:cNvPr>
@@ -4932,7 +6539,7 @@
           <p:cNvPr id="4" name="retrieval-review">
             <a:extLst xmlns:a="http://schemas.openxmlformats.org/drawingml/2006/main">
               <a:ext uri="{FF2B5EF4-FFF2-40B4-BE49-F238E27FC236}">
-                <a16:creationId xmlns:a16="http://schemas.microsoft.com/office/drawing/2014/main" id="{BB047336-3A37-4001-B4AA-17B4EF17DEC2}"/>
+                <a16:creationId xmlns:a16="http://schemas.microsoft.com/office/drawing/2014/main" id="{F69F6E3F-A364-4814-89D4-14708A9E28FD}"/>
               </a:ext>
             </a:extLst>
           </p:cNvPr>
@@ -4997,7 +6604,7 @@
           <p:nvPr/>
         </p:nvPicPr>
         <p:blipFill>
-          <a:blip xmlns:r="http://schemas.openxmlformats.org/officeDocument/2006/relationships" xmlns:a="http://schemas.openxmlformats.org/drawingml/2006/main" r:embed="R0a1df8529a2e4b89"/>
+          <a:blip xmlns:r="http://schemas.openxmlformats.org/officeDocument/2006/relationships" xmlns:a="http://schemas.openxmlformats.org/drawingml/2006/main" r:embed="Rfacd1da59dda4d37"/>
           <a:stretch xmlns:a="http://schemas.openxmlformats.org/drawingml/2006/main"/>
         </p:blipFill>
         <p:spPr>
@@ -5015,7 +6622,7 @@
           <p:cNvPr id="6" name="code-caption">
             <a:extLst xmlns:a="http://schemas.openxmlformats.org/drawingml/2006/main">
               <a:ext uri="{FF2B5EF4-FFF2-40B4-BE49-F238E27FC236}">
-                <a16:creationId xmlns:a16="http://schemas.microsoft.com/office/drawing/2014/main" id="{9D7F4478-8A0A-4093-B259-48177A07A153}"/>
+                <a16:creationId xmlns:a16="http://schemas.microsoft.com/office/drawing/2014/main" id="{EF68D7CC-B4C6-494E-A3F6-23F6C3F35DB3}"/>
               </a:ext>
             </a:extLst>
           </p:cNvPr>
@@ -5076,7 +6683,7 @@
           <p:cNvPr id="7" name="slide-number">
             <a:extLst xmlns:a="http://schemas.openxmlformats.org/drawingml/2006/main">
               <a:ext uri="{FF2B5EF4-FFF2-40B4-BE49-F238E27FC236}">
-                <a16:creationId xmlns:a16="http://schemas.microsoft.com/office/drawing/2014/main" id="{ADF85E57-7AD6-4020-AABE-067D6C0E41DF}"/>
+                <a16:creationId xmlns:a16="http://schemas.microsoft.com/office/drawing/2014/main" id="{FE53CE22-7801-4A19-91D2-A1931BEA0DD6}"/>
               </a:ext>
             </a:extLst>
           </p:cNvPr>
@@ -5135,7 +6742,7 @@
     </p:spTree>
     <p:extLst>
       <p:ext uri="{BB962C8B-B14F-4D97-AF65-F5344CB8AC3E}">
-        <p14:creationId xmlns:p14="http://schemas.microsoft.com/office/powerpoint/2010/main" val="265239971"/>
+        <p14:creationId xmlns:p14="http://schemas.microsoft.com/office/powerpoint/2010/main" val="2134001647"/>
       </p:ext>
     </p:extLst>
   </p:cSld>
@@ -5166,7 +6773,7 @@
           <p:cNvPr id="7" name="section-label">
             <a:extLst xmlns:a="http://schemas.openxmlformats.org/drawingml/2006/main">
               <a:ext uri="{FF2B5EF4-FFF2-40B4-BE49-F238E27FC236}">
-                <a16:creationId xmlns:a16="http://schemas.microsoft.com/office/drawing/2014/main" id="{5E6ECA25-28FA-4AAE-B69F-7DFC0775C9D1}"/>
+                <a16:creationId xmlns:a16="http://schemas.microsoft.com/office/drawing/2014/main" id="{DC581D98-C15C-4927-855A-92169EA68D41}"/>
               </a:ext>
             </a:extLst>
           </p:cNvPr>
@@ -5227,7 +6834,7 @@
           <p:cNvPr id="2" name="headline">
             <a:extLst xmlns:a="http://schemas.openxmlformats.org/drawingml/2006/main">
               <a:ext uri="{FF2B5EF4-FFF2-40B4-BE49-F238E27FC236}">
-                <a16:creationId xmlns:a16="http://schemas.microsoft.com/office/drawing/2014/main" id="{F9C838C1-58EF-4670-BB66-B20A14108F20}"/>
+                <a16:creationId xmlns:a16="http://schemas.microsoft.com/office/drawing/2014/main" id="{9CB016B8-62A3-4971-9F80-9D12F69BF21A}"/>
               </a:ext>
             </a:extLst>
           </p:cNvPr>
@@ -5288,7 +6895,7 @@
           <p:cNvPr id="3" name="course-name">
             <a:extLst xmlns:a="http://schemas.openxmlformats.org/drawingml/2006/main">
               <a:ext uri="{FF2B5EF4-FFF2-40B4-BE49-F238E27FC236}">
-                <a16:creationId xmlns:a16="http://schemas.microsoft.com/office/drawing/2014/main" id="{7E208B55-4A7C-43F7-A48F-772F092E109D}"/>
+                <a16:creationId xmlns:a16="http://schemas.microsoft.com/office/drawing/2014/main" id="{C35F6A20-968D-45D9-A54A-5FC87A05A315}"/>
               </a:ext>
             </a:extLst>
           </p:cNvPr>
@@ -5353,7 +6960,7 @@
           <p:nvPr/>
         </p:nvPicPr>
         <p:blipFill>
-          <a:blip xmlns:r="http://schemas.openxmlformats.org/officeDocument/2006/relationships" xmlns:a="http://schemas.openxmlformats.org/drawingml/2006/main" r:embed="Rb061f8002b374141"/>
+          <a:blip xmlns:r="http://schemas.openxmlformats.org/officeDocument/2006/relationships" xmlns:a="http://schemas.openxmlformats.org/drawingml/2006/main" r:embed="Re39366e147374036"/>
           <a:stretch xmlns:a="http://schemas.openxmlformats.org/drawingml/2006/main"/>
         </p:blipFill>
         <p:spPr>
@@ -5371,7 +6978,7 @@
           <p:cNvPr id="5" name="course-status">
             <a:extLst xmlns:a="http://schemas.openxmlformats.org/drawingml/2006/main">
               <a:ext uri="{FF2B5EF4-FFF2-40B4-BE49-F238E27FC236}">
-                <a16:creationId xmlns:a16="http://schemas.microsoft.com/office/drawing/2014/main" id="{173C8D5F-72EA-4F4C-B619-A8F28B5932D8}"/>
+                <a16:creationId xmlns:a16="http://schemas.microsoft.com/office/drawing/2014/main" id="{743EC672-EA64-4D75-A782-47403518E2E4}"/>
               </a:ext>
             </a:extLst>
           </p:cNvPr>
@@ -5432,7 +7039,7 @@
           <p:cNvPr id="6" name="slide-number">
             <a:extLst xmlns:a="http://schemas.openxmlformats.org/drawingml/2006/main">
               <a:ext uri="{FF2B5EF4-FFF2-40B4-BE49-F238E27FC236}">
-                <a16:creationId xmlns:a16="http://schemas.microsoft.com/office/drawing/2014/main" id="{F9A7EC11-0DE5-4BAE-AB75-6338ED467E0C}"/>
+                <a16:creationId xmlns:a16="http://schemas.microsoft.com/office/drawing/2014/main" id="{15D7F2C5-A1DA-4E17-A484-849780D45B8E}"/>
               </a:ext>
             </a:extLst>
           </p:cNvPr>
@@ -5491,7 +7098,7 @@
     </p:spTree>
     <p:extLst>
       <p:ext uri="{BB962C8B-B14F-4D97-AF65-F5344CB8AC3E}">
-        <p14:creationId xmlns:p14="http://schemas.microsoft.com/office/powerpoint/2010/main" val="1186540551"/>
+        <p14:creationId xmlns:p14="http://schemas.microsoft.com/office/powerpoint/2010/main" val="990775242"/>
       </p:ext>
     </p:extLst>
   </p:cSld>
@@ -5522,7 +7129,7 @@
           <p:cNvPr id="7" name="section-label">
             <a:extLst xmlns:a="http://schemas.openxmlformats.org/drawingml/2006/main">
               <a:ext uri="{FF2B5EF4-FFF2-40B4-BE49-F238E27FC236}">
-                <a16:creationId xmlns:a16="http://schemas.microsoft.com/office/drawing/2014/main" id="{5C68743F-D9AC-4922-BDBB-F861A8B91C28}"/>
+                <a16:creationId xmlns:a16="http://schemas.microsoft.com/office/drawing/2014/main" id="{270F07CF-1F4B-4FFE-BFD9-AD4115D30AF9}"/>
               </a:ext>
             </a:extLst>
           </p:cNvPr>
@@ -5583,7 +7190,7 @@
           <p:cNvPr id="2" name="headline">
             <a:extLst xmlns:a="http://schemas.openxmlformats.org/drawingml/2006/main">
               <a:ext uri="{FF2B5EF4-FFF2-40B4-BE49-F238E27FC236}">
-                <a16:creationId xmlns:a16="http://schemas.microsoft.com/office/drawing/2014/main" id="{D52CB012-4CED-4D11-B03F-759D274C503B}"/>
+                <a16:creationId xmlns:a16="http://schemas.microsoft.com/office/drawing/2014/main" id="{A751D3C1-20CA-48DA-B67D-C96FC16A5EEC}"/>
               </a:ext>
             </a:extLst>
           </p:cNvPr>
@@ -5644,7 +7251,7 @@
           <p:cNvPr id="3" name="course-example-context">
             <a:extLst xmlns:a="http://schemas.openxmlformats.org/drawingml/2006/main">
               <a:ext uri="{FF2B5EF4-FFF2-40B4-BE49-F238E27FC236}">
-                <a16:creationId xmlns:a16="http://schemas.microsoft.com/office/drawing/2014/main" id="{8F1EC61F-E550-4E73-85C9-3FA80D4B1A43}"/>
+                <a16:creationId xmlns:a16="http://schemas.microsoft.com/office/drawing/2014/main" id="{7ADF06A9-0411-476B-B46B-B226C6A425B4}"/>
               </a:ext>
             </a:extLst>
           </p:cNvPr>
@@ -5709,7 +7316,7 @@
           <p:nvPr/>
         </p:nvPicPr>
         <p:blipFill>
-          <a:blip xmlns:r="http://schemas.openxmlformats.org/officeDocument/2006/relationships" xmlns:a="http://schemas.openxmlformats.org/drawingml/2006/main" r:embed="R36b6a668f246473e"/>
+          <a:blip xmlns:r="http://schemas.openxmlformats.org/officeDocument/2006/relationships" xmlns:a="http://schemas.openxmlformats.org/drawingml/2006/main" r:embed="R3bdeb88478ca43c9"/>
           <a:stretch xmlns:a="http://schemas.openxmlformats.org/drawingml/2006/main"/>
         </p:blipFill>
         <p:spPr>
@@ -5727,7 +7334,7 @@
           <p:cNvPr id="5" name="transfer-assessment">
             <a:extLst xmlns:a="http://schemas.openxmlformats.org/drawingml/2006/main">
               <a:ext uri="{FF2B5EF4-FFF2-40B4-BE49-F238E27FC236}">
-                <a16:creationId xmlns:a16="http://schemas.microsoft.com/office/drawing/2014/main" id="{F2C99E60-5AB7-40A0-A7F8-5EDA2923E6F9}"/>
+                <a16:creationId xmlns:a16="http://schemas.microsoft.com/office/drawing/2014/main" id="{B354EA37-BDE9-4C38-9919-D01C37F60017}"/>
               </a:ext>
             </a:extLst>
           </p:cNvPr>
@@ -5788,7 +7395,7 @@
           <p:cNvPr id="6" name="slide-number">
             <a:extLst xmlns:a="http://schemas.openxmlformats.org/drawingml/2006/main">
               <a:ext uri="{FF2B5EF4-FFF2-40B4-BE49-F238E27FC236}">
-                <a16:creationId xmlns:a16="http://schemas.microsoft.com/office/drawing/2014/main" id="{4562E46C-C816-44D0-B56B-A34CECD83507}"/>
+                <a16:creationId xmlns:a16="http://schemas.microsoft.com/office/drawing/2014/main" id="{861C0293-FBD0-4F1B-A4E1-EBE66437D30B}"/>
               </a:ext>
             </a:extLst>
           </p:cNvPr>
@@ -5847,7 +7454,7 @@
     </p:spTree>
     <p:extLst>
       <p:ext uri="{BB962C8B-B14F-4D97-AF65-F5344CB8AC3E}">
-        <p14:creationId xmlns:p14="http://schemas.microsoft.com/office/powerpoint/2010/main" val="168053126"/>
+        <p14:creationId xmlns:p14="http://schemas.microsoft.com/office/powerpoint/2010/main" val="1597166901"/>
       </p:ext>
     </p:extLst>
   </p:cSld>
@@ -5875,10 +7482,10 @@
       </p:grpSpPr>
       <p:sp>
         <p:nvSpPr>
-          <p:cNvPr id="7" name="section-label">
-            <a:extLst xmlns:a="http://schemas.openxmlformats.org/drawingml/2006/main">
-              <a:ext uri="{FF2B5EF4-FFF2-40B4-BE49-F238E27FC236}">
-                <a16:creationId xmlns:a16="http://schemas.microsoft.com/office/drawing/2014/main" id="{1C6FCB76-44E2-4302-9C93-68671AA29397}"/>
+          <p:cNvPr id="9" name="section-label">
+            <a:extLst xmlns:a="http://schemas.openxmlformats.org/drawingml/2006/main">
+              <a:ext uri="{FF2B5EF4-FFF2-40B4-BE49-F238E27FC236}">
+                <a16:creationId xmlns:a16="http://schemas.microsoft.com/office/drawing/2014/main" id="{CBA50FA7-3EB2-48E3-9223-4123D6A341E9}"/>
               </a:ext>
             </a:extLst>
           </p:cNvPr>
@@ -5929,7 +7536,7 @@
                 <a:ea typeface="Helvetica Neue"/>
                 <a:cs typeface="Helvetica Neue"/>
               </a:rPr>
-              <a:t>ASU LEARNING INNOVATIONS   /   AI ANALYST, FEB–OCT 2024</a:t>
+              <a:t>AI WORKSHOP STUDIO   /   PUBLISHED APPLICATION, 2026</a:t>
             </a:r>
           </a:p>
         </p:txBody>
@@ -5939,19 +7546,19 @@
           <p:cNvPr id="2" name="headline">
             <a:extLst xmlns:a="http://schemas.openxmlformats.org/drawingml/2006/main">
               <a:ext uri="{FF2B5EF4-FFF2-40B4-BE49-F238E27FC236}">
-                <a16:creationId xmlns:a16="http://schemas.microsoft.com/office/drawing/2014/main" id="{F19B4A0E-C508-4538-B93B-C8A944942307}"/>
-              </a:ext>
-            </a:extLst>
-          </p:cNvPr>
-          <p:cNvSpPr>
-            <a:spLocks xmlns:a="http://schemas.openxmlformats.org/drawingml/2006/main" noGrp="1"/>
-          </p:cNvSpPr>
-          <p:nvPr/>
-        </p:nvSpPr>
-        <p:spPr>
-          <a:xfrm xmlns:a="http://schemas.openxmlformats.org/drawingml/2006/main">
-            <a:off x="609600" y="1095375"/>
-            <a:ext cx="6810375" cy="1466850"/>
+                <a16:creationId xmlns:a16="http://schemas.microsoft.com/office/drawing/2014/main" id="{978EFA9E-AEFD-4D07-80A4-EF7A1A3A1325}"/>
+              </a:ext>
+            </a:extLst>
+          </p:cNvPr>
+          <p:cNvSpPr>
+            <a:spLocks xmlns:a="http://schemas.openxmlformats.org/drawingml/2006/main" noGrp="1"/>
+          </p:cNvSpPr>
+          <p:nvPr/>
+        </p:nvSpPr>
+        <p:spPr>
+          <a:xfrm xmlns:a="http://schemas.openxmlformats.org/drawingml/2006/main">
+            <a:off x="609600" y="1057275"/>
+            <a:ext cx="10896600" cy="1143000"/>
           </a:xfrm>
           <a:prstGeom xmlns:a="http://schemas.openxmlformats.org/drawingml/2006/main" prst="rect">
             <a:avLst/>
@@ -5972,7 +7579,7 @@
                 <a:spcPct val="110000"/>
               </a:lnSpc>
               <a:buNone/>
-              <a:defRPr sz="3750" b="1">
+              <a:defRPr sz="3600" b="1">
                 <a:solidFill>
                   <a:srgbClr val="192B25"/>
                 </a:solidFill>
@@ -5982,7 +7589,7 @@
               </a:defRPr>
             </a:pPr>
             <a:r>
-              <a:rPr sz="3750" b="1">
+              <a:rPr sz="3600" b="1">
                 <a:solidFill>
                   <a:srgbClr val="192B25"/>
                 </a:solidFill>
@@ -5990,16 +7597,16 @@
                 <a:ea typeface="Helvetica Neue"/>
                 <a:cs typeface="Helvetica Neue"/>
               </a:rPr>
-              <a:t>Mentor review shaped</a:t>
-            </a:r>
-          </a:p>
-          <a:p xmlns:a="http://schemas.openxmlformats.org/drawingml/2006/main">
-            <a:pPr>
-              <a:lnSpc>
-                <a:spcPct val="110000"/>
-              </a:lnSpc>
-              <a:buNone/>
-              <a:defRPr sz="3750" b="1">
+              <a:t>AI Workshop Studio gives</a:t>
+            </a:r>
+          </a:p>
+          <a:p xmlns:a="http://schemas.openxmlformats.org/drawingml/2006/main">
+            <a:pPr>
+              <a:lnSpc>
+                <a:spcPct val="110000"/>
+              </a:lnSpc>
+              <a:buNone/>
+              <a:defRPr sz="3600" b="1">
                 <a:solidFill>
                   <a:srgbClr val="192B25"/>
                 </a:solidFill>
@@ -6009,7 +7616,7 @@
               </a:defRPr>
             </a:pPr>
             <a:r>
-              <a:rPr sz="3750" b="1">
+              <a:rPr sz="3600" b="1">
                 <a:solidFill>
                   <a:srgbClr val="192B25"/>
                 </a:solidFill>
@@ -6017,29 +7624,51 @@
                 <a:ea typeface="Helvetica Neue"/>
                 <a:cs typeface="Helvetica Neue"/>
               </a:rPr>
-              <a:t>the learner workflow</a:t>
-            </a:r>
-          </a:p>
-        </p:txBody>
-      </p:sp>
-      <p:sp>
-        <p:nvSpPr>
-          <p:cNvPr id="3" name="asu-purpose">
-            <a:extLst xmlns:a="http://schemas.openxmlformats.org/drawingml/2006/main">
-              <a:ext uri="{FF2B5EF4-FFF2-40B4-BE49-F238E27FC236}">
-                <a16:creationId xmlns:a16="http://schemas.microsoft.com/office/drawing/2014/main" id="{75702E99-75D7-42DE-8E2A-0367131826AD}"/>
-              </a:ext>
-            </a:extLst>
-          </p:cNvPr>
-          <p:cNvSpPr>
-            <a:spLocks xmlns:a="http://schemas.openxmlformats.org/drawingml/2006/main" noGrp="1"/>
-          </p:cNvSpPr>
-          <p:nvPr/>
-        </p:nvSpPr>
-        <p:spPr>
-          <a:xfrm xmlns:a="http://schemas.openxmlformats.org/drawingml/2006/main">
-            <a:off x="609600" y="3228975"/>
-            <a:ext cx="6286500" cy="1114425"/>
+              <a:t>learners a visible path</a:t>
+            </a:r>
+          </a:p>
+        </p:txBody>
+      </p:sp>
+      <p:pic>
+        <p:nvPicPr>
+          <p:cNvPr id="11" name=""/>
+          <p:cNvPicPr>
+            <a:picLocks xmlns:a="http://schemas.openxmlformats.org/drawingml/2006/main" noChangeAspect="1"/>
+          </p:cNvPicPr>
+          <p:nvPr/>
+        </p:nvPicPr>
+        <p:blipFill>
+          <a:blip xmlns:r="http://schemas.openxmlformats.org/officeDocument/2006/relationships" xmlns:a="http://schemas.openxmlformats.org/drawingml/2006/main" r:embed="Rd30d8bbd18584d2d"/>
+          <a:stretch xmlns:a="http://schemas.openxmlformats.org/drawingml/2006/main"/>
+        </p:blipFill>
+        <p:spPr>
+          <a:xfrm xmlns:a="http://schemas.openxmlformats.org/drawingml/2006/main">
+            <a:off x="1119629" y="2524125"/>
+            <a:ext cx="6599942" cy="3714750"/>
+          </a:xfrm>
+          <a:prstGeom xmlns:a="http://schemas.openxmlformats.org/drawingml/2006/main" prst="rect">
+            <a:avLst/>
+          </a:prstGeom>
+        </p:spPr>
+      </p:pic>
+      <p:sp>
+        <p:nvSpPr>
+          <p:cNvPr id="4" name="studio-purpose">
+            <a:extLst xmlns:a="http://schemas.openxmlformats.org/drawingml/2006/main">
+              <a:ext uri="{FF2B5EF4-FFF2-40B4-BE49-F238E27FC236}">
+                <a16:creationId xmlns:a16="http://schemas.microsoft.com/office/drawing/2014/main" id="{85B4ACB3-6D19-40B5-BD50-8BA6B94C43E9}"/>
+              </a:ext>
+            </a:extLst>
+          </p:cNvPr>
+          <p:cNvSpPr>
+            <a:spLocks xmlns:a="http://schemas.openxmlformats.org/drawingml/2006/main" noGrp="1"/>
+          </p:cNvSpPr>
+          <p:nvPr/>
+        </p:nvSpPr>
+        <p:spPr>
+          <a:xfrm xmlns:a="http://schemas.openxmlformats.org/drawingml/2006/main">
+            <a:off x="8886825" y="2419350"/>
+            <a:ext cx="2638425" cy="2066925"/>
           </a:xfrm>
           <a:prstGeom xmlns:a="http://schemas.openxmlformats.org/drawingml/2006/main" prst="rect">
             <a:avLst/>
@@ -6060,7 +7689,7 @@
                 <a:spcPct val="110000"/>
               </a:lnSpc>
               <a:buNone/>
-              <a:defRPr sz="2025" b="0">
+              <a:defRPr sz="1800" b="0">
                 <a:solidFill>
                   <a:srgbClr val="192B25"/>
                 </a:solidFill>
@@ -6070,7 +7699,7 @@
               </a:defRPr>
             </a:pPr>
             <a:r>
-              <a:rPr sz="2025" b="0">
+              <a:rPr sz="1800" b="0">
                 <a:solidFill>
                   <a:srgbClr val="192B25"/>
                 </a:solidFill>
@@ -6078,51 +7707,29 @@
                 <a:ea typeface="Helvetica Neue"/>
                 <a:cs typeface="Helvetica Neue"/>
               </a:rPr>
-              <a:t>I proposed staged generation of personalized learner tasks, with a mentor checking the context and the output.</a:t>
-            </a:r>
-          </a:p>
-        </p:txBody>
-      </p:sp>
-      <p:pic>
-        <p:nvPicPr>
-          <p:cNvPr id="10" name=""/>
-          <p:cNvPicPr>
-            <a:picLocks xmlns:a="http://schemas.openxmlformats.org/drawingml/2006/main" noChangeAspect="1"/>
-          </p:cNvPicPr>
-          <p:nvPr/>
-        </p:nvPicPr>
-        <p:blipFill>
-          <a:blip xmlns:r="http://schemas.openxmlformats.org/officeDocument/2006/relationships" xmlns:a="http://schemas.openxmlformats.org/drawingml/2006/main" r:embed="R7a3ab35639694787"/>
-          <a:stretch xmlns:a="http://schemas.openxmlformats.org/drawingml/2006/main"/>
-        </p:blipFill>
-        <p:spPr>
-          <a:xfrm xmlns:a="http://schemas.openxmlformats.org/drawingml/2006/main">
-            <a:off x="8241908" y="1200150"/>
-            <a:ext cx="2604285" cy="5038725"/>
-          </a:xfrm>
-          <a:prstGeom xmlns:a="http://schemas.openxmlformats.org/drawingml/2006/main" prst="rect">
-            <a:avLst/>
-          </a:prstGeom>
-        </p:spPr>
-      </p:pic>
-      <p:sp>
-        <p:nvSpPr>
-          <p:cNvPr id="5" name="asu-stage">
-            <a:extLst xmlns:a="http://schemas.openxmlformats.org/drawingml/2006/main">
-              <a:ext uri="{FF2B5EF4-FFF2-40B4-BE49-F238E27FC236}">
-                <a16:creationId xmlns:a16="http://schemas.microsoft.com/office/drawing/2014/main" id="{51E3DBB0-8C58-4035-8707-D03096E5A1E3}"/>
-              </a:ext>
-            </a:extLst>
-          </p:cNvPr>
-          <p:cNvSpPr>
-            <a:spLocks xmlns:a="http://schemas.openxmlformats.org/drawingml/2006/main" noGrp="1"/>
-          </p:cNvSpPr>
-          <p:nvPr/>
-        </p:nvSpPr>
-        <p:spPr>
-          <a:xfrm xmlns:a="http://schemas.openxmlformats.org/drawingml/2006/main">
-            <a:off x="609600" y="5257800"/>
-            <a:ext cx="6381750" cy="866775"/>
+              <a:t>One learning goal and one next action keep a course step clear. Help, files, notes and the agenda stay within reach.</a:t>
+            </a:r>
+          </a:p>
+        </p:txBody>
+      </p:sp>
+      <p:sp>
+        <p:nvSpPr>
+          <p:cNvPr id="5" name="studio-media">
+            <a:extLst xmlns:a="http://schemas.openxmlformats.org/drawingml/2006/main">
+              <a:ext uri="{FF2B5EF4-FFF2-40B4-BE49-F238E27FC236}">
+                <a16:creationId xmlns:a16="http://schemas.microsoft.com/office/drawing/2014/main" id="{1031789E-BBC0-473A-9AD5-0885480422EC}"/>
+              </a:ext>
+            </a:extLst>
+          </p:cNvPr>
+          <p:cNvSpPr>
+            <a:spLocks xmlns:a="http://schemas.openxmlformats.org/drawingml/2006/main" noGrp="1"/>
+          </p:cNvSpPr>
+          <p:nvPr/>
+        </p:nvSpPr>
+        <p:spPr>
+          <a:xfrm xmlns:a="http://schemas.openxmlformats.org/drawingml/2006/main">
+            <a:off x="8886825" y="4619625"/>
+            <a:ext cx="2638425" cy="1190625"/>
           </a:xfrm>
           <a:prstGeom xmlns:a="http://schemas.openxmlformats.org/drawingml/2006/main" prst="rect">
             <a:avLst/>
@@ -6161,29 +7768,59 @@
                 <a:ea typeface="Helvetica Neue"/>
                 <a:cs typeface="Helvetica Neue"/>
               </a:rPr>
-              <a:t>Two mentor checkpoints from the simplified 2024 proposal. Deployment and time savings were not established.</a:t>
-            </a:r>
-          </a:p>
-        </p:txBody>
-      </p:sp>
-      <p:sp>
-        <p:nvSpPr>
-          <p:cNvPr id="6" name="slide-number">
-            <a:extLst xmlns:a="http://schemas.openxmlformats.org/drawingml/2006/main">
-              <a:ext uri="{FF2B5EF4-FFF2-40B4-BE49-F238E27FC236}">
-                <a16:creationId xmlns:a16="http://schemas.microsoft.com/office/drawing/2014/main" id="{0583DDD3-E16F-4545-892B-E17C2D02F926}"/>
-              </a:ext>
-            </a:extLst>
-          </p:cNvPr>
-          <p:cNvSpPr>
-            <a:spLocks xmlns:a="http://schemas.openxmlformats.org/drawingml/2006/main" noGrp="1"/>
-          </p:cNvSpPr>
-          <p:nvPr/>
-        </p:nvSpPr>
-        <p:spPr>
-          <a:xfrm xmlns:a="http://schemas.openxmlformats.org/drawingml/2006/main">
-            <a:off x="11353800" y="6562725"/>
-            <a:ext cx="323850" cy="190500"/>
+              <a:t>The published video workspace adds chapters, a synchronized transcript, a written guide and step materials.</a:t>
+            </a:r>
+          </a:p>
+        </p:txBody>
+      </p:sp>
+      <p:sp>
+        <p:nvSpPr>
+          <p:cNvPr id="6" name="studio-case-background">
+            <a:extLst xmlns:a="http://schemas.openxmlformats.org/drawingml/2006/main">
+              <a:ext uri="{FF2B5EF4-FFF2-40B4-BE49-F238E27FC236}">
+                <a16:creationId xmlns:a16="http://schemas.microsoft.com/office/drawing/2014/main" id="{10F089BF-04CA-495A-A247-9D7E7A686CE4}"/>
+              </a:ext>
+            </a:extLst>
+          </p:cNvPr>
+          <p:cNvSpPr>
+            <a:spLocks xmlns:a="http://schemas.openxmlformats.org/drawingml/2006/main" noGrp="1"/>
+          </p:cNvSpPr>
+          <p:nvPr/>
+        </p:nvSpPr>
+        <p:spPr>
+          <a:xfrm xmlns:a="http://schemas.openxmlformats.org/drawingml/2006/main">
+            <a:off x="8810625" y="6153150"/>
+            <a:ext cx="2343150" cy="400050"/>
+          </a:xfrm>
+          <a:prstGeom xmlns:a="http://schemas.openxmlformats.org/drawingml/2006/main" prst="rect">
+            <a:avLst/>
+          </a:prstGeom>
+          <a:solidFill xmlns:a="http://schemas.openxmlformats.org/drawingml/2006/main">
+            <a:srgbClr val="244D3C"/>
+          </a:solidFill>
+          <a:ln xmlns:a="http://schemas.openxmlformats.org/drawingml/2006/main" w="0">
+            <a:noFill/>
+          </a:ln>
+        </p:spPr>
+      </p:sp>
+      <p:sp>
+        <p:nvSpPr>
+          <p:cNvPr id="7" name="studio-case-link">
+            <a:extLst xmlns:a="http://schemas.openxmlformats.org/drawingml/2006/main">
+              <a:ext uri="{FF2B5EF4-FFF2-40B4-BE49-F238E27FC236}">
+                <a16:creationId xmlns:a16="http://schemas.microsoft.com/office/drawing/2014/main" id="{54533E01-93B7-4406-AD8A-9B3482995BE5}"/>
+              </a:ext>
+            </a:extLst>
+          </p:cNvPr>
+          <p:cNvSpPr>
+            <a:spLocks xmlns:a="http://schemas.openxmlformats.org/drawingml/2006/main" noGrp="1"/>
+          </p:cNvSpPr>
+          <p:nvPr/>
+        </p:nvSpPr>
+        <p:spPr>
+          <a:xfrm xmlns:a="http://schemas.openxmlformats.org/drawingml/2006/main">
+            <a:off x="8963025" y="6229350"/>
+            <a:ext cx="2047875" cy="266700"/>
           </a:xfrm>
           <a:prstGeom xmlns:a="http://schemas.openxmlformats.org/drawingml/2006/main" prst="rect">
             <a:avLst/>
@@ -6204,6 +7841,68 @@
                 <a:spcPct val="110000"/>
               </a:lnSpc>
               <a:buNone/>
+              <a:defRPr sz="1350" b="0" u="sng">
+                <a:solidFill>
+                  <a:srgbClr val="DBEB89"/>
+                </a:solidFill>
+                <a:latin typeface="Helvetica Neue"/>
+                <a:ea typeface="Helvetica Neue"/>
+                <a:cs typeface="Helvetica Neue"/>
+              </a:defRPr>
+            </a:pPr>
+            <a:r>
+              <a:rPr sz="1350" b="0" u="sng">
+                <a:solidFill>
+                  <a:srgbClr val="DBEB89"/>
+                </a:solidFill>
+                <a:latin typeface="Helvetica Neue"/>
+                <a:ea typeface="Helvetica Neue"/>
+                <a:cs typeface="Helvetica Neue"/>
+                <a:hlinkClick xmlns:r="http://schemas.openxmlformats.org/officeDocument/2006/relationships" r:id="Rdbd15285ac334bf4"/>
+              </a:rPr>
+              <a:t>View the case →</a:t>
+            </a:r>
+          </a:p>
+        </p:txBody>
+      </p:sp>
+      <p:sp>
+        <p:nvSpPr>
+          <p:cNvPr id="8" name="slide-number">
+            <a:extLst xmlns:a="http://schemas.openxmlformats.org/drawingml/2006/main">
+              <a:ext uri="{FF2B5EF4-FFF2-40B4-BE49-F238E27FC236}">
+                <a16:creationId xmlns:a16="http://schemas.microsoft.com/office/drawing/2014/main" id="{DE9C0A97-ECF0-4987-A1E2-BBC8A43686B3}"/>
+              </a:ext>
+            </a:extLst>
+          </p:cNvPr>
+          <p:cNvSpPr>
+            <a:spLocks xmlns:a="http://schemas.openxmlformats.org/drawingml/2006/main" noGrp="1"/>
+          </p:cNvSpPr>
+          <p:nvPr/>
+        </p:nvSpPr>
+        <p:spPr>
+          <a:xfrm xmlns:a="http://schemas.openxmlformats.org/drawingml/2006/main">
+            <a:off x="11353800" y="6562725"/>
+            <a:ext cx="323850" cy="190500"/>
+          </a:xfrm>
+          <a:prstGeom xmlns:a="http://schemas.openxmlformats.org/drawingml/2006/main" prst="rect">
+            <a:avLst/>
+          </a:prstGeom>
+          <a:noFill xmlns:a="http://schemas.openxmlformats.org/drawingml/2006/main"/>
+          <a:ln xmlns:a="http://schemas.openxmlformats.org/drawingml/2006/main" w="0">
+            <a:noFill/>
+          </a:ln>
+        </p:spPr>
+        <p:txBody>
+          <a:bodyPr xmlns:a="http://schemas.openxmlformats.org/drawingml/2006/main" wrap="square" lIns="0" tIns="0" rIns="0" bIns="0" anchor="t">
+            <a:noAutofit/>
+          </a:bodyPr>
+          <a:lstStyle xmlns:a="http://schemas.openxmlformats.org/drawingml/2006/main"/>
+          <a:p xmlns:a="http://schemas.openxmlformats.org/drawingml/2006/main">
+            <a:pPr>
+              <a:lnSpc>
+                <a:spcPct val="110000"/>
+              </a:lnSpc>
+              <a:buNone/>
               <a:defRPr sz="1050" b="0">
                 <a:solidFill>
                   <a:srgbClr val="58645D"/>
@@ -6230,7 +7929,7 @@
     </p:spTree>
     <p:extLst>
       <p:ext uri="{BB962C8B-B14F-4D97-AF65-F5344CB8AC3E}">
-        <p14:creationId xmlns:p14="http://schemas.microsoft.com/office/powerpoint/2010/main" val="1754087495"/>
+        <p14:creationId xmlns:p14="http://schemas.microsoft.com/office/powerpoint/2010/main" val="536343031"/>
       </p:ext>
     </p:extLst>
   </p:cSld>

</xml_diff>

<commit_message>
Restore Applied AI hierarchy and link original game case studies
</commit_message>
<xml_diff>
--- a/downloads/ai/kyle-hobson-ai-deck.pptx
+++ b/downloads/ai/kyle-hobson-ai-deck.pptx
@@ -2,26 +2,25 @@
 <file path=ppt/presentation.xml><?xml version="1.0" encoding="utf-8"?>
 <p:presentation xmlns:p="http://schemas.openxmlformats.org/presentationml/2006/main">
   <p:sldMasterIdLst>
-    <p:sldMasterId xmlns:r="http://schemas.openxmlformats.org/officeDocument/2006/relationships" id="2147483648" r:id="Rd751833ee9f74d62"/>
+    <p:sldMasterId xmlns:r="http://schemas.openxmlformats.org/officeDocument/2006/relationships" id="2147483648" r:id="R9eb8cae0b2c8439f"/>
   </p:sldMasterIdLst>
   <p:notesMasterIdLst>
-    <p:notesMasterId xmlns:r="http://schemas.openxmlformats.org/officeDocument/2006/relationships" r:id="R895d3a2b19d743fb"/>
+    <p:notesMasterId xmlns:r="http://schemas.openxmlformats.org/officeDocument/2006/relationships" r:id="R8f37b71fc4124db6"/>
   </p:notesMasterIdLst>
   <p:sldIdLst>
-    <p:sldId xmlns:r="http://schemas.openxmlformats.org/officeDocument/2006/relationships" id="256" r:id="R9f5ace3fb182454e"/>
-    <p:sldId xmlns:r="http://schemas.openxmlformats.org/officeDocument/2006/relationships" id="257" r:id="Re6e264488ef84974"/>
-    <p:sldId xmlns:r="http://schemas.openxmlformats.org/officeDocument/2006/relationships" id="258" r:id="Rcb1d1a3661fe47a5"/>
-    <p:sldId xmlns:r="http://schemas.openxmlformats.org/officeDocument/2006/relationships" id="259" r:id="Rb016987a26ff4954"/>
-    <p:sldId xmlns:r="http://schemas.openxmlformats.org/officeDocument/2006/relationships" id="260" r:id="R06a8fcb0138946f1"/>
-    <p:sldId xmlns:r="http://schemas.openxmlformats.org/officeDocument/2006/relationships" id="261" r:id="R1f49bb5d2c564a10"/>
-    <p:sldId xmlns:r="http://schemas.openxmlformats.org/officeDocument/2006/relationships" id="262" r:id="R8b6a1c5e2deb47a4"/>
-    <p:sldId xmlns:r="http://schemas.openxmlformats.org/officeDocument/2006/relationships" id="263" r:id="Ra1f9851c134d4a26"/>
-    <p:sldId xmlns:r="http://schemas.openxmlformats.org/officeDocument/2006/relationships" id="264" r:id="R97b6a51075524bbc"/>
-    <p:sldId xmlns:r="http://schemas.openxmlformats.org/officeDocument/2006/relationships" id="265" r:id="R99464550dc7346a6"/>
-    <p:sldId xmlns:r="http://schemas.openxmlformats.org/officeDocument/2006/relationships" id="266" r:id="Rd9034d9f88494c3f"/>
-    <p:sldId xmlns:r="http://schemas.openxmlformats.org/officeDocument/2006/relationships" id="267" r:id="R9b64abd5ac7a403c"/>
-    <p:sldId xmlns:r="http://schemas.openxmlformats.org/officeDocument/2006/relationships" id="268" r:id="R3ea5c35b95154a41"/>
-    <p:sldId xmlns:r="http://schemas.openxmlformats.org/officeDocument/2006/relationships" id="269" r:id="Rd3b34bab93fe4a0c"/>
+    <p:sldId xmlns:r="http://schemas.openxmlformats.org/officeDocument/2006/relationships" id="256" r:id="R2300bed877354c35"/>
+    <p:sldId xmlns:r="http://schemas.openxmlformats.org/officeDocument/2006/relationships" id="257" r:id="Re0e335ed551940f9"/>
+    <p:sldId xmlns:r="http://schemas.openxmlformats.org/officeDocument/2006/relationships" id="258" r:id="R9cf63649a3e14f8c"/>
+    <p:sldId xmlns:r="http://schemas.openxmlformats.org/officeDocument/2006/relationships" id="259" r:id="R92a7d4585c8a4548"/>
+    <p:sldId xmlns:r="http://schemas.openxmlformats.org/officeDocument/2006/relationships" id="260" r:id="R6b47d32383d34710"/>
+    <p:sldId xmlns:r="http://schemas.openxmlformats.org/officeDocument/2006/relationships" id="261" r:id="R89c385651850477c"/>
+    <p:sldId xmlns:r="http://schemas.openxmlformats.org/officeDocument/2006/relationships" id="262" r:id="R77f174556ac9450a"/>
+    <p:sldId xmlns:r="http://schemas.openxmlformats.org/officeDocument/2006/relationships" id="263" r:id="R8034bc1f52404d43"/>
+    <p:sldId xmlns:r="http://schemas.openxmlformats.org/officeDocument/2006/relationships" id="264" r:id="R26beb8a8ec2d4ee9"/>
+    <p:sldId xmlns:r="http://schemas.openxmlformats.org/officeDocument/2006/relationships" id="265" r:id="Rd9e61c2ac3fc4520"/>
+    <p:sldId xmlns:r="http://schemas.openxmlformats.org/officeDocument/2006/relationships" id="266" r:id="R48e5bd684ebd4732"/>
+    <p:sldId xmlns:r="http://schemas.openxmlformats.org/officeDocument/2006/relationships" id="267" r:id="Reaaf11a616584fff"/>
+    <p:sldId xmlns:r="http://schemas.openxmlformats.org/officeDocument/2006/relationships" id="268" r:id="Rfc3d871c09d34091"/>
   </p:sldIdLst>
   <p:sldSz cx="12192000" cy="6858000"/>
   <p:notesSz cx="6858000" cy="9144000"/>
@@ -595,7 +594,7 @@
           <a:lstStyle xmlns:a="http://schemas.openxmlformats.org/drawingml/2006/main"/>
           <a:p xmlns:a="http://schemas.openxmlformats.org/drawingml/2006/main">
             <a:r>
-              <a:t>Source image: public/assets/ai-lumina-river.png, a local Lumina3D screenshot showing the playable river candidate and timed bridge objective. Source workflow: Lumina3D docs/ai-prompt-workflow/README.md. A human captures selected-object, transform, collision and visual context; AI diagnoses and proposes a minimal source patch; the developer verifies with build, scene checks and play. Case page: https://jonathankhobson.github.io/portfolio/ai/case/lumina/ . The screenshot is gameplay evidence, not proof of an autonomous game-playing agent. The current local candidate is separate from the older public repository. No public release, success-rate or model capability result is claimed.</a:t>
+              <a:t>Source image: case-library/ai-assisted-web-evolution/site/assets/portfolio-2026-09.png, an original screenshot of Kyle’s earlier public portfolio presentation. Public Applied AI destination: https://jonathankhobson.github.io/portfolio/ai/ . Case page: https://jonathankhobson.github.io/portfolio/ai/case/making-the-portfolio/ . The workflow is evidence selection, AI-assisted drafting and integration into the public site with human claim review. This image predates the current visual case refinements; it is not a screenshot of an autonomous publishing system or a measured conversion result.</a:t>
             </a:r>
           </a:p>
         </p:txBody>
@@ -665,7 +664,7 @@
           <a:lstStyle xmlns:a="http://schemas.openxmlformats.org/drawingml/2006/main"/>
           <a:p xmlns:a="http://schemas.openxmlformats.org/drawingml/2006/main">
             <a:r>
-              <a:t>Source image: case-library/ai-assisted-web-evolution/site/assets/portfolio-2026-09.png, an original screenshot of Kyle’s earlier public portfolio presentation. Public Applied AI destination: https://jonathankhobson.github.io/portfolio/ai/ . Case page: https://jonathankhobson.github.io/portfolio/ai/case/making-the-portfolio/ . The workflow is evidence selection, AI-assisted drafting and integration into the public site with human claim review. This image predates the current visual case refinements; it is not a screenshot of an autonomous publishing system or a measured conversion result.</a:t>
+              <a:t>This editorial connection draws on Kyle’s self-described documentary filmmaking background, reviewed learning-design roles and published AI instruction. It frames his applied-AI approach without claiming production machine-learning engineering or measured client ROI. The portrait is a user-supplied personal image.</a:t>
             </a:r>
           </a:p>
         </p:txBody>
@@ -696,76 +695,6 @@
 </file>
 
 <file path=ppt/notesSlides/notesSlide13.xml><?xml version="1.0" encoding="utf-8"?>
-<p:notes xmlns:p="http://schemas.openxmlformats.org/presentationml/2006/main">
-  <p:cSld>
-    <p:spTree>
-      <p:nvGrpSpPr>
-        <p:cNvPr id="1" name=""/>
-        <p:cNvGrpSpPr/>
-        <p:nvPr/>
-      </p:nvGrpSpPr>
-      <p:grpSpPr>
-        <a:xfrm xmlns:a="http://schemas.openxmlformats.org/drawingml/2006/main"/>
-      </p:grpSpPr>
-      <p:sp>
-        <p:nvSpPr>
-          <p:cNvPr id="2" name="Slide Image Placeholder 1"/>
-          <p:cNvSpPr>
-            <a:spLocks xmlns:a="http://schemas.openxmlformats.org/drawingml/2006/main" noGrp="1"/>
-          </p:cNvSpPr>
-          <p:nvPr>
-            <p:ph type="sldImg" idx="0"/>
-          </p:nvPr>
-        </p:nvSpPr>
-        <p:spPr/>
-      </p:sp>
-      <p:sp>
-        <p:nvSpPr>
-          <p:cNvPr id="3" name="Notes Placeholder 2"/>
-          <p:cNvSpPr>
-            <a:spLocks xmlns:a="http://schemas.openxmlformats.org/drawingml/2006/main" noGrp="1"/>
-          </p:cNvSpPr>
-          <p:nvPr>
-            <p:ph type="body" idx="1"/>
-          </p:nvPr>
-        </p:nvSpPr>
-        <p:spPr/>
-        <p:txBody>
-          <a:bodyPr xmlns:a="http://schemas.openxmlformats.org/drawingml/2006/main"/>
-          <a:lstStyle xmlns:a="http://schemas.openxmlformats.org/drawingml/2006/main"/>
-          <a:p xmlns:a="http://schemas.openxmlformats.org/drawingml/2006/main">
-            <a:r>
-              <a:t>This editorial connection draws on Kyle’s self-described documentary filmmaking background, reviewed learning-design roles and published AI instruction. It frames his applied-AI approach without claiming production machine-learning engineering or measured client ROI. The portrait is a user-supplied personal image.</a:t>
-            </a:r>
-          </a:p>
-        </p:txBody>
-      </p:sp>
-      <p:sp>
-        <p:nvSpPr>
-          <p:cNvPr id="4" name="Slide Number Placeholder 3"/>
-          <p:cNvSpPr>
-            <a:spLocks xmlns:a="http://schemas.openxmlformats.org/drawingml/2006/main" noGrp="1"/>
-          </p:cNvSpPr>
-          <p:nvPr>
-            <p:ph type="sldNum" idx="5"/>
-          </p:nvPr>
-        </p:nvSpPr>
-        <p:spPr/>
-        <p:txBody>
-          <a:bodyPr xmlns:a="http://schemas.openxmlformats.org/drawingml/2006/main"/>
-          <a:lstStyle xmlns:a="http://schemas.openxmlformats.org/drawingml/2006/main"/>
-          <a:p xmlns:a="http://schemas.openxmlformats.org/drawingml/2006/main"/>
-        </p:txBody>
-      </p:sp>
-    </p:spTree>
-  </p:cSld>
-  <p:clrMapOvr>
-    <a:masterClrMapping xmlns:a="http://schemas.openxmlformats.org/drawingml/2006/main"/>
-  </p:clrMapOvr>
-</p:notes>
-</file>
-
-<file path=ppt/notesSlides/notesSlide14.xml><?xml version="1.0" encoding="utf-8"?>
 <p:notes xmlns:p="http://schemas.openxmlformats.org/presentationml/2006/main">
   <p:cSld>
     <p:spTree>
@@ -1433,7 +1362,7 @@
   </p:cSld>
   <p:clrMap bg1="lt1" tx1="dk1" bg2="lt2" tx2="dk2" accent1="accent1" accent2="accent2" accent3="accent3" accent4="accent4" accent5="accent5" accent6="accent6" hlink="hlink" folHlink="folHlink"/>
   <p:sldLayoutIdLst>
-    <p:sldLayoutId xmlns:r="http://schemas.openxmlformats.org/officeDocument/2006/relationships" id="2147483649" r:id="R033c7b51478f48bd"/>
+    <p:sldLayoutId xmlns:r="http://schemas.openxmlformats.org/officeDocument/2006/relationships" id="2147483649" r:id="Re3863c0b92824793"/>
   </p:sldLayoutIdLst>
   <p:txStyles>
     <p:titleStyle>
@@ -1984,7 +1913,7 @@
           <p:cNvPr id="7" name="section-label">
             <a:extLst xmlns:a="http://schemas.openxmlformats.org/drawingml/2006/main">
               <a:ext uri="{FF2B5EF4-FFF2-40B4-BE49-F238E27FC236}">
-                <a16:creationId xmlns:a16="http://schemas.microsoft.com/office/drawing/2014/main" id="{0168E38D-8DF3-4C7D-9EF5-D420C5005A52}"/>
+                <a16:creationId xmlns:a16="http://schemas.microsoft.com/office/drawing/2014/main" id="{DA5F72E1-EE5D-431E-868C-7C51A0C77289}"/>
               </a:ext>
             </a:extLst>
           </p:cNvPr>
@@ -2045,7 +1974,7 @@
           <p:cNvPr id="2" name="headline">
             <a:extLst xmlns:a="http://schemas.openxmlformats.org/drawingml/2006/main">
               <a:ext uri="{FF2B5EF4-FFF2-40B4-BE49-F238E27FC236}">
-                <a16:creationId xmlns:a16="http://schemas.microsoft.com/office/drawing/2014/main" id="{7B0E7B8C-9D4F-4946-847D-90E3C6109A65}"/>
+                <a16:creationId xmlns:a16="http://schemas.microsoft.com/office/drawing/2014/main" id="{18B39D00-FCCA-43C4-A97E-73EFEE2B0389}"/>
               </a:ext>
             </a:extLst>
           </p:cNvPr>
@@ -2137,7 +2066,7 @@
           <p:nvPr/>
         </p:nvPicPr>
         <p:blipFill>
-          <a:blip xmlns:r="http://schemas.openxmlformats.org/officeDocument/2006/relationships" xmlns:a="http://schemas.openxmlformats.org/drawingml/2006/main" r:embed="Re92fea9c4103427b"/>
+          <a:blip xmlns:r="http://schemas.openxmlformats.org/officeDocument/2006/relationships" xmlns:a="http://schemas.openxmlformats.org/drawingml/2006/main" r:embed="R6f7b2e91c7094a70"/>
           <a:stretch xmlns:a="http://schemas.openxmlformats.org/drawingml/2006/main"/>
         </p:blipFill>
         <p:spPr>
@@ -2155,7 +2084,7 @@
           <p:cNvPr id="4" name="cover-intro">
             <a:extLst xmlns:a="http://schemas.openxmlformats.org/drawingml/2006/main">
               <a:ext uri="{FF2B5EF4-FFF2-40B4-BE49-F238E27FC236}">
-                <a16:creationId xmlns:a16="http://schemas.microsoft.com/office/drawing/2014/main" id="{C9CB9851-322B-4B4E-9F01-7E8B1D75E58F}"/>
+                <a16:creationId xmlns:a16="http://schemas.microsoft.com/office/drawing/2014/main" id="{38EE7DFB-8D73-446B-B88F-C95ACBBDFD5C}"/>
               </a:ext>
             </a:extLst>
           </p:cNvPr>
@@ -2270,7 +2199,7 @@
           <p:cNvPr id="5" name="cover-role">
             <a:extLst xmlns:a="http://schemas.openxmlformats.org/drawingml/2006/main">
               <a:ext uri="{FF2B5EF4-FFF2-40B4-BE49-F238E27FC236}">
-                <a16:creationId xmlns:a16="http://schemas.microsoft.com/office/drawing/2014/main" id="{09387CE2-4E41-4E93-A858-2990F14651D1}"/>
+                <a16:creationId xmlns:a16="http://schemas.microsoft.com/office/drawing/2014/main" id="{D3CE0A40-5940-4145-ADD3-A77E3423C77E}"/>
               </a:ext>
             </a:extLst>
           </p:cNvPr>
@@ -2358,7 +2287,7 @@
           <p:cNvPr id="6" name="slide-number">
             <a:extLst xmlns:a="http://schemas.openxmlformats.org/drawingml/2006/main">
               <a:ext uri="{FF2B5EF4-FFF2-40B4-BE49-F238E27FC236}">
-                <a16:creationId xmlns:a16="http://schemas.microsoft.com/office/drawing/2014/main" id="{E1050CCA-2947-41E9-9FA1-84553A1A1E65}"/>
+                <a16:creationId xmlns:a16="http://schemas.microsoft.com/office/drawing/2014/main" id="{A5D7B427-F90A-477D-9CD2-87FF6B72B0F6}"/>
               </a:ext>
             </a:extLst>
           </p:cNvPr>
@@ -2417,7 +2346,7 @@
     </p:spTree>
     <p:extLst>
       <p:ext uri="{BB962C8B-B14F-4D97-AF65-F5344CB8AC3E}">
-        <p14:creationId xmlns:p14="http://schemas.microsoft.com/office/powerpoint/2010/main" val="274552175"/>
+        <p14:creationId xmlns:p14="http://schemas.microsoft.com/office/powerpoint/2010/main" val="66673492"/>
       </p:ext>
     </p:extLst>
   </p:cSld>
@@ -2448,7 +2377,7 @@
           <p:cNvPr id="7" name="section-label">
             <a:extLst xmlns:a="http://schemas.openxmlformats.org/drawingml/2006/main">
               <a:ext uri="{FF2B5EF4-FFF2-40B4-BE49-F238E27FC236}">
-                <a16:creationId xmlns:a16="http://schemas.microsoft.com/office/drawing/2014/main" id="{CF1B556B-5902-4D3D-879B-A77948FC1DE6}"/>
+                <a16:creationId xmlns:a16="http://schemas.microsoft.com/office/drawing/2014/main" id="{C62DBD11-7928-4378-8A53-6E246796E7E5}"/>
               </a:ext>
             </a:extLst>
           </p:cNvPr>
@@ -2509,7 +2438,7 @@
           <p:cNvPr id="2" name="headline">
             <a:extLst xmlns:a="http://schemas.openxmlformats.org/drawingml/2006/main">
               <a:ext uri="{FF2B5EF4-FFF2-40B4-BE49-F238E27FC236}">
-                <a16:creationId xmlns:a16="http://schemas.microsoft.com/office/drawing/2014/main" id="{4BF4AB73-6A8F-4C3B-85FD-ABD2119245E9}"/>
+                <a16:creationId xmlns:a16="http://schemas.microsoft.com/office/drawing/2014/main" id="{712F1744-9C56-412E-B5A1-C9777ADDEEF8}"/>
               </a:ext>
             </a:extLst>
           </p:cNvPr>
@@ -2597,7 +2526,7 @@
           <p:cNvPr id="3" name="asu-purpose">
             <a:extLst xmlns:a="http://schemas.openxmlformats.org/drawingml/2006/main">
               <a:ext uri="{FF2B5EF4-FFF2-40B4-BE49-F238E27FC236}">
-                <a16:creationId xmlns:a16="http://schemas.microsoft.com/office/drawing/2014/main" id="{8F4593FF-732E-4485-A06B-C11636456306}"/>
+                <a16:creationId xmlns:a16="http://schemas.microsoft.com/office/drawing/2014/main" id="{7BC4865D-893A-4E41-98FD-91EAD30B6DEA}"/>
               </a:ext>
             </a:extLst>
           </p:cNvPr>
@@ -2662,7 +2591,7 @@
           <p:nvPr/>
         </p:nvPicPr>
         <p:blipFill>
-          <a:blip xmlns:r="http://schemas.openxmlformats.org/officeDocument/2006/relationships" xmlns:a="http://schemas.openxmlformats.org/drawingml/2006/main" r:embed="R444cfc0a62e24116"/>
+          <a:blip xmlns:r="http://schemas.openxmlformats.org/officeDocument/2006/relationships" xmlns:a="http://schemas.openxmlformats.org/drawingml/2006/main" r:embed="R7d05f15e86ea48ba"/>
           <a:stretch xmlns:a="http://schemas.openxmlformats.org/drawingml/2006/main"/>
         </p:blipFill>
         <p:spPr>
@@ -2680,7 +2609,7 @@
           <p:cNvPr id="5" name="asu-stage">
             <a:extLst xmlns:a="http://schemas.openxmlformats.org/drawingml/2006/main">
               <a:ext uri="{FF2B5EF4-FFF2-40B4-BE49-F238E27FC236}">
-                <a16:creationId xmlns:a16="http://schemas.microsoft.com/office/drawing/2014/main" id="{CEADAC50-9255-4012-8333-DD98E4F21043}"/>
+                <a16:creationId xmlns:a16="http://schemas.microsoft.com/office/drawing/2014/main" id="{914FA87A-5703-4AFD-B903-8E8B579565D0}"/>
               </a:ext>
             </a:extLst>
           </p:cNvPr>
@@ -2741,7 +2670,7 @@
           <p:cNvPr id="6" name="slide-number">
             <a:extLst xmlns:a="http://schemas.openxmlformats.org/drawingml/2006/main">
               <a:ext uri="{FF2B5EF4-FFF2-40B4-BE49-F238E27FC236}">
-                <a16:creationId xmlns:a16="http://schemas.microsoft.com/office/drawing/2014/main" id="{588F70A2-C2C3-4131-B6D7-D6DA64273C39}"/>
+                <a16:creationId xmlns:a16="http://schemas.microsoft.com/office/drawing/2014/main" id="{31688481-2D09-4500-B2AF-318AF1D512C9}"/>
               </a:ext>
             </a:extLst>
           </p:cNvPr>
@@ -2800,7 +2729,7 @@
     </p:spTree>
     <p:extLst>
       <p:ext uri="{BB962C8B-B14F-4D97-AF65-F5344CB8AC3E}">
-        <p14:creationId xmlns:p14="http://schemas.microsoft.com/office/powerpoint/2010/main" val="473011641"/>
+        <p14:creationId xmlns:p14="http://schemas.microsoft.com/office/powerpoint/2010/main" val="2137463032"/>
       </p:ext>
     </p:extLst>
   </p:cSld>
@@ -2828,10 +2757,10 @@
       </p:grpSpPr>
       <p:sp>
         <p:nvSpPr>
-          <p:cNvPr id="9" name="section-label">
+          <p:cNvPr id="10" name="section-label">
             <a:extLst xmlns:a="http://schemas.openxmlformats.org/drawingml/2006/main">
               <a:ext uri="{FF2B5EF4-FFF2-40B4-BE49-F238E27FC236}">
-                <a16:creationId xmlns:a16="http://schemas.microsoft.com/office/drawing/2014/main" id="{79419B5A-84FE-48D7-A954-27EFFC437B80}"/>
+                <a16:creationId xmlns:a16="http://schemas.microsoft.com/office/drawing/2014/main" id="{21501E11-C6FD-435A-B005-9A85A2484E49}"/>
               </a:ext>
             </a:extLst>
           </p:cNvPr>
@@ -2882,7 +2811,7 @@
                 <a:ea typeface="Helvetica Neue"/>
                 <a:cs typeface="Helvetica Neue"/>
               </a:rPr>
-              <a:t>LUMINA3D   /   LOCAL PLAYABLE CANDIDATE, 2026</a:t>
+              <a:t>PORTFOLIO MAKING   /   ORIGINAL PUBLIC SITE, 2026</a:t>
             </a:r>
           </a:p>
         </p:txBody>
@@ -2892,7 +2821,7 @@
           <p:cNvPr id="2" name="headline">
             <a:extLst xmlns:a="http://schemas.openxmlformats.org/drawingml/2006/main">
               <a:ext uri="{FF2B5EF4-FFF2-40B4-BE49-F238E27FC236}">
-                <a16:creationId xmlns:a16="http://schemas.microsoft.com/office/drawing/2014/main" id="{2DD94AF9-53FA-413E-890E-7E7125C12287}"/>
+                <a16:creationId xmlns:a16="http://schemas.microsoft.com/office/drawing/2014/main" id="{EA1F906A-6C7B-4E23-BF50-756C2313B49A}"/>
               </a:ext>
             </a:extLst>
           </p:cNvPr>
@@ -2943,7 +2872,7 @@
                 <a:ea typeface="Helvetica Neue"/>
                 <a:cs typeface="Helvetica Neue"/>
               </a:rPr>
-              <a:t>Spatial context guides</a:t>
+              <a:t>The portfolio is part</a:t>
             </a:r>
           </a:p>
           <a:p xmlns:a="http://schemas.openxmlformats.org/drawingml/2006/main">
@@ -2970,27 +2899,27 @@
                 <a:ea typeface="Helvetica Neue"/>
                 <a:cs typeface="Helvetica Neue"/>
               </a:rPr>
-              <a:t>AI-assisted edits</a:t>
+              <a:t>of the AI workflow</a:t>
             </a:r>
           </a:p>
         </p:txBody>
       </p:sp>
       <p:pic>
         <p:nvPicPr>
-          <p:cNvPr id="11" name=""/>
+          <p:cNvPr id="12" name=""/>
           <p:cNvPicPr>
             <a:picLocks xmlns:a="http://schemas.openxmlformats.org/drawingml/2006/main" noChangeAspect="1"/>
           </p:cNvPicPr>
           <p:nvPr/>
         </p:nvPicPr>
         <p:blipFill>
-          <a:blip xmlns:r="http://schemas.openxmlformats.org/officeDocument/2006/relationships" xmlns:a="http://schemas.openxmlformats.org/drawingml/2006/main" r:embed="R98461685271e4624"/>
+          <a:blip xmlns:r="http://schemas.openxmlformats.org/officeDocument/2006/relationships" xmlns:a="http://schemas.openxmlformats.org/drawingml/2006/main" r:embed="Rb692713e58db4dd5"/>
           <a:stretch xmlns:a="http://schemas.openxmlformats.org/drawingml/2006/main"/>
         </p:blipFill>
         <p:spPr>
           <a:xfrm xmlns:a="http://schemas.openxmlformats.org/drawingml/2006/main">
-            <a:off x="1479033" y="2286000"/>
-            <a:ext cx="6281184" cy="3971925"/>
+            <a:off x="1716977" y="2286000"/>
+            <a:ext cx="5719572" cy="3971925"/>
           </a:xfrm>
           <a:prstGeom xmlns:a="http://schemas.openxmlformats.org/drawingml/2006/main" prst="rect">
             <a:avLst/>
@@ -2999,10 +2928,10 @@
       </p:pic>
       <p:sp>
         <p:nvSpPr>
-          <p:cNvPr id="4" name="lumina-purpose">
+          <p:cNvPr id="4" name="portfolio-purpose">
             <a:extLst xmlns:a="http://schemas.openxmlformats.org/drawingml/2006/main">
               <a:ext uri="{FF2B5EF4-FFF2-40B4-BE49-F238E27FC236}">
-                <a16:creationId xmlns:a16="http://schemas.microsoft.com/office/drawing/2014/main" id="{62CDFC7A-A401-42C4-AA1F-E357F6608CA0}"/>
+                <a16:creationId xmlns:a16="http://schemas.microsoft.com/office/drawing/2014/main" id="{458FF332-2D70-42AA-BFC7-365951C77A89}"/>
               </a:ext>
             </a:extLst>
           </p:cNvPr>
@@ -3013,8 +2942,8 @@
         </p:nvSpPr>
         <p:spPr>
           <a:xfrm xmlns:a="http://schemas.openxmlformats.org/drawingml/2006/main">
-            <a:off x="8991600" y="2428875"/>
-            <a:ext cx="2562225" cy="1714500"/>
+            <a:off x="8896350" y="2419350"/>
+            <a:ext cx="2657475" cy="1714500"/>
           </a:xfrm>
           <a:prstGeom xmlns:a="http://schemas.openxmlformats.org/drawingml/2006/main" prst="rect">
             <a:avLst/>
@@ -3053,17 +2982,17 @@
                 <a:ea typeface="Helvetica Neue"/>
                 <a:cs typeface="Helvetica Neue"/>
               </a:rPr>
-              <a:t>I capture the selected object, position and collision context before asking AI to diagnose a scene bug.</a:t>
-            </a:r>
-          </a:p>
-        </p:txBody>
-      </p:sp>
-      <p:sp>
-        <p:nvSpPr>
-          <p:cNvPr id="5" name="lumina-detail">
+              <a:t>I use AI to organize source material and test drafts, then check each public claim against its evidence.</a:t>
+            </a:r>
+          </a:p>
+        </p:txBody>
+      </p:sp>
+      <p:sp>
+        <p:nvSpPr>
+          <p:cNvPr id="5" name="portfolio-detail">
             <a:extLst xmlns:a="http://schemas.openxmlformats.org/drawingml/2006/main">
               <a:ext uri="{FF2B5EF4-FFF2-40B4-BE49-F238E27FC236}">
-                <a16:creationId xmlns:a16="http://schemas.microsoft.com/office/drawing/2014/main" id="{8C130CBA-9D78-4907-BFA1-29B396349218}"/>
+                <a16:creationId xmlns:a16="http://schemas.microsoft.com/office/drawing/2014/main" id="{40E76C17-5B13-455B-9F59-B857AFBBB57E}"/>
               </a:ext>
             </a:extLst>
           </p:cNvPr>
@@ -3074,8 +3003,8 @@
         </p:nvSpPr>
         <p:spPr>
           <a:xfrm xmlns:a="http://schemas.openxmlformats.org/drawingml/2006/main">
-            <a:off x="8991600" y="4505325"/>
-            <a:ext cx="2562225" cy="1190625"/>
+            <a:off x="8896350" y="4629150"/>
+            <a:ext cx="2657475" cy="1057275"/>
           </a:xfrm>
           <a:prstGeom xmlns:a="http://schemas.openxmlformats.org/drawingml/2006/main" prst="rect">
             <a:avLst/>
@@ -3114,17 +3043,78 @@
                 <a:ea typeface="Helvetica Neue"/>
                 <a:cs typeface="Helvetica Neue"/>
               </a:rPr>
-              <a:t>The AI proposes a small source change. I check it with a build, scene tests and play.</a:t>
-            </a:r>
-          </a:p>
-        </p:txBody>
-      </p:sp>
-      <p:sp>
-        <p:nvSpPr>
-          <p:cNvPr id="6" name="lumina-case-background">
+              <a:t>The result connects a working example to its case, context and next action.</a:t>
+            </a:r>
+          </a:p>
+        </p:txBody>
+      </p:sp>
+      <p:sp>
+        <p:nvSpPr>
+          <p:cNvPr id="6" name="portfolio-image-status">
             <a:extLst xmlns:a="http://schemas.openxmlformats.org/drawingml/2006/main">
               <a:ext uri="{FF2B5EF4-FFF2-40B4-BE49-F238E27FC236}">
-                <a16:creationId xmlns:a16="http://schemas.microsoft.com/office/drawing/2014/main" id="{F0078BE6-2C1B-43B7-9673-5A23C98C0DCB}"/>
+                <a16:creationId xmlns:a16="http://schemas.microsoft.com/office/drawing/2014/main" id="{B75A1103-15EB-4E2B-9915-E65C07727D22}"/>
+              </a:ext>
+            </a:extLst>
+          </p:cNvPr>
+          <p:cNvSpPr>
+            <a:spLocks xmlns:a="http://schemas.openxmlformats.org/drawingml/2006/main" noGrp="1"/>
+          </p:cNvSpPr>
+          <p:nvPr/>
+        </p:nvSpPr>
+        <p:spPr>
+          <a:xfrm xmlns:a="http://schemas.openxmlformats.org/drawingml/2006/main">
+            <a:off x="609600" y="6286500"/>
+            <a:ext cx="7953375" cy="238125"/>
+          </a:xfrm>
+          <a:prstGeom xmlns:a="http://schemas.openxmlformats.org/drawingml/2006/main" prst="rect">
+            <a:avLst/>
+          </a:prstGeom>
+          <a:noFill xmlns:a="http://schemas.openxmlformats.org/drawingml/2006/main"/>
+          <a:ln xmlns:a="http://schemas.openxmlformats.org/drawingml/2006/main" w="0">
+            <a:noFill/>
+          </a:ln>
+        </p:spPr>
+        <p:txBody>
+          <a:bodyPr xmlns:a="http://schemas.openxmlformats.org/drawingml/2006/main" wrap="square" lIns="0" tIns="0" rIns="0" bIns="0" anchor="t">
+            <a:noAutofit/>
+          </a:bodyPr>
+          <a:lstStyle xmlns:a="http://schemas.openxmlformats.org/drawingml/2006/main"/>
+          <a:p xmlns:a="http://schemas.openxmlformats.org/drawingml/2006/main">
+            <a:pPr>
+              <a:lnSpc>
+                <a:spcPct val="110000"/>
+              </a:lnSpc>
+              <a:buNone/>
+              <a:defRPr sz="1275" b="0">
+                <a:solidFill>
+                  <a:srgbClr val="58645D"/>
+                </a:solidFill>
+                <a:latin typeface="Helvetica Neue"/>
+                <a:ea typeface="Helvetica Neue"/>
+                <a:cs typeface="Helvetica Neue"/>
+              </a:defRPr>
+            </a:pPr>
+            <a:r>
+              <a:rPr sz="1275" b="0">
+                <a:solidFill>
+                  <a:srgbClr val="58645D"/>
+                </a:solidFill>
+                <a:latin typeface="Helvetica Neue"/>
+                <a:ea typeface="Helvetica Neue"/>
+                <a:cs typeface="Helvetica Neue"/>
+              </a:rPr>
+              <a:t>Earlier portfolio presentation, before visual case refinements</a:t>
+            </a:r>
+          </a:p>
+        </p:txBody>
+      </p:sp>
+      <p:sp>
+        <p:nvSpPr>
+          <p:cNvPr id="7" name="portfolio-case-background">
+            <a:extLst xmlns:a="http://schemas.openxmlformats.org/drawingml/2006/main">
+              <a:ext uri="{FF2B5EF4-FFF2-40B4-BE49-F238E27FC236}">
+                <a16:creationId xmlns:a16="http://schemas.microsoft.com/office/drawing/2014/main" id="{65909BE0-A281-4063-908A-11C7F89C29BD}"/>
               </a:ext>
             </a:extLst>
           </p:cNvPr>
@@ -3151,10 +3141,10 @@
       </p:sp>
       <p:sp>
         <p:nvSpPr>
-          <p:cNvPr id="7" name="lumina-case-link">
+          <p:cNvPr id="8" name="portfolio-case-link">
             <a:extLst xmlns:a="http://schemas.openxmlformats.org/drawingml/2006/main">
               <a:ext uri="{FF2B5EF4-FFF2-40B4-BE49-F238E27FC236}">
-                <a16:creationId xmlns:a16="http://schemas.microsoft.com/office/drawing/2014/main" id="{1F22B30B-F18D-431A-9CDB-21EEAE7813A4}"/>
+                <a16:creationId xmlns:a16="http://schemas.microsoft.com/office/drawing/2014/main" id="{1E9E2F09-0366-4D4A-AA7D-805BF74491F3}"/>
               </a:ext>
             </a:extLst>
           </p:cNvPr>
@@ -3204,7 +3194,7 @@
                 <a:latin typeface="Helvetica Neue"/>
                 <a:ea typeface="Helvetica Neue"/>
                 <a:cs typeface="Helvetica Neue"/>
-                <a:hlinkClick xmlns:r="http://schemas.openxmlformats.org/officeDocument/2006/relationships" r:id="Ra20fcaa4c4c742ad"/>
+                <a:hlinkClick xmlns:r="http://schemas.openxmlformats.org/officeDocument/2006/relationships" r:id="R28dcfa2c78f14ba6"/>
               </a:rPr>
               <a:t>View the case →</a:t>
             </a:r>
@@ -3213,10 +3203,10 @@
       </p:sp>
       <p:sp>
         <p:nvSpPr>
-          <p:cNvPr id="8" name="slide-number">
+          <p:cNvPr id="9" name="slide-number">
             <a:extLst xmlns:a="http://schemas.openxmlformats.org/drawingml/2006/main">
               <a:ext uri="{FF2B5EF4-FFF2-40B4-BE49-F238E27FC236}">
-                <a16:creationId xmlns:a16="http://schemas.microsoft.com/office/drawing/2014/main" id="{F7CD9389-2901-489B-8867-46C4272809F2}"/>
+                <a16:creationId xmlns:a16="http://schemas.microsoft.com/office/drawing/2014/main" id="{D3A433B8-BFD0-4725-8498-BB9E3054D220}"/>
               </a:ext>
             </a:extLst>
           </p:cNvPr>
@@ -3275,7 +3265,7 @@
     </p:spTree>
     <p:extLst>
       <p:ext uri="{BB962C8B-B14F-4D97-AF65-F5344CB8AC3E}">
-        <p14:creationId xmlns:p14="http://schemas.microsoft.com/office/powerpoint/2010/main" val="1249901970"/>
+        <p14:creationId xmlns:p14="http://schemas.microsoft.com/office/powerpoint/2010/main" val="264936365"/>
       </p:ext>
     </p:extLst>
   </p:cSld>
@@ -3303,10 +3293,10 @@
       </p:grpSpPr>
       <p:sp>
         <p:nvSpPr>
-          <p:cNvPr id="10" name="section-label">
+          <p:cNvPr id="7" name="section-label">
             <a:extLst xmlns:a="http://schemas.openxmlformats.org/drawingml/2006/main">
               <a:ext uri="{FF2B5EF4-FFF2-40B4-BE49-F238E27FC236}">
-                <a16:creationId xmlns:a16="http://schemas.microsoft.com/office/drawing/2014/main" id="{A999F192-BA08-4EEA-8048-A3F00875C5C7}"/>
+                <a16:creationId xmlns:a16="http://schemas.microsoft.com/office/drawing/2014/main" id="{D6922405-859E-433C-9DAE-E57221E7A8A9}"/>
               </a:ext>
             </a:extLst>
           </p:cNvPr>
@@ -3317,8 +3307,8 @@
         </p:nvSpPr>
         <p:spPr>
           <a:xfrm xmlns:a="http://schemas.openxmlformats.org/drawingml/2006/main">
-            <a:off x="609600" y="495300"/>
-            <a:ext cx="10668000" cy="266700"/>
+            <a:off x="609600" y="514350"/>
+            <a:ext cx="6477000" cy="266700"/>
           </a:xfrm>
           <a:prstGeom xmlns:a="http://schemas.openxmlformats.org/drawingml/2006/main" prst="rect">
             <a:avLst/>
@@ -3357,7 +3347,7 @@
                 <a:ea typeface="Helvetica Neue"/>
                 <a:cs typeface="Helvetica Neue"/>
               </a:rPr>
-              <a:t>PORTFOLIO MAKING   /   ORIGINAL PUBLIC SITE, 2026</a:t>
+              <a:t>THE THREAD THROUGH MY WORK</a:t>
             </a:r>
           </a:p>
         </p:txBody>
@@ -3367,7 +3357,7 @@
           <p:cNvPr id="2" name="headline">
             <a:extLst xmlns:a="http://schemas.openxmlformats.org/drawingml/2006/main">
               <a:ext uri="{FF2B5EF4-FFF2-40B4-BE49-F238E27FC236}">
-                <a16:creationId xmlns:a16="http://schemas.microsoft.com/office/drawing/2014/main" id="{07DEB018-8998-465F-AD57-A6B2AF0E3723}"/>
+                <a16:creationId xmlns:a16="http://schemas.microsoft.com/office/drawing/2014/main" id="{40E130DD-4744-4149-8EB9-885457FD35F6}"/>
               </a:ext>
             </a:extLst>
           </p:cNvPr>
@@ -3378,8 +3368,8 @@
         </p:nvSpPr>
         <p:spPr>
           <a:xfrm xmlns:a="http://schemas.openxmlformats.org/drawingml/2006/main">
-            <a:off x="609600" y="1057275"/>
-            <a:ext cx="10896600" cy="1143000"/>
+            <a:off x="609600" y="1352550"/>
+            <a:ext cx="5905500" cy="1485900"/>
           </a:xfrm>
           <a:prstGeom xmlns:a="http://schemas.openxmlformats.org/drawingml/2006/main" prst="rect">
             <a:avLst/>
@@ -3400,7 +3390,7 @@
                 <a:spcPct val="110000"/>
               </a:lnSpc>
               <a:buNone/>
-              <a:defRPr sz="3600" b="1">
+              <a:defRPr sz="3750" b="1">
                 <a:solidFill>
                   <a:srgbClr val="192B25"/>
                 </a:solidFill>
@@ -3410,7 +3400,7 @@
               </a:defRPr>
             </a:pPr>
             <a:r>
-              <a:rPr sz="3600" b="1">
+              <a:rPr sz="3750" b="1">
                 <a:solidFill>
                   <a:srgbClr val="192B25"/>
                 </a:solidFill>
@@ -3418,16 +3408,16 @@
                 <a:ea typeface="Helvetica Neue"/>
                 <a:cs typeface="Helvetica Neue"/>
               </a:rPr>
-              <a:t>The portfolio is part</a:t>
-            </a:r>
-          </a:p>
-          <a:p xmlns:a="http://schemas.openxmlformats.org/drawingml/2006/main">
-            <a:pPr>
-              <a:lnSpc>
-                <a:spcPct val="110000"/>
-              </a:lnSpc>
-              <a:buNone/>
-              <a:defRPr sz="3600" b="1">
+              <a:t>The person using</a:t>
+            </a:r>
+          </a:p>
+          <a:p xmlns:a="http://schemas.openxmlformats.org/drawingml/2006/main">
+            <a:pPr>
+              <a:lnSpc>
+                <a:spcPct val="110000"/>
+              </a:lnSpc>
+              <a:buNone/>
+              <a:defRPr sz="3750" b="1">
                 <a:solidFill>
                   <a:srgbClr val="192B25"/>
                 </a:solidFill>
@@ -3437,7 +3427,7 @@
               </a:defRPr>
             </a:pPr>
             <a:r>
-              <a:rPr sz="3600" b="1">
+              <a:rPr sz="3750" b="1">
                 <a:solidFill>
                   <a:srgbClr val="192B25"/>
                 </a:solidFill>
@@ -3445,39 +3435,17 @@
                 <a:ea typeface="Helvetica Neue"/>
                 <a:cs typeface="Helvetica Neue"/>
               </a:rPr>
-              <a:t>of the AI workflow</a:t>
-            </a:r>
-          </a:p>
-        </p:txBody>
-      </p:sp>
-      <p:pic>
-        <p:nvPicPr>
-          <p:cNvPr id="12" name=""/>
-          <p:cNvPicPr>
-            <a:picLocks xmlns:a="http://schemas.openxmlformats.org/drawingml/2006/main" noChangeAspect="1"/>
-          </p:cNvPicPr>
-          <p:nvPr/>
-        </p:nvPicPr>
-        <p:blipFill>
-          <a:blip xmlns:r="http://schemas.openxmlformats.org/officeDocument/2006/relationships" xmlns:a="http://schemas.openxmlformats.org/drawingml/2006/main" r:embed="R1292b3510add4ddf"/>
-          <a:stretch xmlns:a="http://schemas.openxmlformats.org/drawingml/2006/main"/>
-        </p:blipFill>
-        <p:spPr>
-          <a:xfrm xmlns:a="http://schemas.openxmlformats.org/drawingml/2006/main">
-            <a:off x="1716977" y="2286000"/>
-            <a:ext cx="5719572" cy="3971925"/>
-          </a:xfrm>
-          <a:prstGeom xmlns:a="http://schemas.openxmlformats.org/drawingml/2006/main" prst="rect">
-            <a:avLst/>
-          </a:prstGeom>
-        </p:spPr>
-      </p:pic>
-      <p:sp>
-        <p:nvSpPr>
-          <p:cNvPr id="4" name="portfolio-purpose">
+              <a:t>the system matters</a:t>
+            </a:r>
+          </a:p>
+        </p:txBody>
+      </p:sp>
+      <p:sp>
+        <p:nvSpPr>
+          <p:cNvPr id="3" name="story-origin">
             <a:extLst xmlns:a="http://schemas.openxmlformats.org/drawingml/2006/main">
               <a:ext uri="{FF2B5EF4-FFF2-40B4-BE49-F238E27FC236}">
-                <a16:creationId xmlns:a16="http://schemas.microsoft.com/office/drawing/2014/main" id="{5C02D13F-5D6D-4CA6-AC10-B179C05A848E}"/>
+                <a16:creationId xmlns:a16="http://schemas.microsoft.com/office/drawing/2014/main" id="{E8DD5B6E-DD5B-47C8-A8DE-90A8C73505C7}"/>
               </a:ext>
             </a:extLst>
           </p:cNvPr>
@@ -3488,8 +3456,8 @@
         </p:nvSpPr>
         <p:spPr>
           <a:xfrm xmlns:a="http://schemas.openxmlformats.org/drawingml/2006/main">
-            <a:off x="8896350" y="2419350"/>
-            <a:ext cx="2657475" cy="1714500"/>
+            <a:off x="609600" y="3333750"/>
+            <a:ext cx="5572125" cy="1228725"/>
           </a:xfrm>
           <a:prstGeom xmlns:a="http://schemas.openxmlformats.org/drawingml/2006/main" prst="rect">
             <a:avLst/>
@@ -3510,7 +3478,7 @@
                 <a:spcPct val="110000"/>
               </a:lnSpc>
               <a:buNone/>
-              <a:defRPr sz="1800" b="0">
+              <a:defRPr sz="1950" b="0">
                 <a:solidFill>
                   <a:srgbClr val="192B25"/>
                 </a:solidFill>
@@ -3520,7 +3488,7 @@
               </a:defRPr>
             </a:pPr>
             <a:r>
-              <a:rPr sz="1800" b="0">
+              <a:rPr sz="1950" b="0">
                 <a:solidFill>
                   <a:srgbClr val="192B25"/>
                 </a:solidFill>
@@ -3528,17 +3496,17 @@
                 <a:ea typeface="Helvetica Neue"/>
                 <a:cs typeface="Helvetica Neue"/>
               </a:rPr>
-              <a:t>I use AI to organize source material and test drafts, then check each public claim against its evidence.</a:t>
-            </a:r>
-          </a:p>
-        </p:txBody>
-      </p:sp>
-      <p:sp>
-        <p:nvSpPr>
-          <p:cNvPr id="5" name="portfolio-detail">
+              <a:t>Documentary filmmaking taught me to listen closely. Learning design taught me to make the next step teachable.</a:t>
+            </a:r>
+          </a:p>
+        </p:txBody>
+      </p:sp>
+      <p:sp>
+        <p:nvSpPr>
+          <p:cNvPr id="4" name="story-ai">
             <a:extLst xmlns:a="http://schemas.openxmlformats.org/drawingml/2006/main">
               <a:ext uri="{FF2B5EF4-FFF2-40B4-BE49-F238E27FC236}">
-                <a16:creationId xmlns:a16="http://schemas.microsoft.com/office/drawing/2014/main" id="{FF2711F7-1978-494C-99C9-164790F2C42A}"/>
+                <a16:creationId xmlns:a16="http://schemas.microsoft.com/office/drawing/2014/main" id="{550B461D-DE73-4B04-892F-FD50B362FCD5}"/>
               </a:ext>
             </a:extLst>
           </p:cNvPr>
@@ -3549,8 +3517,8 @@
         </p:nvSpPr>
         <p:spPr>
           <a:xfrm xmlns:a="http://schemas.openxmlformats.org/drawingml/2006/main">
-            <a:off x="8896350" y="4629150"/>
-            <a:ext cx="2657475" cy="1057275"/>
+            <a:off x="609600" y="4953000"/>
+            <a:ext cx="5572125" cy="1209675"/>
           </a:xfrm>
           <a:prstGeom xmlns:a="http://schemas.openxmlformats.org/drawingml/2006/main" prst="rect">
             <a:avLst/>
@@ -3571,7 +3539,7 @@
                 <a:spcPct val="110000"/>
               </a:lnSpc>
               <a:buNone/>
-              <a:defRPr sz="1575" b="0">
+              <a:defRPr sz="1800" b="0">
                 <a:solidFill>
                   <a:srgbClr val="58645D"/>
                 </a:solidFill>
@@ -3581,7 +3549,7 @@
               </a:defRPr>
             </a:pPr>
             <a:r>
-              <a:rPr sz="1575" b="0">
+              <a:rPr sz="1800" b="0">
                 <a:solidFill>
                   <a:srgbClr val="58645D"/>
                 </a:solidFill>
@@ -3589,17 +3557,39 @@
                 <a:ea typeface="Helvetica Neue"/>
                 <a:cs typeface="Helvetica Neue"/>
               </a:rPr>
-              <a:t>The result connects a working example to its case, context and next action.</a:t>
-            </a:r>
-          </a:p>
-        </p:txBody>
-      </p:sp>
-      <p:sp>
-        <p:nvSpPr>
-          <p:cNvPr id="6" name="portfolio-image-status">
+              <a:t>That perspective carries into my AI work: understand the task, make the output inspectable, and leave room for human judgment.</a:t>
+            </a:r>
+          </a:p>
+        </p:txBody>
+      </p:sp>
+      <p:pic>
+        <p:nvPicPr>
+          <p:cNvPr id="11" name=""/>
+          <p:cNvPicPr>
+            <a:picLocks xmlns:a="http://schemas.openxmlformats.org/drawingml/2006/main" noChangeAspect="1"/>
+          </p:cNvPicPr>
+          <p:nvPr/>
+        </p:nvPicPr>
+        <p:blipFill>
+          <a:blip xmlns:r="http://schemas.openxmlformats.org/officeDocument/2006/relationships" xmlns:a="http://schemas.openxmlformats.org/drawingml/2006/main" r:embed="R44bccbc4bc8a4165"/>
+          <a:stretch xmlns:a="http://schemas.openxmlformats.org/drawingml/2006/main"/>
+        </p:blipFill>
+        <p:spPr>
+          <a:xfrm xmlns:a="http://schemas.openxmlformats.org/drawingml/2006/main">
+            <a:off x="7010400" y="1447800"/>
+            <a:ext cx="4876800" cy="4876800"/>
+          </a:xfrm>
+          <a:prstGeom xmlns:a="http://schemas.openxmlformats.org/drawingml/2006/main" prst="rect">
+            <a:avLst/>
+          </a:prstGeom>
+        </p:spPr>
+      </p:pic>
+      <p:sp>
+        <p:nvSpPr>
+          <p:cNvPr id="6" name="slide-number">
             <a:extLst xmlns:a="http://schemas.openxmlformats.org/drawingml/2006/main">
               <a:ext uri="{FF2B5EF4-FFF2-40B4-BE49-F238E27FC236}">
-                <a16:creationId xmlns:a16="http://schemas.microsoft.com/office/drawing/2014/main" id="{7DADA056-E331-4360-B939-83E592678D3F}"/>
+                <a16:creationId xmlns:a16="http://schemas.microsoft.com/office/drawing/2014/main" id="{CCEFA589-A5DD-411E-84D5-B45A2B402693}"/>
               </a:ext>
             </a:extLst>
           </p:cNvPr>
@@ -3610,8 +3600,8 @@
         </p:nvSpPr>
         <p:spPr>
           <a:xfrm xmlns:a="http://schemas.openxmlformats.org/drawingml/2006/main">
-            <a:off x="609600" y="6286500"/>
-            <a:ext cx="7953375" cy="238125"/>
+            <a:off x="11353800" y="6562725"/>
+            <a:ext cx="323850" cy="190500"/>
           </a:xfrm>
           <a:prstGeom xmlns:a="http://schemas.openxmlformats.org/drawingml/2006/main" prst="rect">
             <a:avLst/>
@@ -3632,159 +3622,6 @@
                 <a:spcPct val="110000"/>
               </a:lnSpc>
               <a:buNone/>
-              <a:defRPr sz="1275" b="0">
-                <a:solidFill>
-                  <a:srgbClr val="58645D"/>
-                </a:solidFill>
-                <a:latin typeface="Helvetica Neue"/>
-                <a:ea typeface="Helvetica Neue"/>
-                <a:cs typeface="Helvetica Neue"/>
-              </a:defRPr>
-            </a:pPr>
-            <a:r>
-              <a:rPr sz="1275" b="0">
-                <a:solidFill>
-                  <a:srgbClr val="58645D"/>
-                </a:solidFill>
-                <a:latin typeface="Helvetica Neue"/>
-                <a:ea typeface="Helvetica Neue"/>
-                <a:cs typeface="Helvetica Neue"/>
-              </a:rPr>
-              <a:t>Earlier portfolio presentation, before visual case refinements</a:t>
-            </a:r>
-          </a:p>
-        </p:txBody>
-      </p:sp>
-      <p:sp>
-        <p:nvSpPr>
-          <p:cNvPr id="7" name="portfolio-case-background">
-            <a:extLst xmlns:a="http://schemas.openxmlformats.org/drawingml/2006/main">
-              <a:ext uri="{FF2B5EF4-FFF2-40B4-BE49-F238E27FC236}">
-                <a16:creationId xmlns:a16="http://schemas.microsoft.com/office/drawing/2014/main" id="{C5E11898-3FA2-4DF8-8273-3FC3E58AAA3F}"/>
-              </a:ext>
-            </a:extLst>
-          </p:cNvPr>
-          <p:cNvSpPr>
-            <a:spLocks xmlns:a="http://schemas.openxmlformats.org/drawingml/2006/main" noGrp="1"/>
-          </p:cNvSpPr>
-          <p:nvPr/>
-        </p:nvSpPr>
-        <p:spPr>
-          <a:xfrm xmlns:a="http://schemas.openxmlformats.org/drawingml/2006/main">
-            <a:off x="8810625" y="6153150"/>
-            <a:ext cx="2343150" cy="400050"/>
-          </a:xfrm>
-          <a:prstGeom xmlns:a="http://schemas.openxmlformats.org/drawingml/2006/main" prst="rect">
-            <a:avLst/>
-          </a:prstGeom>
-          <a:solidFill xmlns:a="http://schemas.openxmlformats.org/drawingml/2006/main">
-            <a:srgbClr val="244D3C"/>
-          </a:solidFill>
-          <a:ln xmlns:a="http://schemas.openxmlformats.org/drawingml/2006/main" w="0">
-            <a:noFill/>
-          </a:ln>
-        </p:spPr>
-      </p:sp>
-      <p:sp>
-        <p:nvSpPr>
-          <p:cNvPr id="8" name="portfolio-case-link">
-            <a:extLst xmlns:a="http://schemas.openxmlformats.org/drawingml/2006/main">
-              <a:ext uri="{FF2B5EF4-FFF2-40B4-BE49-F238E27FC236}">
-                <a16:creationId xmlns:a16="http://schemas.microsoft.com/office/drawing/2014/main" id="{298396DE-6596-4383-96F2-3427E7432033}"/>
-              </a:ext>
-            </a:extLst>
-          </p:cNvPr>
-          <p:cNvSpPr>
-            <a:spLocks xmlns:a="http://schemas.openxmlformats.org/drawingml/2006/main" noGrp="1"/>
-          </p:cNvSpPr>
-          <p:nvPr/>
-        </p:nvSpPr>
-        <p:spPr>
-          <a:xfrm xmlns:a="http://schemas.openxmlformats.org/drawingml/2006/main">
-            <a:off x="8963025" y="6229350"/>
-            <a:ext cx="2047875" cy="266700"/>
-          </a:xfrm>
-          <a:prstGeom xmlns:a="http://schemas.openxmlformats.org/drawingml/2006/main" prst="rect">
-            <a:avLst/>
-          </a:prstGeom>
-          <a:noFill xmlns:a="http://schemas.openxmlformats.org/drawingml/2006/main"/>
-          <a:ln xmlns:a="http://schemas.openxmlformats.org/drawingml/2006/main" w="0">
-            <a:noFill/>
-          </a:ln>
-        </p:spPr>
-        <p:txBody>
-          <a:bodyPr xmlns:a="http://schemas.openxmlformats.org/drawingml/2006/main" wrap="square" lIns="0" tIns="0" rIns="0" bIns="0" anchor="t">
-            <a:noAutofit/>
-          </a:bodyPr>
-          <a:lstStyle xmlns:a="http://schemas.openxmlformats.org/drawingml/2006/main"/>
-          <a:p xmlns:a="http://schemas.openxmlformats.org/drawingml/2006/main">
-            <a:pPr>
-              <a:lnSpc>
-                <a:spcPct val="110000"/>
-              </a:lnSpc>
-              <a:buNone/>
-              <a:defRPr sz="1350" b="0" u="sng">
-                <a:solidFill>
-                  <a:srgbClr val="DBEB89"/>
-                </a:solidFill>
-                <a:latin typeface="Helvetica Neue"/>
-                <a:ea typeface="Helvetica Neue"/>
-                <a:cs typeface="Helvetica Neue"/>
-              </a:defRPr>
-            </a:pPr>
-            <a:r>
-              <a:rPr sz="1350" b="0" u="sng">
-                <a:solidFill>
-                  <a:srgbClr val="DBEB89"/>
-                </a:solidFill>
-                <a:latin typeface="Helvetica Neue"/>
-                <a:ea typeface="Helvetica Neue"/>
-                <a:cs typeface="Helvetica Neue"/>
-                <a:hlinkClick xmlns:r="http://schemas.openxmlformats.org/officeDocument/2006/relationships" r:id="R51716a2dde574a9c"/>
-              </a:rPr>
-              <a:t>View the case →</a:t>
-            </a:r>
-          </a:p>
-        </p:txBody>
-      </p:sp>
-      <p:sp>
-        <p:nvSpPr>
-          <p:cNvPr id="9" name="slide-number">
-            <a:extLst xmlns:a="http://schemas.openxmlformats.org/drawingml/2006/main">
-              <a:ext uri="{FF2B5EF4-FFF2-40B4-BE49-F238E27FC236}">
-                <a16:creationId xmlns:a16="http://schemas.microsoft.com/office/drawing/2014/main" id="{538E74F8-F058-4368-9798-0108EF0362E5}"/>
-              </a:ext>
-            </a:extLst>
-          </p:cNvPr>
-          <p:cNvSpPr>
-            <a:spLocks xmlns:a="http://schemas.openxmlformats.org/drawingml/2006/main" noGrp="1"/>
-          </p:cNvSpPr>
-          <p:nvPr/>
-        </p:nvSpPr>
-        <p:spPr>
-          <a:xfrm xmlns:a="http://schemas.openxmlformats.org/drawingml/2006/main">
-            <a:off x="11353800" y="6562725"/>
-            <a:ext cx="323850" cy="190500"/>
-          </a:xfrm>
-          <a:prstGeom xmlns:a="http://schemas.openxmlformats.org/drawingml/2006/main" prst="rect">
-            <a:avLst/>
-          </a:prstGeom>
-          <a:noFill xmlns:a="http://schemas.openxmlformats.org/drawingml/2006/main"/>
-          <a:ln xmlns:a="http://schemas.openxmlformats.org/drawingml/2006/main" w="0">
-            <a:noFill/>
-          </a:ln>
-        </p:spPr>
-        <p:txBody>
-          <a:bodyPr xmlns:a="http://schemas.openxmlformats.org/drawingml/2006/main" wrap="square" lIns="0" tIns="0" rIns="0" bIns="0" anchor="t">
-            <a:noAutofit/>
-          </a:bodyPr>
-          <a:lstStyle xmlns:a="http://schemas.openxmlformats.org/drawingml/2006/main"/>
-          <a:p xmlns:a="http://schemas.openxmlformats.org/drawingml/2006/main">
-            <a:pPr>
-              <a:lnSpc>
-                <a:spcPct val="110000"/>
-              </a:lnSpc>
-              <a:buNone/>
               <a:defRPr sz="1050" b="0">
                 <a:solidFill>
                   <a:srgbClr val="58645D"/>
@@ -3811,7 +3648,7 @@
     </p:spTree>
     <p:extLst>
       <p:ext uri="{BB962C8B-B14F-4D97-AF65-F5344CB8AC3E}">
-        <p14:creationId xmlns:p14="http://schemas.microsoft.com/office/powerpoint/2010/main" val="1987097151"/>
+        <p14:creationId xmlns:p14="http://schemas.microsoft.com/office/powerpoint/2010/main" val="809264768"/>
       </p:ext>
     </p:extLst>
   </p:cSld>
@@ -3819,389 +3656,6 @@
 </file>
 
 <file path=ppt/slides/slide13.xml><?xml version="1.0" encoding="utf-8"?>
-<p:sld xmlns:p="http://schemas.openxmlformats.org/presentationml/2006/main">
-  <p:cSld>
-    <p:bg>
-      <p:bgPr>
-        <a:solidFill xmlns:a="http://schemas.openxmlformats.org/drawingml/2006/main">
-          <a:srgbClr val="F4F2E9"/>
-        </a:solidFill>
-      </p:bgPr>
-    </p:bg>
-    <p:spTree>
-      <p:nvGrpSpPr>
-        <p:cNvPr id="1" name=""/>
-        <p:cNvGrpSpPr/>
-        <p:nvPr/>
-      </p:nvGrpSpPr>
-      <p:grpSpPr>
-        <a:xfrm xmlns:a="http://schemas.openxmlformats.org/drawingml/2006/main"/>
-      </p:grpSpPr>
-      <p:sp>
-        <p:nvSpPr>
-          <p:cNvPr id="7" name="section-label">
-            <a:extLst xmlns:a="http://schemas.openxmlformats.org/drawingml/2006/main">
-              <a:ext uri="{FF2B5EF4-FFF2-40B4-BE49-F238E27FC236}">
-                <a16:creationId xmlns:a16="http://schemas.microsoft.com/office/drawing/2014/main" id="{1BA8870A-F13F-4FCC-845D-9D3854A18BFB}"/>
-              </a:ext>
-            </a:extLst>
-          </p:cNvPr>
-          <p:cNvSpPr>
-            <a:spLocks xmlns:a="http://schemas.openxmlformats.org/drawingml/2006/main" noGrp="1"/>
-          </p:cNvSpPr>
-          <p:nvPr/>
-        </p:nvSpPr>
-        <p:spPr>
-          <a:xfrm xmlns:a="http://schemas.openxmlformats.org/drawingml/2006/main">
-            <a:off x="609600" y="514350"/>
-            <a:ext cx="6477000" cy="266700"/>
-          </a:xfrm>
-          <a:prstGeom xmlns:a="http://schemas.openxmlformats.org/drawingml/2006/main" prst="rect">
-            <a:avLst/>
-          </a:prstGeom>
-          <a:noFill xmlns:a="http://schemas.openxmlformats.org/drawingml/2006/main"/>
-          <a:ln xmlns:a="http://schemas.openxmlformats.org/drawingml/2006/main" w="0">
-            <a:noFill/>
-          </a:ln>
-        </p:spPr>
-        <p:txBody>
-          <a:bodyPr xmlns:a="http://schemas.openxmlformats.org/drawingml/2006/main" wrap="square" lIns="0" tIns="0" rIns="0" bIns="0" anchor="t">
-            <a:noAutofit/>
-          </a:bodyPr>
-          <a:lstStyle xmlns:a="http://schemas.openxmlformats.org/drawingml/2006/main"/>
-          <a:p xmlns:a="http://schemas.openxmlformats.org/drawingml/2006/main">
-            <a:pPr>
-              <a:lnSpc>
-                <a:spcPct val="110000"/>
-              </a:lnSpc>
-              <a:buNone/>
-              <a:defRPr sz="1200" b="1">
-                <a:solidFill>
-                  <a:srgbClr val="244D3C"/>
-                </a:solidFill>
-                <a:latin typeface="Helvetica Neue"/>
-                <a:ea typeface="Helvetica Neue"/>
-                <a:cs typeface="Helvetica Neue"/>
-              </a:defRPr>
-            </a:pPr>
-            <a:r>
-              <a:rPr sz="1200" b="1">
-                <a:solidFill>
-                  <a:srgbClr val="244D3C"/>
-                </a:solidFill>
-                <a:latin typeface="Helvetica Neue"/>
-                <a:ea typeface="Helvetica Neue"/>
-                <a:cs typeface="Helvetica Neue"/>
-              </a:rPr>
-              <a:t>THE THREAD THROUGH MY WORK</a:t>
-            </a:r>
-          </a:p>
-        </p:txBody>
-      </p:sp>
-      <p:sp>
-        <p:nvSpPr>
-          <p:cNvPr id="2" name="headline">
-            <a:extLst xmlns:a="http://schemas.openxmlformats.org/drawingml/2006/main">
-              <a:ext uri="{FF2B5EF4-FFF2-40B4-BE49-F238E27FC236}">
-                <a16:creationId xmlns:a16="http://schemas.microsoft.com/office/drawing/2014/main" id="{8F5075C9-9172-4EE3-B46C-4E4D3A4A1A7B}"/>
-              </a:ext>
-            </a:extLst>
-          </p:cNvPr>
-          <p:cNvSpPr>
-            <a:spLocks xmlns:a="http://schemas.openxmlformats.org/drawingml/2006/main" noGrp="1"/>
-          </p:cNvSpPr>
-          <p:nvPr/>
-        </p:nvSpPr>
-        <p:spPr>
-          <a:xfrm xmlns:a="http://schemas.openxmlformats.org/drawingml/2006/main">
-            <a:off x="609600" y="1352550"/>
-            <a:ext cx="5905500" cy="1485900"/>
-          </a:xfrm>
-          <a:prstGeom xmlns:a="http://schemas.openxmlformats.org/drawingml/2006/main" prst="rect">
-            <a:avLst/>
-          </a:prstGeom>
-          <a:noFill xmlns:a="http://schemas.openxmlformats.org/drawingml/2006/main"/>
-          <a:ln xmlns:a="http://schemas.openxmlformats.org/drawingml/2006/main" w="0">
-            <a:noFill/>
-          </a:ln>
-        </p:spPr>
-        <p:txBody>
-          <a:bodyPr xmlns:a="http://schemas.openxmlformats.org/drawingml/2006/main" wrap="square" lIns="0" tIns="0" rIns="0" bIns="0" anchor="t">
-            <a:noAutofit/>
-          </a:bodyPr>
-          <a:lstStyle xmlns:a="http://schemas.openxmlformats.org/drawingml/2006/main"/>
-          <a:p xmlns:a="http://schemas.openxmlformats.org/drawingml/2006/main">
-            <a:pPr>
-              <a:lnSpc>
-                <a:spcPct val="110000"/>
-              </a:lnSpc>
-              <a:buNone/>
-              <a:defRPr sz="3750" b="1">
-                <a:solidFill>
-                  <a:srgbClr val="192B25"/>
-                </a:solidFill>
-                <a:latin typeface="Helvetica Neue"/>
-                <a:ea typeface="Helvetica Neue"/>
-                <a:cs typeface="Helvetica Neue"/>
-              </a:defRPr>
-            </a:pPr>
-            <a:r>
-              <a:rPr sz="3750" b="1">
-                <a:solidFill>
-                  <a:srgbClr val="192B25"/>
-                </a:solidFill>
-                <a:latin typeface="Helvetica Neue"/>
-                <a:ea typeface="Helvetica Neue"/>
-                <a:cs typeface="Helvetica Neue"/>
-              </a:rPr>
-              <a:t>The person using</a:t>
-            </a:r>
-          </a:p>
-          <a:p xmlns:a="http://schemas.openxmlformats.org/drawingml/2006/main">
-            <a:pPr>
-              <a:lnSpc>
-                <a:spcPct val="110000"/>
-              </a:lnSpc>
-              <a:buNone/>
-              <a:defRPr sz="3750" b="1">
-                <a:solidFill>
-                  <a:srgbClr val="192B25"/>
-                </a:solidFill>
-                <a:latin typeface="Helvetica Neue"/>
-                <a:ea typeface="Helvetica Neue"/>
-                <a:cs typeface="Helvetica Neue"/>
-              </a:defRPr>
-            </a:pPr>
-            <a:r>
-              <a:rPr sz="3750" b="1">
-                <a:solidFill>
-                  <a:srgbClr val="192B25"/>
-                </a:solidFill>
-                <a:latin typeface="Helvetica Neue"/>
-                <a:ea typeface="Helvetica Neue"/>
-                <a:cs typeface="Helvetica Neue"/>
-              </a:rPr>
-              <a:t>the system matters</a:t>
-            </a:r>
-          </a:p>
-        </p:txBody>
-      </p:sp>
-      <p:sp>
-        <p:nvSpPr>
-          <p:cNvPr id="3" name="story-origin">
-            <a:extLst xmlns:a="http://schemas.openxmlformats.org/drawingml/2006/main">
-              <a:ext uri="{FF2B5EF4-FFF2-40B4-BE49-F238E27FC236}">
-                <a16:creationId xmlns:a16="http://schemas.microsoft.com/office/drawing/2014/main" id="{80CCEC20-355A-4E8B-B128-94352A735333}"/>
-              </a:ext>
-            </a:extLst>
-          </p:cNvPr>
-          <p:cNvSpPr>
-            <a:spLocks xmlns:a="http://schemas.openxmlformats.org/drawingml/2006/main" noGrp="1"/>
-          </p:cNvSpPr>
-          <p:nvPr/>
-        </p:nvSpPr>
-        <p:spPr>
-          <a:xfrm xmlns:a="http://schemas.openxmlformats.org/drawingml/2006/main">
-            <a:off x="609600" y="3333750"/>
-            <a:ext cx="5572125" cy="1228725"/>
-          </a:xfrm>
-          <a:prstGeom xmlns:a="http://schemas.openxmlformats.org/drawingml/2006/main" prst="rect">
-            <a:avLst/>
-          </a:prstGeom>
-          <a:noFill xmlns:a="http://schemas.openxmlformats.org/drawingml/2006/main"/>
-          <a:ln xmlns:a="http://schemas.openxmlformats.org/drawingml/2006/main" w="0">
-            <a:noFill/>
-          </a:ln>
-        </p:spPr>
-        <p:txBody>
-          <a:bodyPr xmlns:a="http://schemas.openxmlformats.org/drawingml/2006/main" wrap="square" lIns="0" tIns="0" rIns="0" bIns="0" anchor="t">
-            <a:noAutofit/>
-          </a:bodyPr>
-          <a:lstStyle xmlns:a="http://schemas.openxmlformats.org/drawingml/2006/main"/>
-          <a:p xmlns:a="http://schemas.openxmlformats.org/drawingml/2006/main">
-            <a:pPr>
-              <a:lnSpc>
-                <a:spcPct val="110000"/>
-              </a:lnSpc>
-              <a:buNone/>
-              <a:defRPr sz="1950" b="0">
-                <a:solidFill>
-                  <a:srgbClr val="192B25"/>
-                </a:solidFill>
-                <a:latin typeface="Helvetica Neue"/>
-                <a:ea typeface="Helvetica Neue"/>
-                <a:cs typeface="Helvetica Neue"/>
-              </a:defRPr>
-            </a:pPr>
-            <a:r>
-              <a:rPr sz="1950" b="0">
-                <a:solidFill>
-                  <a:srgbClr val="192B25"/>
-                </a:solidFill>
-                <a:latin typeface="Helvetica Neue"/>
-                <a:ea typeface="Helvetica Neue"/>
-                <a:cs typeface="Helvetica Neue"/>
-              </a:rPr>
-              <a:t>Documentary filmmaking taught me to listen closely. Learning design taught me to make the next step teachable.</a:t>
-            </a:r>
-          </a:p>
-        </p:txBody>
-      </p:sp>
-      <p:sp>
-        <p:nvSpPr>
-          <p:cNvPr id="4" name="story-ai">
-            <a:extLst xmlns:a="http://schemas.openxmlformats.org/drawingml/2006/main">
-              <a:ext uri="{FF2B5EF4-FFF2-40B4-BE49-F238E27FC236}">
-                <a16:creationId xmlns:a16="http://schemas.microsoft.com/office/drawing/2014/main" id="{13339B96-0F64-48C8-B6D0-1029401FD7F1}"/>
-              </a:ext>
-            </a:extLst>
-          </p:cNvPr>
-          <p:cNvSpPr>
-            <a:spLocks xmlns:a="http://schemas.openxmlformats.org/drawingml/2006/main" noGrp="1"/>
-          </p:cNvSpPr>
-          <p:nvPr/>
-        </p:nvSpPr>
-        <p:spPr>
-          <a:xfrm xmlns:a="http://schemas.openxmlformats.org/drawingml/2006/main">
-            <a:off x="609600" y="4953000"/>
-            <a:ext cx="5572125" cy="1209675"/>
-          </a:xfrm>
-          <a:prstGeom xmlns:a="http://schemas.openxmlformats.org/drawingml/2006/main" prst="rect">
-            <a:avLst/>
-          </a:prstGeom>
-          <a:noFill xmlns:a="http://schemas.openxmlformats.org/drawingml/2006/main"/>
-          <a:ln xmlns:a="http://schemas.openxmlformats.org/drawingml/2006/main" w="0">
-            <a:noFill/>
-          </a:ln>
-        </p:spPr>
-        <p:txBody>
-          <a:bodyPr xmlns:a="http://schemas.openxmlformats.org/drawingml/2006/main" wrap="square" lIns="0" tIns="0" rIns="0" bIns="0" anchor="t">
-            <a:noAutofit/>
-          </a:bodyPr>
-          <a:lstStyle xmlns:a="http://schemas.openxmlformats.org/drawingml/2006/main"/>
-          <a:p xmlns:a="http://schemas.openxmlformats.org/drawingml/2006/main">
-            <a:pPr>
-              <a:lnSpc>
-                <a:spcPct val="110000"/>
-              </a:lnSpc>
-              <a:buNone/>
-              <a:defRPr sz="1800" b="0">
-                <a:solidFill>
-                  <a:srgbClr val="58645D"/>
-                </a:solidFill>
-                <a:latin typeface="Helvetica Neue"/>
-                <a:ea typeface="Helvetica Neue"/>
-                <a:cs typeface="Helvetica Neue"/>
-              </a:defRPr>
-            </a:pPr>
-            <a:r>
-              <a:rPr sz="1800" b="0">
-                <a:solidFill>
-                  <a:srgbClr val="58645D"/>
-                </a:solidFill>
-                <a:latin typeface="Helvetica Neue"/>
-                <a:ea typeface="Helvetica Neue"/>
-                <a:cs typeface="Helvetica Neue"/>
-              </a:rPr>
-              <a:t>That perspective carries into my AI work: understand the task, make the output inspectable, and leave room for human judgment.</a:t>
-            </a:r>
-          </a:p>
-        </p:txBody>
-      </p:sp>
-      <p:pic>
-        <p:nvPicPr>
-          <p:cNvPr id="11" name=""/>
-          <p:cNvPicPr>
-            <a:picLocks xmlns:a="http://schemas.openxmlformats.org/drawingml/2006/main" noChangeAspect="1"/>
-          </p:cNvPicPr>
-          <p:nvPr/>
-        </p:nvPicPr>
-        <p:blipFill>
-          <a:blip xmlns:r="http://schemas.openxmlformats.org/officeDocument/2006/relationships" xmlns:a="http://schemas.openxmlformats.org/drawingml/2006/main" r:embed="R1d2bf517d34b42d1"/>
-          <a:stretch xmlns:a="http://schemas.openxmlformats.org/drawingml/2006/main"/>
-        </p:blipFill>
-        <p:spPr>
-          <a:xfrm xmlns:a="http://schemas.openxmlformats.org/drawingml/2006/main">
-            <a:off x="7010400" y="1447800"/>
-            <a:ext cx="4876800" cy="4876800"/>
-          </a:xfrm>
-          <a:prstGeom xmlns:a="http://schemas.openxmlformats.org/drawingml/2006/main" prst="rect">
-            <a:avLst/>
-          </a:prstGeom>
-        </p:spPr>
-      </p:pic>
-      <p:sp>
-        <p:nvSpPr>
-          <p:cNvPr id="6" name="slide-number">
-            <a:extLst xmlns:a="http://schemas.openxmlformats.org/drawingml/2006/main">
-              <a:ext uri="{FF2B5EF4-FFF2-40B4-BE49-F238E27FC236}">
-                <a16:creationId xmlns:a16="http://schemas.microsoft.com/office/drawing/2014/main" id="{6670C944-B77D-4769-ADF0-C2EBA6288E10}"/>
-              </a:ext>
-            </a:extLst>
-          </p:cNvPr>
-          <p:cNvSpPr>
-            <a:spLocks xmlns:a="http://schemas.openxmlformats.org/drawingml/2006/main" noGrp="1"/>
-          </p:cNvSpPr>
-          <p:nvPr/>
-        </p:nvSpPr>
-        <p:spPr>
-          <a:xfrm xmlns:a="http://schemas.openxmlformats.org/drawingml/2006/main">
-            <a:off x="11353800" y="6562725"/>
-            <a:ext cx="323850" cy="190500"/>
-          </a:xfrm>
-          <a:prstGeom xmlns:a="http://schemas.openxmlformats.org/drawingml/2006/main" prst="rect">
-            <a:avLst/>
-          </a:prstGeom>
-          <a:noFill xmlns:a="http://schemas.openxmlformats.org/drawingml/2006/main"/>
-          <a:ln xmlns:a="http://schemas.openxmlformats.org/drawingml/2006/main" w="0">
-            <a:noFill/>
-          </a:ln>
-        </p:spPr>
-        <p:txBody>
-          <a:bodyPr xmlns:a="http://schemas.openxmlformats.org/drawingml/2006/main" wrap="square" lIns="0" tIns="0" rIns="0" bIns="0" anchor="t">
-            <a:noAutofit/>
-          </a:bodyPr>
-          <a:lstStyle xmlns:a="http://schemas.openxmlformats.org/drawingml/2006/main"/>
-          <a:p xmlns:a="http://schemas.openxmlformats.org/drawingml/2006/main">
-            <a:pPr>
-              <a:lnSpc>
-                <a:spcPct val="110000"/>
-              </a:lnSpc>
-              <a:buNone/>
-              <a:defRPr sz="1050" b="0">
-                <a:solidFill>
-                  <a:srgbClr val="58645D"/>
-                </a:solidFill>
-                <a:latin typeface="Helvetica Neue"/>
-                <a:ea typeface="Helvetica Neue"/>
-                <a:cs typeface="Helvetica Neue"/>
-              </a:defRPr>
-            </a:pPr>
-            <a:r>
-              <a:rPr sz="1050" b="0">
-                <a:solidFill>
-                  <a:srgbClr val="58645D"/>
-                </a:solidFill>
-                <a:latin typeface="Helvetica Neue"/>
-                <a:ea typeface="Helvetica Neue"/>
-                <a:cs typeface="Helvetica Neue"/>
-              </a:rPr>
-              <a:t>13</a:t>
-            </a:r>
-          </a:p>
-        </p:txBody>
-      </p:sp>
-    </p:spTree>
-    <p:extLst>
-      <p:ext uri="{BB962C8B-B14F-4D97-AF65-F5344CB8AC3E}">
-        <p14:creationId xmlns:p14="http://schemas.microsoft.com/office/powerpoint/2010/main" val="1759730857"/>
-      </p:ext>
-    </p:extLst>
-  </p:cSld>
-</p:sld>
-</file>
-
-<file path=ppt/slides/slide14.xml><?xml version="1.0" encoding="utf-8"?>
 <p:sld xmlns:p="http://schemas.openxmlformats.org/presentationml/2006/main">
   <p:cSld>
     <p:bg>
@@ -4225,7 +3679,7 @@
           <p:cNvPr id="7" name="section-label">
             <a:extLst xmlns:a="http://schemas.openxmlformats.org/drawingml/2006/main">
               <a:ext uri="{FF2B5EF4-FFF2-40B4-BE49-F238E27FC236}">
-                <a16:creationId xmlns:a16="http://schemas.microsoft.com/office/drawing/2014/main" id="{BDA9708C-4932-404C-9507-DF6B5FB74FBB}"/>
+                <a16:creationId xmlns:a16="http://schemas.microsoft.com/office/drawing/2014/main" id="{4F42E34D-5BB6-4939-A37F-E6690DCAEE3C}"/>
               </a:ext>
             </a:extLst>
           </p:cNvPr>
@@ -4286,7 +3740,7 @@
           <p:cNvPr id="2" name="headline">
             <a:extLst xmlns:a="http://schemas.openxmlformats.org/drawingml/2006/main">
               <a:ext uri="{FF2B5EF4-FFF2-40B4-BE49-F238E27FC236}">
-                <a16:creationId xmlns:a16="http://schemas.microsoft.com/office/drawing/2014/main" id="{ACC25B1B-7F99-4B79-AF3C-5C9A5A191858}"/>
+                <a16:creationId xmlns:a16="http://schemas.microsoft.com/office/drawing/2014/main" id="{1A9910C9-04B8-45E6-A1EE-E917A5ABCF4E}"/>
               </a:ext>
             </a:extLst>
           </p:cNvPr>
@@ -4374,7 +3828,7 @@
           <p:cNvPr id="3" name="contact-intent">
             <a:extLst xmlns:a="http://schemas.openxmlformats.org/drawingml/2006/main">
               <a:ext uri="{FF2B5EF4-FFF2-40B4-BE49-F238E27FC236}">
-                <a16:creationId xmlns:a16="http://schemas.microsoft.com/office/drawing/2014/main" id="{FAF73A0C-8363-474E-909D-FFF1D0C5CB11}"/>
+                <a16:creationId xmlns:a16="http://schemas.microsoft.com/office/drawing/2014/main" id="{FF3856D8-B509-4FA0-87E3-3347F4F8F610}"/>
               </a:ext>
             </a:extLst>
           </p:cNvPr>
@@ -4435,7 +3889,7 @@
           <p:cNvPr id="4" name="email">
             <a:extLst xmlns:a="http://schemas.openxmlformats.org/drawingml/2006/main">
               <a:ext uri="{FF2B5EF4-FFF2-40B4-BE49-F238E27FC236}">
-                <a16:creationId xmlns:a16="http://schemas.microsoft.com/office/drawing/2014/main" id="{83D9BAC1-5172-4D39-B242-12623F600F5B}"/>
+                <a16:creationId xmlns:a16="http://schemas.microsoft.com/office/drawing/2014/main" id="{CCDE1B2B-17F8-492C-BC52-0FDED0E11709}"/>
               </a:ext>
             </a:extLst>
           </p:cNvPr>
@@ -4485,7 +3939,7 @@
                 <a:latin typeface="Helvetica Neue"/>
                 <a:ea typeface="Helvetica Neue"/>
                 <a:cs typeface="Helvetica Neue"/>
-                <a:hlinkClick xmlns:r="http://schemas.openxmlformats.org/officeDocument/2006/relationships" r:id="Raf1ccf5bd02c4ec3"/>
+                <a:hlinkClick xmlns:r="http://schemas.openxmlformats.org/officeDocument/2006/relationships" r:id="R6c7176fb309b4cd6"/>
               </a:rPr>
               <a:t>JonathanKyleHobson@gmail.com</a:t>
             </a:r>
@@ -4497,7 +3951,7 @@
           <p:cNvPr id="5" name="portfolio">
             <a:extLst xmlns:a="http://schemas.openxmlformats.org/drawingml/2006/main">
               <a:ext uri="{FF2B5EF4-FFF2-40B4-BE49-F238E27FC236}">
-                <a16:creationId xmlns:a16="http://schemas.microsoft.com/office/drawing/2014/main" id="{4AEE9D05-6F4E-415A-9ED1-5BA804434144}"/>
+                <a16:creationId xmlns:a16="http://schemas.microsoft.com/office/drawing/2014/main" id="{99EE3A72-5BA1-4CEA-A814-3D66AA50E0AC}"/>
               </a:ext>
             </a:extLst>
           </p:cNvPr>
@@ -4547,7 +4001,7 @@
                 <a:latin typeface="Helvetica Neue"/>
                 <a:ea typeface="Helvetica Neue"/>
                 <a:cs typeface="Helvetica Neue"/>
-                <a:hlinkClick xmlns:r="http://schemas.openxmlformats.org/officeDocument/2006/relationships" r:id="Ra0564cf1ec3046fa"/>
+                <a:hlinkClick xmlns:r="http://schemas.openxmlformats.org/officeDocument/2006/relationships" r:id="R740fb26b4659493f"/>
               </a:rPr>
               <a:t>jonathankhobson.github.io/portfolio/ai</a:t>
             </a:r>
@@ -4559,7 +4013,7 @@
           <p:cNvPr id="6" name="slide-number">
             <a:extLst xmlns:a="http://schemas.openxmlformats.org/drawingml/2006/main">
               <a:ext uri="{FF2B5EF4-FFF2-40B4-BE49-F238E27FC236}">
-                <a16:creationId xmlns:a16="http://schemas.microsoft.com/office/drawing/2014/main" id="{E5C78305-7E95-417D-B09B-C1620ED7C91A}"/>
+                <a16:creationId xmlns:a16="http://schemas.microsoft.com/office/drawing/2014/main" id="{493CB659-CE38-4930-9321-2D2FD21BDD77}"/>
               </a:ext>
             </a:extLst>
           </p:cNvPr>
@@ -4610,7 +4064,7 @@
                 <a:ea typeface="Helvetica Neue"/>
                 <a:cs typeface="Helvetica Neue"/>
               </a:rPr>
-              <a:t>14</a:t>
+              <a:t>13</a:t>
             </a:r>
           </a:p>
         </p:txBody>
@@ -4618,7 +4072,7 @@
     </p:spTree>
     <p:extLst>
       <p:ext uri="{BB962C8B-B14F-4D97-AF65-F5344CB8AC3E}">
-        <p14:creationId xmlns:p14="http://schemas.microsoft.com/office/powerpoint/2010/main" val="1532696714"/>
+        <p14:creationId xmlns:p14="http://schemas.microsoft.com/office/powerpoint/2010/main" val="1758749869"/>
       </p:ext>
     </p:extLst>
   </p:cSld>
@@ -4649,7 +4103,7 @@
           <p:cNvPr id="7" name="section-label">
             <a:extLst xmlns:a="http://schemas.openxmlformats.org/drawingml/2006/main">
               <a:ext uri="{FF2B5EF4-FFF2-40B4-BE49-F238E27FC236}">
-                <a16:creationId xmlns:a16="http://schemas.microsoft.com/office/drawing/2014/main" id="{A1D516BF-B4C8-42F8-A9ED-EB07074B3ADE}"/>
+                <a16:creationId xmlns:a16="http://schemas.microsoft.com/office/drawing/2014/main" id="{DD0530D2-A53B-45C4-AB7D-90C5EA5B8F65}"/>
               </a:ext>
             </a:extLst>
           </p:cNvPr>
@@ -4710,7 +4164,7 @@
           <p:cNvPr id="2" name="headline">
             <a:extLst xmlns:a="http://schemas.openxmlformats.org/drawingml/2006/main">
               <a:ext uri="{FF2B5EF4-FFF2-40B4-BE49-F238E27FC236}">
-                <a16:creationId xmlns:a16="http://schemas.microsoft.com/office/drawing/2014/main" id="{12F36C93-83C7-4757-892A-2EA5E3FAD38E}"/>
+                <a16:creationId xmlns:a16="http://schemas.microsoft.com/office/drawing/2014/main" id="{3FAAC111-67EB-4ECE-8DD6-322FCE2CE9A4}"/>
               </a:ext>
             </a:extLst>
           </p:cNvPr>
@@ -4771,7 +4225,7 @@
           <p:cNvPr id="3" name="prompt-purpose">
             <a:extLst xmlns:a="http://schemas.openxmlformats.org/drawingml/2006/main">
               <a:ext uri="{FF2B5EF4-FFF2-40B4-BE49-F238E27FC236}">
-                <a16:creationId xmlns:a16="http://schemas.microsoft.com/office/drawing/2014/main" id="{22B9850A-8B69-417A-AC83-2781A24F6BFD}"/>
+                <a16:creationId xmlns:a16="http://schemas.microsoft.com/office/drawing/2014/main" id="{04C0BA24-F649-4551-AAF4-10101BF505BD}"/>
               </a:ext>
             </a:extLst>
           </p:cNvPr>
@@ -4836,7 +4290,7 @@
           <p:nvPr/>
         </p:nvPicPr>
         <p:blipFill>
-          <a:blip xmlns:r="http://schemas.openxmlformats.org/officeDocument/2006/relationships" xmlns:a="http://schemas.openxmlformats.org/drawingml/2006/main" r:embed="R93e3d5608b454141"/>
+          <a:blip xmlns:r="http://schemas.openxmlformats.org/officeDocument/2006/relationships" xmlns:a="http://schemas.openxmlformats.org/drawingml/2006/main" r:embed="Rf1330bf7ccbb42df"/>
           <a:stretch xmlns:a="http://schemas.openxmlformats.org/drawingml/2006/main"/>
         </p:blipFill>
         <p:spPr>
@@ -4854,7 +4308,7 @@
           <p:cNvPr id="5" name="prompt-status">
             <a:extLst xmlns:a="http://schemas.openxmlformats.org/drawingml/2006/main">
               <a:ext uri="{FF2B5EF4-FFF2-40B4-BE49-F238E27FC236}">
-                <a16:creationId xmlns:a16="http://schemas.microsoft.com/office/drawing/2014/main" id="{06D0F797-5B68-4B78-A635-BBD4B2F52053}"/>
+                <a16:creationId xmlns:a16="http://schemas.microsoft.com/office/drawing/2014/main" id="{108CD298-156A-4BDE-BF69-B0DBA7D402BD}"/>
               </a:ext>
             </a:extLst>
           </p:cNvPr>
@@ -4915,7 +4369,7 @@
           <p:cNvPr id="6" name="slide-number">
             <a:extLst xmlns:a="http://schemas.openxmlformats.org/drawingml/2006/main">
               <a:ext uri="{FF2B5EF4-FFF2-40B4-BE49-F238E27FC236}">
-                <a16:creationId xmlns:a16="http://schemas.microsoft.com/office/drawing/2014/main" id="{811376AF-5AAA-448B-9C24-B9176C80AA8A}"/>
+                <a16:creationId xmlns:a16="http://schemas.microsoft.com/office/drawing/2014/main" id="{568730B4-12D9-4D61-AFD8-C81CA07C1213}"/>
               </a:ext>
             </a:extLst>
           </p:cNvPr>
@@ -4974,7 +4428,7 @@
     </p:spTree>
     <p:extLst>
       <p:ext uri="{BB962C8B-B14F-4D97-AF65-F5344CB8AC3E}">
-        <p14:creationId xmlns:p14="http://schemas.microsoft.com/office/powerpoint/2010/main" val="1429300355"/>
+        <p14:creationId xmlns:p14="http://schemas.microsoft.com/office/powerpoint/2010/main" val="2072118146"/>
       </p:ext>
     </p:extLst>
   </p:cSld>
@@ -5005,7 +4459,7 @@
           <p:cNvPr id="10" name="section-label">
             <a:extLst xmlns:a="http://schemas.openxmlformats.org/drawingml/2006/main">
               <a:ext uri="{FF2B5EF4-FFF2-40B4-BE49-F238E27FC236}">
-                <a16:creationId xmlns:a16="http://schemas.microsoft.com/office/drawing/2014/main" id="{A137F959-6269-4C6E-9719-E81FD78D35A8}"/>
+                <a16:creationId xmlns:a16="http://schemas.microsoft.com/office/drawing/2014/main" id="{0B5ACFCE-FC6A-42D7-94DE-987C0F8065AA}"/>
               </a:ext>
             </a:extLst>
           </p:cNvPr>
@@ -5066,7 +4520,7 @@
           <p:cNvPr id="2" name="headline">
             <a:extLst xmlns:a="http://schemas.openxmlformats.org/drawingml/2006/main">
               <a:ext uri="{FF2B5EF4-FFF2-40B4-BE49-F238E27FC236}">
-                <a16:creationId xmlns:a16="http://schemas.microsoft.com/office/drawing/2014/main" id="{3C260FCB-3635-485F-8612-7A69A5E28879}"/>
+                <a16:creationId xmlns:a16="http://schemas.microsoft.com/office/drawing/2014/main" id="{EC538276-3E46-47C7-8DD5-ADB058CCD8D4}"/>
               </a:ext>
             </a:extLst>
           </p:cNvPr>
@@ -5127,7 +4581,7 @@
           <p:cNvPr id="3" name="before-label">
             <a:extLst xmlns:a="http://schemas.openxmlformats.org/drawingml/2006/main">
               <a:ext uri="{FF2B5EF4-FFF2-40B4-BE49-F238E27FC236}">
-                <a16:creationId xmlns:a16="http://schemas.microsoft.com/office/drawing/2014/main" id="{2BB8EB5E-1E56-49CD-B596-892CE238C0E2}"/>
+                <a16:creationId xmlns:a16="http://schemas.microsoft.com/office/drawing/2014/main" id="{C9F0CAC3-A804-447A-A40E-02434378478F}"/>
               </a:ext>
             </a:extLst>
           </p:cNvPr>
@@ -5188,7 +4642,7 @@
           <p:cNvPr id="4" name="after-label">
             <a:extLst xmlns:a="http://schemas.openxmlformats.org/drawingml/2006/main">
               <a:ext uri="{FF2B5EF4-FFF2-40B4-BE49-F238E27FC236}">
-                <a16:creationId xmlns:a16="http://schemas.microsoft.com/office/drawing/2014/main" id="{8FB1E23A-ACE5-4F0A-B06D-0A3A1805F47C}"/>
+                <a16:creationId xmlns:a16="http://schemas.microsoft.com/office/drawing/2014/main" id="{8A723099-73FF-48D0-823E-C66894A47CDC}"/>
               </a:ext>
             </a:extLst>
           </p:cNvPr>
@@ -5249,7 +4703,7 @@
           <p:cNvPr id="5" name="before-prompt">
             <a:extLst xmlns:a="http://schemas.openxmlformats.org/drawingml/2006/main">
               <a:ext uri="{FF2B5EF4-FFF2-40B4-BE49-F238E27FC236}">
-                <a16:creationId xmlns:a16="http://schemas.microsoft.com/office/drawing/2014/main" id="{26F89521-0B9F-436F-9F89-5E234A5BF5E8}"/>
+                <a16:creationId xmlns:a16="http://schemas.microsoft.com/office/drawing/2014/main" id="{8EF9D8F2-449A-4BC8-8901-7C7CE2153614}"/>
               </a:ext>
             </a:extLst>
           </p:cNvPr>
@@ -5310,7 +4764,7 @@
           <p:cNvPr id="6" name="after-prompt">
             <a:extLst xmlns:a="http://schemas.openxmlformats.org/drawingml/2006/main">
               <a:ext uri="{FF2B5EF4-FFF2-40B4-BE49-F238E27FC236}">
-                <a16:creationId xmlns:a16="http://schemas.microsoft.com/office/drawing/2014/main" id="{6A7B903B-2C87-4408-99EF-7631C1494A2B}"/>
+                <a16:creationId xmlns:a16="http://schemas.microsoft.com/office/drawing/2014/main" id="{82F04043-6002-49D5-9E3F-8E9306E8D474}"/>
               </a:ext>
             </a:extLst>
           </p:cNvPr>
@@ -5371,7 +4825,7 @@
           <p:cNvPr id="7" name="expected-winner">
             <a:extLst xmlns:a="http://schemas.openxmlformats.org/drawingml/2006/main">
               <a:ext uri="{FF2B5EF4-FFF2-40B4-BE49-F238E27FC236}">
-                <a16:creationId xmlns:a16="http://schemas.microsoft.com/office/drawing/2014/main" id="{BAAD91CC-FECF-4225-A439-48D3CEA79355}"/>
+                <a16:creationId xmlns:a16="http://schemas.microsoft.com/office/drawing/2014/main" id="{F8E5CD21-D2D0-4090-9F06-7F03B296B81E}"/>
               </a:ext>
             </a:extLst>
           </p:cNvPr>
@@ -5432,7 +4886,7 @@
           <p:cNvPr id="8" name="fixture-reason">
             <a:extLst xmlns:a="http://schemas.openxmlformats.org/drawingml/2006/main">
               <a:ext uri="{FF2B5EF4-FFF2-40B4-BE49-F238E27FC236}">
-                <a16:creationId xmlns:a16="http://schemas.microsoft.com/office/drawing/2014/main" id="{3D8E55BB-4A87-4953-8E8F-3BDCC11111FC}"/>
+                <a16:creationId xmlns:a16="http://schemas.microsoft.com/office/drawing/2014/main" id="{6A8075BA-43C2-4F5A-AA3C-1F92BE4ABF3B}"/>
               </a:ext>
             </a:extLst>
           </p:cNvPr>
@@ -5493,7 +4947,7 @@
           <p:cNvPr id="9" name="slide-number">
             <a:extLst xmlns:a="http://schemas.openxmlformats.org/drawingml/2006/main">
               <a:ext uri="{FF2B5EF4-FFF2-40B4-BE49-F238E27FC236}">
-                <a16:creationId xmlns:a16="http://schemas.microsoft.com/office/drawing/2014/main" id="{222C6693-6C0A-4EE1-B43D-8F5FA01EB9B7}"/>
+                <a16:creationId xmlns:a16="http://schemas.microsoft.com/office/drawing/2014/main" id="{2C7D54F7-59AD-4E51-B1A3-7D975FC272D6}"/>
               </a:ext>
             </a:extLst>
           </p:cNvPr>
@@ -5552,7 +5006,7 @@
     </p:spTree>
     <p:extLst>
       <p:ext uri="{BB962C8B-B14F-4D97-AF65-F5344CB8AC3E}">
-        <p14:creationId xmlns:p14="http://schemas.microsoft.com/office/powerpoint/2010/main" val="2127500150"/>
+        <p14:creationId xmlns:p14="http://schemas.microsoft.com/office/powerpoint/2010/main" val="1128612469"/>
       </p:ext>
     </p:extLst>
   </p:cSld>
@@ -5583,7 +5037,7 @@
           <p:cNvPr id="8" name="section-label">
             <a:extLst xmlns:a="http://schemas.openxmlformats.org/drawingml/2006/main">
               <a:ext uri="{FF2B5EF4-FFF2-40B4-BE49-F238E27FC236}">
-                <a16:creationId xmlns:a16="http://schemas.microsoft.com/office/drawing/2014/main" id="{1DC0F625-63C6-42DD-8016-8A25B99EEB58}"/>
+                <a16:creationId xmlns:a16="http://schemas.microsoft.com/office/drawing/2014/main" id="{DB79504E-66E7-4194-A6FD-61B0C3BC9871}"/>
               </a:ext>
             </a:extLst>
           </p:cNvPr>
@@ -5644,7 +5098,7 @@
           <p:cNvPr id="2" name="headline">
             <a:extLst xmlns:a="http://schemas.openxmlformats.org/drawingml/2006/main">
               <a:ext uri="{FF2B5EF4-FFF2-40B4-BE49-F238E27FC236}">
-                <a16:creationId xmlns:a16="http://schemas.microsoft.com/office/drawing/2014/main" id="{6055136C-1EF9-448C-9F44-23DBEE877FB1}"/>
+                <a16:creationId xmlns:a16="http://schemas.microsoft.com/office/drawing/2014/main" id="{5A89D25F-3175-4C1B-B296-564C5A6D2DDC}"/>
               </a:ext>
             </a:extLst>
           </p:cNvPr>
@@ -5705,7 +5159,7 @@
           <p:cNvPr id="3" name="host-tool">
             <a:extLst xmlns:a="http://schemas.openxmlformats.org/drawingml/2006/main">
               <a:ext uri="{FF2B5EF4-FFF2-40B4-BE49-F238E27FC236}">
-                <a16:creationId xmlns:a16="http://schemas.microsoft.com/office/drawing/2014/main" id="{726AF689-2BE6-4FA5-91DF-7CE6741C1EC2}"/>
+                <a16:creationId xmlns:a16="http://schemas.microsoft.com/office/drawing/2014/main" id="{235C315E-E72E-4604-9961-518FB40FEC9C}"/>
               </a:ext>
             </a:extLst>
           </p:cNvPr>
@@ -5766,7 +5220,7 @@
           <p:cNvPr id="4" name="prompt-next">
             <a:extLst xmlns:a="http://schemas.openxmlformats.org/drawingml/2006/main">
               <a:ext uri="{FF2B5EF4-FFF2-40B4-BE49-F238E27FC236}">
-                <a16:creationId xmlns:a16="http://schemas.microsoft.com/office/drawing/2014/main" id="{EA5BD1F3-6B15-4F2A-965A-40CDF3A01729}"/>
+                <a16:creationId xmlns:a16="http://schemas.microsoft.com/office/drawing/2014/main" id="{AB7CEB45-C670-41B7-B6F5-CF7AF2D26F6F}"/>
               </a:ext>
             </a:extLst>
           </p:cNvPr>
@@ -5831,7 +5285,7 @@
           <p:nvPr/>
         </p:nvPicPr>
         <p:blipFill>
-          <a:blip xmlns:r="http://schemas.openxmlformats.org/officeDocument/2006/relationships" xmlns:a="http://schemas.openxmlformats.org/drawingml/2006/main" r:embed="Rf201f167dfdd42ba"/>
+          <a:blip xmlns:r="http://schemas.openxmlformats.org/officeDocument/2006/relationships" xmlns:a="http://schemas.openxmlformats.org/drawingml/2006/main" r:embed="R926c50de71e44f3c"/>
           <a:stretch xmlns:a="http://schemas.openxmlformats.org/drawingml/2006/main"/>
         </p:blipFill>
         <p:spPr>
@@ -5849,7 +5303,7 @@
           <p:cNvPr id="6" name="session-caption">
             <a:extLst xmlns:a="http://schemas.openxmlformats.org/drawingml/2006/main">
               <a:ext uri="{FF2B5EF4-FFF2-40B4-BE49-F238E27FC236}">
-                <a16:creationId xmlns:a16="http://schemas.microsoft.com/office/drawing/2014/main" id="{F1024482-B071-478E-ACF2-F7138A38DC34}"/>
+                <a16:creationId xmlns:a16="http://schemas.microsoft.com/office/drawing/2014/main" id="{C322689C-BBE8-4AB7-B1B6-FBCCC4B767A9}"/>
               </a:ext>
             </a:extLst>
           </p:cNvPr>
@@ -5910,7 +5364,7 @@
           <p:cNvPr id="7" name="slide-number">
             <a:extLst xmlns:a="http://schemas.openxmlformats.org/drawingml/2006/main">
               <a:ext uri="{FF2B5EF4-FFF2-40B4-BE49-F238E27FC236}">
-                <a16:creationId xmlns:a16="http://schemas.microsoft.com/office/drawing/2014/main" id="{6E0EC25F-57B3-475B-A1D8-D8BE4AF417E5}"/>
+                <a16:creationId xmlns:a16="http://schemas.microsoft.com/office/drawing/2014/main" id="{C2C13DBC-731F-43E6-90D7-01DA972A964A}"/>
               </a:ext>
             </a:extLst>
           </p:cNvPr>
@@ -5969,7 +5423,7 @@
     </p:spTree>
     <p:extLst>
       <p:ext uri="{BB962C8B-B14F-4D97-AF65-F5344CB8AC3E}">
-        <p14:creationId xmlns:p14="http://schemas.microsoft.com/office/powerpoint/2010/main" val="648885786"/>
+        <p14:creationId xmlns:p14="http://schemas.microsoft.com/office/powerpoint/2010/main" val="186259559"/>
       </p:ext>
     </p:extLst>
   </p:cSld>
@@ -6000,7 +5454,7 @@
           <p:cNvPr id="7" name="section-label">
             <a:extLst xmlns:a="http://schemas.openxmlformats.org/drawingml/2006/main">
               <a:ext uri="{FF2B5EF4-FFF2-40B4-BE49-F238E27FC236}">
-                <a16:creationId xmlns:a16="http://schemas.microsoft.com/office/drawing/2014/main" id="{13442D05-3E1C-4BCD-AB3B-7213B83698B7}"/>
+                <a16:creationId xmlns:a16="http://schemas.microsoft.com/office/drawing/2014/main" id="{0A77D252-DA76-4209-A84F-DC4FE5440539}"/>
               </a:ext>
             </a:extLst>
           </p:cNvPr>
@@ -6061,7 +5515,7 @@
           <p:cNvPr id="2" name="headline">
             <a:extLst xmlns:a="http://schemas.openxmlformats.org/drawingml/2006/main">
               <a:ext uri="{FF2B5EF4-FFF2-40B4-BE49-F238E27FC236}">
-                <a16:creationId xmlns:a16="http://schemas.microsoft.com/office/drawing/2014/main" id="{A18E9656-2235-4F30-BD3F-D636994F5B00}"/>
+                <a16:creationId xmlns:a16="http://schemas.microsoft.com/office/drawing/2014/main" id="{9AB4CE9D-DA52-40B7-BC42-C5EFBB75D095}"/>
               </a:ext>
             </a:extLst>
           </p:cNvPr>
@@ -6122,7 +5576,7 @@
           <p:cNvPr id="3" name="retrieval-purpose">
             <a:extLst xmlns:a="http://schemas.openxmlformats.org/drawingml/2006/main">
               <a:ext uri="{FF2B5EF4-FFF2-40B4-BE49-F238E27FC236}">
-                <a16:creationId xmlns:a16="http://schemas.microsoft.com/office/drawing/2014/main" id="{62BEA31B-B522-4480-A763-8B57ED71B036}"/>
+                <a16:creationId xmlns:a16="http://schemas.microsoft.com/office/drawing/2014/main" id="{56A4DC91-D740-451A-AD27-C543B3B77BA0}"/>
               </a:ext>
             </a:extLst>
           </p:cNvPr>
@@ -6187,7 +5641,7 @@
           <p:nvPr/>
         </p:nvPicPr>
         <p:blipFill>
-          <a:blip xmlns:r="http://schemas.openxmlformats.org/officeDocument/2006/relationships" xmlns:a="http://schemas.openxmlformats.org/drawingml/2006/main" r:embed="R133291c3bc1b47d3"/>
+          <a:blip xmlns:r="http://schemas.openxmlformats.org/officeDocument/2006/relationships" xmlns:a="http://schemas.openxmlformats.org/drawingml/2006/main" r:embed="R7c21862691d8461c"/>
           <a:stretch xmlns:a="http://schemas.openxmlformats.org/drawingml/2006/main"/>
         </p:blipFill>
         <p:spPr>
@@ -6205,7 +5659,7 @@
           <p:cNvPr id="5" name="internal-status">
             <a:extLst xmlns:a="http://schemas.openxmlformats.org/drawingml/2006/main">
               <a:ext uri="{FF2B5EF4-FFF2-40B4-BE49-F238E27FC236}">
-                <a16:creationId xmlns:a16="http://schemas.microsoft.com/office/drawing/2014/main" id="{D36B5A2B-DA21-48C1-8B6C-4ED82671C199}"/>
+                <a16:creationId xmlns:a16="http://schemas.microsoft.com/office/drawing/2014/main" id="{62D85CB6-5F1A-4FF6-B59B-5C1F0F11DC9F}"/>
               </a:ext>
             </a:extLst>
           </p:cNvPr>
@@ -6266,7 +5720,7 @@
           <p:cNvPr id="6" name="slide-number">
             <a:extLst xmlns:a="http://schemas.openxmlformats.org/drawingml/2006/main">
               <a:ext uri="{FF2B5EF4-FFF2-40B4-BE49-F238E27FC236}">
-                <a16:creationId xmlns:a16="http://schemas.microsoft.com/office/drawing/2014/main" id="{64831BCE-E025-42F7-B702-4DBE1022B686}"/>
+                <a16:creationId xmlns:a16="http://schemas.microsoft.com/office/drawing/2014/main" id="{BEE53CC9-DF89-498D-9D12-71ECC8BD7398}"/>
               </a:ext>
             </a:extLst>
           </p:cNvPr>
@@ -6325,7 +5779,7 @@
     </p:spTree>
     <p:extLst>
       <p:ext uri="{BB962C8B-B14F-4D97-AF65-F5344CB8AC3E}">
-        <p14:creationId xmlns:p14="http://schemas.microsoft.com/office/powerpoint/2010/main" val="563646195"/>
+        <p14:creationId xmlns:p14="http://schemas.microsoft.com/office/powerpoint/2010/main" val="1983435131"/>
       </p:ext>
     </p:extLst>
   </p:cSld>
@@ -6356,7 +5810,7 @@
           <p:cNvPr id="8" name="section-label">
             <a:extLst xmlns:a="http://schemas.openxmlformats.org/drawingml/2006/main">
               <a:ext uri="{FF2B5EF4-FFF2-40B4-BE49-F238E27FC236}">
-                <a16:creationId xmlns:a16="http://schemas.microsoft.com/office/drawing/2014/main" id="{0B68A74A-58FE-4235-BA5E-2159C27E6682}"/>
+                <a16:creationId xmlns:a16="http://schemas.microsoft.com/office/drawing/2014/main" id="{8A086AC4-A309-4A6B-8DAC-E60ACEC6BB39}"/>
               </a:ext>
             </a:extLst>
           </p:cNvPr>
@@ -6417,7 +5871,7 @@
           <p:cNvPr id="2" name="headline">
             <a:extLst xmlns:a="http://schemas.openxmlformats.org/drawingml/2006/main">
               <a:ext uri="{FF2B5EF4-FFF2-40B4-BE49-F238E27FC236}">
-                <a16:creationId xmlns:a16="http://schemas.microsoft.com/office/drawing/2014/main" id="{05676DBA-D008-41C6-87A6-BA11C8B4E557}"/>
+                <a16:creationId xmlns:a16="http://schemas.microsoft.com/office/drawing/2014/main" id="{9FEC9CFA-7BC7-4CAA-9B84-00F59B820905}"/>
               </a:ext>
             </a:extLst>
           </p:cNvPr>
@@ -6478,7 +5932,7 @@
           <p:cNvPr id="3" name="retrieval-detail">
             <a:extLst xmlns:a="http://schemas.openxmlformats.org/drawingml/2006/main">
               <a:ext uri="{FF2B5EF4-FFF2-40B4-BE49-F238E27FC236}">
-                <a16:creationId xmlns:a16="http://schemas.microsoft.com/office/drawing/2014/main" id="{159684C5-7A4A-4E69-89CA-EFF4AD1AED17}"/>
+                <a16:creationId xmlns:a16="http://schemas.microsoft.com/office/drawing/2014/main" id="{2603D3EB-20AB-43E2-AEB0-A09926CD4362}"/>
               </a:ext>
             </a:extLst>
           </p:cNvPr>
@@ -6539,7 +5993,7 @@
           <p:cNvPr id="4" name="retrieval-review">
             <a:extLst xmlns:a="http://schemas.openxmlformats.org/drawingml/2006/main">
               <a:ext uri="{FF2B5EF4-FFF2-40B4-BE49-F238E27FC236}">
-                <a16:creationId xmlns:a16="http://schemas.microsoft.com/office/drawing/2014/main" id="{F69F6E3F-A364-4814-89D4-14708A9E28FD}"/>
+                <a16:creationId xmlns:a16="http://schemas.microsoft.com/office/drawing/2014/main" id="{3F38CBFB-6C90-470A-81C3-B910C137DD9F}"/>
               </a:ext>
             </a:extLst>
           </p:cNvPr>
@@ -6604,7 +6058,7 @@
           <p:nvPr/>
         </p:nvPicPr>
         <p:blipFill>
-          <a:blip xmlns:r="http://schemas.openxmlformats.org/officeDocument/2006/relationships" xmlns:a="http://schemas.openxmlformats.org/drawingml/2006/main" r:embed="Rfacd1da59dda4d37"/>
+          <a:blip xmlns:r="http://schemas.openxmlformats.org/officeDocument/2006/relationships" xmlns:a="http://schemas.openxmlformats.org/drawingml/2006/main" r:embed="R56a9af0e53b24589"/>
           <a:stretch xmlns:a="http://schemas.openxmlformats.org/drawingml/2006/main"/>
         </p:blipFill>
         <p:spPr>
@@ -6622,7 +6076,7 @@
           <p:cNvPr id="6" name="code-caption">
             <a:extLst xmlns:a="http://schemas.openxmlformats.org/drawingml/2006/main">
               <a:ext uri="{FF2B5EF4-FFF2-40B4-BE49-F238E27FC236}">
-                <a16:creationId xmlns:a16="http://schemas.microsoft.com/office/drawing/2014/main" id="{EF68D7CC-B4C6-494E-A3F6-23F6C3F35DB3}"/>
+                <a16:creationId xmlns:a16="http://schemas.microsoft.com/office/drawing/2014/main" id="{03B5AB4E-19BF-4ECE-9FB1-A0A1465DBF09}"/>
               </a:ext>
             </a:extLst>
           </p:cNvPr>
@@ -6683,7 +6137,7 @@
           <p:cNvPr id="7" name="slide-number">
             <a:extLst xmlns:a="http://schemas.openxmlformats.org/drawingml/2006/main">
               <a:ext uri="{FF2B5EF4-FFF2-40B4-BE49-F238E27FC236}">
-                <a16:creationId xmlns:a16="http://schemas.microsoft.com/office/drawing/2014/main" id="{FE53CE22-7801-4A19-91D2-A1931BEA0DD6}"/>
+                <a16:creationId xmlns:a16="http://schemas.microsoft.com/office/drawing/2014/main" id="{A897BB4B-F6B0-4AAC-B206-37BAD3387EC7}"/>
               </a:ext>
             </a:extLst>
           </p:cNvPr>
@@ -6742,7 +6196,7 @@
     </p:spTree>
     <p:extLst>
       <p:ext uri="{BB962C8B-B14F-4D97-AF65-F5344CB8AC3E}">
-        <p14:creationId xmlns:p14="http://schemas.microsoft.com/office/powerpoint/2010/main" val="2134001647"/>
+        <p14:creationId xmlns:p14="http://schemas.microsoft.com/office/powerpoint/2010/main" val="32891641"/>
       </p:ext>
     </p:extLst>
   </p:cSld>
@@ -6773,7 +6227,7 @@
           <p:cNvPr id="7" name="section-label">
             <a:extLst xmlns:a="http://schemas.openxmlformats.org/drawingml/2006/main">
               <a:ext uri="{FF2B5EF4-FFF2-40B4-BE49-F238E27FC236}">
-                <a16:creationId xmlns:a16="http://schemas.microsoft.com/office/drawing/2014/main" id="{DC581D98-C15C-4927-855A-92169EA68D41}"/>
+                <a16:creationId xmlns:a16="http://schemas.microsoft.com/office/drawing/2014/main" id="{EA433768-3345-4540-9EFB-46C2BB8750D4}"/>
               </a:ext>
             </a:extLst>
           </p:cNvPr>
@@ -6834,7 +6288,7 @@
           <p:cNvPr id="2" name="headline">
             <a:extLst xmlns:a="http://schemas.openxmlformats.org/drawingml/2006/main">
               <a:ext uri="{FF2B5EF4-FFF2-40B4-BE49-F238E27FC236}">
-                <a16:creationId xmlns:a16="http://schemas.microsoft.com/office/drawing/2014/main" id="{9CB016B8-62A3-4971-9F80-9D12F69BF21A}"/>
+                <a16:creationId xmlns:a16="http://schemas.microsoft.com/office/drawing/2014/main" id="{D22A93D4-8567-4DA6-B83A-D404C3D8A931}"/>
               </a:ext>
             </a:extLst>
           </p:cNvPr>
@@ -6895,7 +6349,7 @@
           <p:cNvPr id="3" name="course-name">
             <a:extLst xmlns:a="http://schemas.openxmlformats.org/drawingml/2006/main">
               <a:ext uri="{FF2B5EF4-FFF2-40B4-BE49-F238E27FC236}">
-                <a16:creationId xmlns:a16="http://schemas.microsoft.com/office/drawing/2014/main" id="{C35F6A20-968D-45D9-A54A-5FC87A05A315}"/>
+                <a16:creationId xmlns:a16="http://schemas.microsoft.com/office/drawing/2014/main" id="{16185EDC-3D9B-4983-BC16-784291CFA656}"/>
               </a:ext>
             </a:extLst>
           </p:cNvPr>
@@ -6960,7 +6414,7 @@
           <p:nvPr/>
         </p:nvPicPr>
         <p:blipFill>
-          <a:blip xmlns:r="http://schemas.openxmlformats.org/officeDocument/2006/relationships" xmlns:a="http://schemas.openxmlformats.org/drawingml/2006/main" r:embed="Re39366e147374036"/>
+          <a:blip xmlns:r="http://schemas.openxmlformats.org/officeDocument/2006/relationships" xmlns:a="http://schemas.openxmlformats.org/drawingml/2006/main" r:embed="Rb5a520bb532844ce"/>
           <a:stretch xmlns:a="http://schemas.openxmlformats.org/drawingml/2006/main"/>
         </p:blipFill>
         <p:spPr>
@@ -6978,7 +6432,7 @@
           <p:cNvPr id="5" name="course-status">
             <a:extLst xmlns:a="http://schemas.openxmlformats.org/drawingml/2006/main">
               <a:ext uri="{FF2B5EF4-FFF2-40B4-BE49-F238E27FC236}">
-                <a16:creationId xmlns:a16="http://schemas.microsoft.com/office/drawing/2014/main" id="{743EC672-EA64-4D75-A782-47403518E2E4}"/>
+                <a16:creationId xmlns:a16="http://schemas.microsoft.com/office/drawing/2014/main" id="{BDF3279A-79D9-4A45-9ECD-072285E66EB2}"/>
               </a:ext>
             </a:extLst>
           </p:cNvPr>
@@ -7039,7 +6493,7 @@
           <p:cNvPr id="6" name="slide-number">
             <a:extLst xmlns:a="http://schemas.openxmlformats.org/drawingml/2006/main">
               <a:ext uri="{FF2B5EF4-FFF2-40B4-BE49-F238E27FC236}">
-                <a16:creationId xmlns:a16="http://schemas.microsoft.com/office/drawing/2014/main" id="{15D7F2C5-A1DA-4E17-A484-849780D45B8E}"/>
+                <a16:creationId xmlns:a16="http://schemas.microsoft.com/office/drawing/2014/main" id="{8BB336AB-0981-4597-9313-01C744262F95}"/>
               </a:ext>
             </a:extLst>
           </p:cNvPr>
@@ -7098,7 +6552,7 @@
     </p:spTree>
     <p:extLst>
       <p:ext uri="{BB962C8B-B14F-4D97-AF65-F5344CB8AC3E}">
-        <p14:creationId xmlns:p14="http://schemas.microsoft.com/office/powerpoint/2010/main" val="990775242"/>
+        <p14:creationId xmlns:p14="http://schemas.microsoft.com/office/powerpoint/2010/main" val="229857012"/>
       </p:ext>
     </p:extLst>
   </p:cSld>
@@ -7129,7 +6583,7 @@
           <p:cNvPr id="7" name="section-label">
             <a:extLst xmlns:a="http://schemas.openxmlformats.org/drawingml/2006/main">
               <a:ext uri="{FF2B5EF4-FFF2-40B4-BE49-F238E27FC236}">
-                <a16:creationId xmlns:a16="http://schemas.microsoft.com/office/drawing/2014/main" id="{270F07CF-1F4B-4FFE-BFD9-AD4115D30AF9}"/>
+                <a16:creationId xmlns:a16="http://schemas.microsoft.com/office/drawing/2014/main" id="{EEE30E1A-CA19-4953-A5F0-617AC8EA657E}"/>
               </a:ext>
             </a:extLst>
           </p:cNvPr>
@@ -7190,7 +6644,7 @@
           <p:cNvPr id="2" name="headline">
             <a:extLst xmlns:a="http://schemas.openxmlformats.org/drawingml/2006/main">
               <a:ext uri="{FF2B5EF4-FFF2-40B4-BE49-F238E27FC236}">
-                <a16:creationId xmlns:a16="http://schemas.microsoft.com/office/drawing/2014/main" id="{A751D3C1-20CA-48DA-B67D-C96FC16A5EEC}"/>
+                <a16:creationId xmlns:a16="http://schemas.microsoft.com/office/drawing/2014/main" id="{EF4346CA-17D9-46BD-9F75-669F9497AEC4}"/>
               </a:ext>
             </a:extLst>
           </p:cNvPr>
@@ -7251,7 +6705,7 @@
           <p:cNvPr id="3" name="course-example-context">
             <a:extLst xmlns:a="http://schemas.openxmlformats.org/drawingml/2006/main">
               <a:ext uri="{FF2B5EF4-FFF2-40B4-BE49-F238E27FC236}">
-                <a16:creationId xmlns:a16="http://schemas.microsoft.com/office/drawing/2014/main" id="{7ADF06A9-0411-476B-B46B-B226C6A425B4}"/>
+                <a16:creationId xmlns:a16="http://schemas.microsoft.com/office/drawing/2014/main" id="{DA30E94D-457C-4EC2-A7D2-960103C20700}"/>
               </a:ext>
             </a:extLst>
           </p:cNvPr>
@@ -7316,7 +6770,7 @@
           <p:nvPr/>
         </p:nvPicPr>
         <p:blipFill>
-          <a:blip xmlns:r="http://schemas.openxmlformats.org/officeDocument/2006/relationships" xmlns:a="http://schemas.openxmlformats.org/drawingml/2006/main" r:embed="R3bdeb88478ca43c9"/>
+          <a:blip xmlns:r="http://schemas.openxmlformats.org/officeDocument/2006/relationships" xmlns:a="http://schemas.openxmlformats.org/drawingml/2006/main" r:embed="R4b781a93f96e45c9"/>
           <a:stretch xmlns:a="http://schemas.openxmlformats.org/drawingml/2006/main"/>
         </p:blipFill>
         <p:spPr>
@@ -7334,7 +6788,7 @@
           <p:cNvPr id="5" name="transfer-assessment">
             <a:extLst xmlns:a="http://schemas.openxmlformats.org/drawingml/2006/main">
               <a:ext uri="{FF2B5EF4-FFF2-40B4-BE49-F238E27FC236}">
-                <a16:creationId xmlns:a16="http://schemas.microsoft.com/office/drawing/2014/main" id="{B354EA37-BDE9-4C38-9919-D01C37F60017}"/>
+                <a16:creationId xmlns:a16="http://schemas.microsoft.com/office/drawing/2014/main" id="{0B05CC37-E1BC-438D-9DED-A072A860C219}"/>
               </a:ext>
             </a:extLst>
           </p:cNvPr>
@@ -7395,7 +6849,7 @@
           <p:cNvPr id="6" name="slide-number">
             <a:extLst xmlns:a="http://schemas.openxmlformats.org/drawingml/2006/main">
               <a:ext uri="{FF2B5EF4-FFF2-40B4-BE49-F238E27FC236}">
-                <a16:creationId xmlns:a16="http://schemas.microsoft.com/office/drawing/2014/main" id="{861C0293-FBD0-4F1B-A4E1-EBE66437D30B}"/>
+                <a16:creationId xmlns:a16="http://schemas.microsoft.com/office/drawing/2014/main" id="{E4B9871C-14D0-4E00-883C-41AC892886E7}"/>
               </a:ext>
             </a:extLst>
           </p:cNvPr>
@@ -7454,7 +6908,7 @@
     </p:spTree>
     <p:extLst>
       <p:ext uri="{BB962C8B-B14F-4D97-AF65-F5344CB8AC3E}">
-        <p14:creationId xmlns:p14="http://schemas.microsoft.com/office/powerpoint/2010/main" val="1597166901"/>
+        <p14:creationId xmlns:p14="http://schemas.microsoft.com/office/powerpoint/2010/main" val="636819539"/>
       </p:ext>
     </p:extLst>
   </p:cSld>
@@ -7485,7 +6939,7 @@
           <p:cNvPr id="9" name="section-label">
             <a:extLst xmlns:a="http://schemas.openxmlformats.org/drawingml/2006/main">
               <a:ext uri="{FF2B5EF4-FFF2-40B4-BE49-F238E27FC236}">
-                <a16:creationId xmlns:a16="http://schemas.microsoft.com/office/drawing/2014/main" id="{CBA50FA7-3EB2-48E3-9223-4123D6A341E9}"/>
+                <a16:creationId xmlns:a16="http://schemas.microsoft.com/office/drawing/2014/main" id="{EE8F88E6-05D6-40BF-BB7E-2455D6CA50AC}"/>
               </a:ext>
             </a:extLst>
           </p:cNvPr>
@@ -7546,7 +7000,7 @@
           <p:cNvPr id="2" name="headline">
             <a:extLst xmlns:a="http://schemas.openxmlformats.org/drawingml/2006/main">
               <a:ext uri="{FF2B5EF4-FFF2-40B4-BE49-F238E27FC236}">
-                <a16:creationId xmlns:a16="http://schemas.microsoft.com/office/drawing/2014/main" id="{978EFA9E-AEFD-4D07-80A4-EF7A1A3A1325}"/>
+                <a16:creationId xmlns:a16="http://schemas.microsoft.com/office/drawing/2014/main" id="{C41DA3D3-3C68-45BC-8D09-41878C86C195}"/>
               </a:ext>
             </a:extLst>
           </p:cNvPr>
@@ -7638,7 +7092,7 @@
           <p:nvPr/>
         </p:nvPicPr>
         <p:blipFill>
-          <a:blip xmlns:r="http://schemas.openxmlformats.org/officeDocument/2006/relationships" xmlns:a="http://schemas.openxmlformats.org/drawingml/2006/main" r:embed="Rd30d8bbd18584d2d"/>
+          <a:blip xmlns:r="http://schemas.openxmlformats.org/officeDocument/2006/relationships" xmlns:a="http://schemas.openxmlformats.org/drawingml/2006/main" r:embed="R86a7ad7a34f2429e"/>
           <a:stretch xmlns:a="http://schemas.openxmlformats.org/drawingml/2006/main"/>
         </p:blipFill>
         <p:spPr>
@@ -7656,7 +7110,7 @@
           <p:cNvPr id="4" name="studio-purpose">
             <a:extLst xmlns:a="http://schemas.openxmlformats.org/drawingml/2006/main">
               <a:ext uri="{FF2B5EF4-FFF2-40B4-BE49-F238E27FC236}">
-                <a16:creationId xmlns:a16="http://schemas.microsoft.com/office/drawing/2014/main" id="{85B4ACB3-6D19-40B5-BD50-8BA6B94C43E9}"/>
+                <a16:creationId xmlns:a16="http://schemas.microsoft.com/office/drawing/2014/main" id="{B2EB43C2-C6FC-4FC3-8C5B-A5B83088820D}"/>
               </a:ext>
             </a:extLst>
           </p:cNvPr>
@@ -7717,7 +7171,7 @@
           <p:cNvPr id="5" name="studio-media">
             <a:extLst xmlns:a="http://schemas.openxmlformats.org/drawingml/2006/main">
               <a:ext uri="{FF2B5EF4-FFF2-40B4-BE49-F238E27FC236}">
-                <a16:creationId xmlns:a16="http://schemas.microsoft.com/office/drawing/2014/main" id="{1031789E-BBC0-473A-9AD5-0885480422EC}"/>
+                <a16:creationId xmlns:a16="http://schemas.microsoft.com/office/drawing/2014/main" id="{BCB5379D-7EC5-44F5-973C-6A5162EDBCC7}"/>
               </a:ext>
             </a:extLst>
           </p:cNvPr>
@@ -7778,7 +7232,7 @@
           <p:cNvPr id="6" name="studio-case-background">
             <a:extLst xmlns:a="http://schemas.openxmlformats.org/drawingml/2006/main">
               <a:ext uri="{FF2B5EF4-FFF2-40B4-BE49-F238E27FC236}">
-                <a16:creationId xmlns:a16="http://schemas.microsoft.com/office/drawing/2014/main" id="{10F089BF-04CA-495A-A247-9D7E7A686CE4}"/>
+                <a16:creationId xmlns:a16="http://schemas.microsoft.com/office/drawing/2014/main" id="{8F425C7C-8B59-4477-972D-E36091C0079B}"/>
               </a:ext>
             </a:extLst>
           </p:cNvPr>
@@ -7808,7 +7262,7 @@
           <p:cNvPr id="7" name="studio-case-link">
             <a:extLst xmlns:a="http://schemas.openxmlformats.org/drawingml/2006/main">
               <a:ext uri="{FF2B5EF4-FFF2-40B4-BE49-F238E27FC236}">
-                <a16:creationId xmlns:a16="http://schemas.microsoft.com/office/drawing/2014/main" id="{54533E01-93B7-4406-AD8A-9B3482995BE5}"/>
+                <a16:creationId xmlns:a16="http://schemas.microsoft.com/office/drawing/2014/main" id="{DFA36588-04E9-4604-9CBB-F4EB28159653}"/>
               </a:ext>
             </a:extLst>
           </p:cNvPr>
@@ -7858,7 +7312,7 @@
                 <a:latin typeface="Helvetica Neue"/>
                 <a:ea typeface="Helvetica Neue"/>
                 <a:cs typeface="Helvetica Neue"/>
-                <a:hlinkClick xmlns:r="http://schemas.openxmlformats.org/officeDocument/2006/relationships" r:id="Rdbd15285ac334bf4"/>
+                <a:hlinkClick xmlns:r="http://schemas.openxmlformats.org/officeDocument/2006/relationships" r:id="Rd079516302ed42a2"/>
               </a:rPr>
               <a:t>View the case →</a:t>
             </a:r>
@@ -7870,7 +7324,7 @@
           <p:cNvPr id="8" name="slide-number">
             <a:extLst xmlns:a="http://schemas.openxmlformats.org/drawingml/2006/main">
               <a:ext uri="{FF2B5EF4-FFF2-40B4-BE49-F238E27FC236}">
-                <a16:creationId xmlns:a16="http://schemas.microsoft.com/office/drawing/2014/main" id="{DE9C0A97-ECF0-4987-A1E2-BBC8A43686B3}"/>
+                <a16:creationId xmlns:a16="http://schemas.microsoft.com/office/drawing/2014/main" id="{F786B9E8-FC85-43D2-A51F-3B1F8AE2BE74}"/>
               </a:ext>
             </a:extLst>
           </p:cNvPr>
@@ -7929,7 +7383,7 @@
     </p:spTree>
     <p:extLst>
       <p:ext uri="{BB962C8B-B14F-4D97-AF65-F5344CB8AC3E}">
-        <p14:creationId xmlns:p14="http://schemas.microsoft.com/office/powerpoint/2010/main" val="536343031"/>
+        <p14:creationId xmlns:p14="http://schemas.microsoft.com/office/powerpoint/2010/main" val="643477019"/>
       </p:ext>
     </p:extLst>
   </p:cSld>

</xml_diff>